<commit_message>
style(ppt): restyle overview deck to professional Orion palette
Apply the org reference look to Deck 00 and the shared generators:
- azure-blue section headers, magenta sub-heads, white body (retire rainbow accents)
- Arial throughout; slide titles keep the template gradient
- remove box borders and vertical dividers; borderless dark panels
- precedence chain uses azure numbered circles instead of colour bars

Shared helpers (orion.py, common.py) updated so decks 01-09 adopt the same
style when regenerated after review.

Co-Authored-By: Claude Opus 4.8 <noreply@anthropic.com>
Claude-Session: https://claude.ai/code/session_01NZAFLWCrwekDfmM1HS83Mp
</commit_message>
<xml_diff>
--- a/docs/PPT/00-overview.pptx
+++ b/docs/PPT/00-overview.pptx
@@ -7798,7 +7798,7 @@
             <a:r>
               <a:rPr>
                 <a:solidFill>
-                  <a:srgbClr val="D5D5D5"/>
+                  <a:srgbClr val="CFD3DA"/>
                 </a:solidFill>
               </a:rPr>
               <a:t>Technical Architecture  ·  Architecture Review Board  ·  September 2026</a:t>
@@ -7871,9 +7871,9 @@
             <a:r>
               <a:rPr sz="1500" b="1" i="0">
                 <a:solidFill>
-                  <a:srgbClr val="2ACCFF"/>
-                </a:solidFill>
-                <a:latin typeface="Calibri"/>
+                  <a:srgbClr val="2E9BF0"/>
+                </a:solidFill>
+                <a:latin typeface="Arial"/>
               </a:rPr>
               <a:t>Every significant decision is recorded and governed</a:t>
             </a:r>
@@ -7914,7 +7914,7 @@
                           <a:solidFill>
                             <a:srgbClr val="FFFFFF"/>
                           </a:solidFill>
-                          <a:latin typeface="Calibri"/>
+                          <a:latin typeface="Arial"/>
                         </a:rPr>
                         <a:t>Domain</a:t>
                       </a:r>
@@ -7922,7 +7922,7 @@
                   </a:txBody>
                   <a:tcPr marL="63500" marR="63500" marT="25400" marB="25400" anchor="ctr">
                     <a:solidFill>
-                      <a:srgbClr val="7F19BE"/>
+                      <a:srgbClr val="153A5C"/>
                     </a:solidFill>
                   </a:tcPr>
                 </a:tc>
@@ -7936,7 +7936,7 @@
                           <a:solidFill>
                             <a:srgbClr val="FFFFFF"/>
                           </a:solidFill>
-                          <a:latin typeface="Calibri"/>
+                          <a:latin typeface="Arial"/>
                         </a:rPr>
                         <a:t>ADRs</a:t>
                       </a:r>
@@ -7944,7 +7944,7 @@
                   </a:txBody>
                   <a:tcPr marL="63500" marR="63500" marT="25400" marB="25400" anchor="ctr">
                     <a:solidFill>
-                      <a:srgbClr val="7F19BE"/>
+                      <a:srgbClr val="153A5C"/>
                     </a:solidFill>
                   </a:tcPr>
                 </a:tc>
@@ -7958,7 +7958,7 @@
                           <a:solidFill>
                             <a:srgbClr val="FFFFFF"/>
                           </a:solidFill>
-                          <a:latin typeface="Calibri"/>
+                          <a:latin typeface="Arial"/>
                         </a:rPr>
                         <a:t>Focus</a:t>
                       </a:r>
@@ -7966,7 +7966,7 @@
                   </a:txBody>
                   <a:tcPr marL="63500" marR="63500" marT="25400" marB="25400" anchor="ctr">
                     <a:solidFill>
-                      <a:srgbClr val="7F19BE"/>
+                      <a:srgbClr val="153A5C"/>
                     </a:solidFill>
                   </a:tcPr>
                 </a:tc>
@@ -7982,7 +7982,7 @@
                           <a:solidFill>
                             <a:srgbClr val="FFFFFF"/>
                           </a:solidFill>
-                          <a:latin typeface="Calibri"/>
+                          <a:latin typeface="Arial"/>
                         </a:rPr>
                         <a:t>D0 Decision Programme</a:t>
                       </a:r>
@@ -7990,7 +7990,7 @@
                   </a:txBody>
                   <a:tcPr marL="63500" marR="63500" marT="25400" marB="25400" anchor="ctr">
                     <a:solidFill>
-                      <a:srgbClr val="14161C"/>
+                      <a:srgbClr val="121419"/>
                     </a:solidFill>
                   </a:tcPr>
                 </a:tc>
@@ -8002,9 +8002,9 @@
                       <a:r>
                         <a:rPr sz="1200" b="0">
                           <a:solidFill>
-                            <a:srgbClr val="D5D5D5"/>
+                            <a:srgbClr val="CFD3DA"/>
                           </a:solidFill>
-                          <a:latin typeface="Calibri"/>
+                          <a:latin typeface="Arial"/>
                         </a:rPr>
                         <a:t>4</a:t>
                       </a:r>
@@ -8012,7 +8012,7 @@
                   </a:txBody>
                   <a:tcPr marL="63500" marR="63500" marT="25400" marB="25400" anchor="ctr">
                     <a:solidFill>
-                      <a:srgbClr val="14161C"/>
+                      <a:srgbClr val="121419"/>
                     </a:solidFill>
                   </a:tcPr>
                 </a:tc>
@@ -8024,9 +8024,9 @@
                       <a:r>
                         <a:rPr sz="1200" b="0">
                           <a:solidFill>
-                            <a:srgbClr val="D5D5D5"/>
+                            <a:srgbClr val="CFD3DA"/>
                           </a:solidFill>
-                          <a:latin typeface="Calibri"/>
+                          <a:latin typeface="Arial"/>
                         </a:rPr>
                         <a:t>ADR governance, review board, open-decision register</a:t>
                       </a:r>
@@ -8034,7 +8034,7 @@
                   </a:txBody>
                   <a:tcPr marL="63500" marR="63500" marT="25400" marB="25400" anchor="ctr">
                     <a:solidFill>
-                      <a:srgbClr val="14161C"/>
+                      <a:srgbClr val="121419"/>
                     </a:solidFill>
                   </a:tcPr>
                 </a:tc>
@@ -8050,7 +8050,7 @@
                           <a:solidFill>
                             <a:srgbClr val="FFFFFF"/>
                           </a:solidFill>
-                          <a:latin typeface="Calibri"/>
+                          <a:latin typeface="Arial"/>
                         </a:rPr>
                         <a:t>D1 Business</a:t>
                       </a:r>
@@ -8058,7 +8058,7 @@
                   </a:txBody>
                   <a:tcPr marL="63500" marR="63500" marT="25400" marB="25400" anchor="ctr">
                     <a:solidFill>
-                      <a:srgbClr val="1E222B"/>
+                      <a:srgbClr val="1B1F27"/>
                     </a:solidFill>
                   </a:tcPr>
                 </a:tc>
@@ -8070,9 +8070,9 @@
                       <a:r>
                         <a:rPr sz="1200" b="0">
                           <a:solidFill>
-                            <a:srgbClr val="D5D5D5"/>
+                            <a:srgbClr val="CFD3DA"/>
                           </a:solidFill>
-                          <a:latin typeface="Calibri"/>
+                          <a:latin typeface="Arial"/>
                         </a:rPr>
                         <a:t>12</a:t>
                       </a:r>
@@ -8080,7 +8080,7 @@
                   </a:txBody>
                   <a:tcPr marL="63500" marR="63500" marT="25400" marB="25400" anchor="ctr">
                     <a:solidFill>
-                      <a:srgbClr val="1E222B"/>
+                      <a:srgbClr val="1B1F27"/>
                     </a:solidFill>
                   </a:tcPr>
                 </a:tc>
@@ -8092,9 +8092,9 @@
                       <a:r>
                         <a:rPr sz="1200" b="0">
                           <a:solidFill>
-                            <a:srgbClr val="D5D5D5"/>
+                            <a:srgbClr val="CFD3DA"/>
                           </a:solidFill>
-                          <a:latin typeface="Calibri"/>
+                          <a:latin typeface="Arial"/>
                         </a:rPr>
                         <a:t>scope, Golden Rule, persona, workflows, traceability</a:t>
                       </a:r>
@@ -8102,7 +8102,7 @@
                   </a:txBody>
                   <a:tcPr marL="63500" marR="63500" marT="25400" marB="25400" anchor="ctr">
                     <a:solidFill>
-                      <a:srgbClr val="1E222B"/>
+                      <a:srgbClr val="1B1F27"/>
                     </a:solidFill>
                   </a:tcPr>
                 </a:tc>
@@ -8118,7 +8118,7 @@
                           <a:solidFill>
                             <a:srgbClr val="FFFFFF"/>
                           </a:solidFill>
-                          <a:latin typeface="Calibri"/>
+                          <a:latin typeface="Arial"/>
                         </a:rPr>
                         <a:t>D2 Application</a:t>
                       </a:r>
@@ -8126,7 +8126,7 @@
                   </a:txBody>
                   <a:tcPr marL="63500" marR="63500" marT="25400" marB="25400" anchor="ctr">
                     <a:solidFill>
-                      <a:srgbClr val="14161C"/>
+                      <a:srgbClr val="121419"/>
                     </a:solidFill>
                   </a:tcPr>
                 </a:tc>
@@ -8138,9 +8138,9 @@
                       <a:r>
                         <a:rPr sz="1200" b="0">
                           <a:solidFill>
-                            <a:srgbClr val="D5D5D5"/>
+                            <a:srgbClr val="CFD3DA"/>
                           </a:solidFill>
-                          <a:latin typeface="Calibri"/>
+                          <a:latin typeface="Arial"/>
                         </a:rPr>
                         <a:t>21</a:t>
                       </a:r>
@@ -8148,7 +8148,7 @@
                   </a:txBody>
                   <a:tcPr marL="63500" marR="63500" marT="25400" marB="25400" anchor="ctr">
                     <a:solidFill>
-                      <a:srgbClr val="14161C"/>
+                      <a:srgbClr val="121419"/>
                     </a:solidFill>
                   </a:tcPr>
                 </a:tc>
@@ -8160,9 +8160,9 @@
                       <a:r>
                         <a:rPr sz="1200" b="0">
                           <a:solidFill>
-                            <a:srgbClr val="D5D5D5"/>
+                            <a:srgbClr val="CFD3DA"/>
                           </a:solidFill>
-                          <a:latin typeface="Calibri"/>
+                          <a:latin typeface="Arial"/>
                         </a:rPr>
                         <a:t>layering, orchestration, integration, eventing</a:t>
                       </a:r>
@@ -8170,7 +8170,7 @@
                   </a:txBody>
                   <a:tcPr marL="63500" marR="63500" marT="25400" marB="25400" anchor="ctr">
                     <a:solidFill>
-                      <a:srgbClr val="14161C"/>
+                      <a:srgbClr val="121419"/>
                     </a:solidFill>
                   </a:tcPr>
                 </a:tc>
@@ -8186,7 +8186,7 @@
                           <a:solidFill>
                             <a:srgbClr val="FFFFFF"/>
                           </a:solidFill>
-                          <a:latin typeface="Calibri"/>
+                          <a:latin typeface="Arial"/>
                         </a:rPr>
                         <a:t>D3 AI</a:t>
                       </a:r>
@@ -8194,7 +8194,7 @@
                   </a:txBody>
                   <a:tcPr marL="63500" marR="63500" marT="25400" marB="25400" anchor="ctr">
                     <a:solidFill>
-                      <a:srgbClr val="1E222B"/>
+                      <a:srgbClr val="1B1F27"/>
                     </a:solidFill>
                   </a:tcPr>
                 </a:tc>
@@ -8206,9 +8206,9 @@
                       <a:r>
                         <a:rPr sz="1200" b="0">
                           <a:solidFill>
-                            <a:srgbClr val="D5D5D5"/>
+                            <a:srgbClr val="CFD3DA"/>
                           </a:solidFill>
-                          <a:latin typeface="Calibri"/>
+                          <a:latin typeface="Arial"/>
                         </a:rPr>
                         <a:t>28</a:t>
                       </a:r>
@@ -8216,7 +8216,7 @@
                   </a:txBody>
                   <a:tcPr marL="63500" marR="63500" marT="25400" marB="25400" anchor="ctr">
                     <a:solidFill>
-                      <a:srgbClr val="1E222B"/>
+                      <a:srgbClr val="1B1F27"/>
                     </a:solidFill>
                   </a:tcPr>
                 </a:tc>
@@ -8228,9 +8228,9 @@
                       <a:r>
                         <a:rPr sz="1200" b="0">
                           <a:solidFill>
-                            <a:srgbClr val="D5D5D5"/>
+                            <a:srgbClr val="CFD3DA"/>
                           </a:solidFill>
-                          <a:latin typeface="Calibri"/>
+                          <a:latin typeface="Arial"/>
                         </a:rPr>
                         <a:t>agents, prompts, SLM, RAG, embeddings, refinement</a:t>
                       </a:r>
@@ -8238,7 +8238,7 @@
                   </a:txBody>
                   <a:tcPr marL="63500" marR="63500" marT="25400" marB="25400" anchor="ctr">
                     <a:solidFill>
-                      <a:srgbClr val="1E222B"/>
+                      <a:srgbClr val="1B1F27"/>
                     </a:solidFill>
                   </a:tcPr>
                 </a:tc>
@@ -8254,7 +8254,7 @@
                           <a:solidFill>
                             <a:srgbClr val="FFFFFF"/>
                           </a:solidFill>
-                          <a:latin typeface="Calibri"/>
+                          <a:latin typeface="Arial"/>
                         </a:rPr>
                         <a:t>D4 Information</a:t>
                       </a:r>
@@ -8262,7 +8262,7 @@
                   </a:txBody>
                   <a:tcPr marL="63500" marR="63500" marT="25400" marB="25400" anchor="ctr">
                     <a:solidFill>
-                      <a:srgbClr val="14161C"/>
+                      <a:srgbClr val="121419"/>
                     </a:solidFill>
                   </a:tcPr>
                 </a:tc>
@@ -8274,9 +8274,9 @@
                       <a:r>
                         <a:rPr sz="1200" b="0">
                           <a:solidFill>
-                            <a:srgbClr val="D5D5D5"/>
+                            <a:srgbClr val="CFD3DA"/>
                           </a:solidFill>
-                          <a:latin typeface="Calibri"/>
+                          <a:latin typeface="Arial"/>
                         </a:rPr>
                         <a:t>13</a:t>
                       </a:r>
@@ -8284,7 +8284,7 @@
                   </a:txBody>
                   <a:tcPr marL="63500" marR="63500" marT="25400" marB="25400" anchor="ctr">
                     <a:solidFill>
-                      <a:srgbClr val="14161C"/>
+                      <a:srgbClr val="121419"/>
                     </a:solidFill>
                   </a:tcPr>
                 </a:tc>
@@ -8296,9 +8296,9 @@
                       <a:r>
                         <a:rPr sz="1200" b="0">
                           <a:solidFill>
-                            <a:srgbClr val="D5D5D5"/>
+                            <a:srgbClr val="CFD3DA"/>
                           </a:solidFill>
-                          <a:latin typeface="Calibri"/>
+                          <a:latin typeface="Arial"/>
                         </a:rPr>
                         <a:t>ERC, state, memory, cache, identifiers</a:t>
                       </a:r>
@@ -8306,7 +8306,7 @@
                   </a:txBody>
                   <a:tcPr marL="63500" marR="63500" marT="25400" marB="25400" anchor="ctr">
                     <a:solidFill>
-                      <a:srgbClr val="14161C"/>
+                      <a:srgbClr val="121419"/>
                     </a:solidFill>
                   </a:tcPr>
                 </a:tc>
@@ -8322,7 +8322,7 @@
                           <a:solidFill>
                             <a:srgbClr val="FFFFFF"/>
                           </a:solidFill>
-                          <a:latin typeface="Calibri"/>
+                          <a:latin typeface="Arial"/>
                         </a:rPr>
                         <a:t>D5 Technology</a:t>
                       </a:r>
@@ -8330,7 +8330,7 @@
                   </a:txBody>
                   <a:tcPr marL="63500" marR="63500" marT="25400" marB="25400" anchor="ctr">
                     <a:solidFill>
-                      <a:srgbClr val="1E222B"/>
+                      <a:srgbClr val="1B1F27"/>
                     </a:solidFill>
                   </a:tcPr>
                 </a:tc>
@@ -8342,9 +8342,9 @@
                       <a:r>
                         <a:rPr sz="1200" b="0">
                           <a:solidFill>
-                            <a:srgbClr val="D5D5D5"/>
+                            <a:srgbClr val="CFD3DA"/>
                           </a:solidFill>
-                          <a:latin typeface="Calibri"/>
+                          <a:latin typeface="Arial"/>
                         </a:rPr>
                         <a:t>20</a:t>
                       </a:r>
@@ -8352,7 +8352,7 @@
                   </a:txBody>
                   <a:tcPr marL="63500" marR="63500" marT="25400" marB="25400" anchor="ctr">
                     <a:solidFill>
-                      <a:srgbClr val="1E222B"/>
+                      <a:srgbClr val="1B1F27"/>
                     </a:solidFill>
                   </a:tcPr>
                 </a:tc>
@@ -8364,9 +8364,9 @@
                       <a:r>
                         <a:rPr sz="1200" b="0">
                           <a:solidFill>
-                            <a:srgbClr val="D5D5D5"/>
+                            <a:srgbClr val="CFD3DA"/>
                           </a:solidFill>
-                          <a:latin typeface="Calibri"/>
+                          <a:latin typeface="Arial"/>
                         </a:rPr>
                         <a:t>Azure/AKS, APIM, Key Vault, vLLM, delivery</a:t>
                       </a:r>
@@ -8374,7 +8374,7 @@
                   </a:txBody>
                   <a:tcPr marL="63500" marR="63500" marT="25400" marB="25400" anchor="ctr">
                     <a:solidFill>
-                      <a:srgbClr val="1E222B"/>
+                      <a:srgbClr val="1B1F27"/>
                     </a:solidFill>
                   </a:tcPr>
                 </a:tc>
@@ -8390,7 +8390,7 @@
                           <a:solidFill>
                             <a:srgbClr val="FFFFFF"/>
                           </a:solidFill>
-                          <a:latin typeface="Calibri"/>
+                          <a:latin typeface="Arial"/>
                         </a:rPr>
                         <a:t>D6 Security &amp; Governance</a:t>
                       </a:r>
@@ -8398,7 +8398,7 @@
                   </a:txBody>
                   <a:tcPr marL="63500" marR="63500" marT="25400" marB="25400" anchor="ctr">
                     <a:solidFill>
-                      <a:srgbClr val="14161C"/>
+                      <a:srgbClr val="121419"/>
                     </a:solidFill>
                   </a:tcPr>
                 </a:tc>
@@ -8410,9 +8410,9 @@
                       <a:r>
                         <a:rPr sz="1200" b="0">
                           <a:solidFill>
-                            <a:srgbClr val="D5D5D5"/>
+                            <a:srgbClr val="CFD3DA"/>
                           </a:solidFill>
-                          <a:latin typeface="Calibri"/>
+                          <a:latin typeface="Arial"/>
                         </a:rPr>
                         <a:t>19</a:t>
                       </a:r>
@@ -8420,7 +8420,7 @@
                   </a:txBody>
                   <a:tcPr marL="63500" marR="63500" marT="25400" marB="25400" anchor="ctr">
                     <a:solidFill>
-                      <a:srgbClr val="14161C"/>
+                      <a:srgbClr val="121419"/>
                     </a:solidFill>
                   </a:tcPr>
                 </a:tc>
@@ -8432,9 +8432,9 @@
                       <a:r>
                         <a:rPr sz="1200" b="0">
                           <a:solidFill>
-                            <a:srgbClr val="D5D5D5"/>
+                            <a:srgbClr val="CFD3DA"/>
                           </a:solidFill>
-                          <a:latin typeface="Calibri"/>
+                          <a:latin typeface="Arial"/>
                         </a:rPr>
                         <a:t>zero-trust, masking, guardrails, GDPR</a:t>
                       </a:r>
@@ -8442,7 +8442,7 @@
                   </a:txBody>
                   <a:tcPr marL="63500" marR="63500" marT="25400" marB="25400" anchor="ctr">
                     <a:solidFill>
-                      <a:srgbClr val="14161C"/>
+                      <a:srgbClr val="121419"/>
                     </a:solidFill>
                   </a:tcPr>
                 </a:tc>
@@ -8458,7 +8458,7 @@
                           <a:solidFill>
                             <a:srgbClr val="FFFFFF"/>
                           </a:solidFill>
-                          <a:latin typeface="Calibri"/>
+                          <a:latin typeface="Arial"/>
                         </a:rPr>
                         <a:t>D7 Operations</a:t>
                       </a:r>
@@ -8466,7 +8466,7 @@
                   </a:txBody>
                   <a:tcPr marL="63500" marR="63500" marT="25400" marB="25400" anchor="ctr">
                     <a:solidFill>
-                      <a:srgbClr val="1E222B"/>
+                      <a:srgbClr val="1B1F27"/>
                     </a:solidFill>
                   </a:tcPr>
                 </a:tc>
@@ -8478,9 +8478,9 @@
                       <a:r>
                         <a:rPr sz="1200" b="0">
                           <a:solidFill>
-                            <a:srgbClr val="D5D5D5"/>
+                            <a:srgbClr val="CFD3DA"/>
                           </a:solidFill>
-                          <a:latin typeface="Calibri"/>
+                          <a:latin typeface="Arial"/>
                         </a:rPr>
                         <a:t>18</a:t>
                       </a:r>
@@ -8488,7 +8488,7 @@
                   </a:txBody>
                   <a:tcPr marL="63500" marR="63500" marT="25400" marB="25400" anchor="ctr">
                     <a:solidFill>
-                      <a:srgbClr val="1E222B"/>
+                      <a:srgbClr val="1B1F27"/>
                     </a:solidFill>
                   </a:tcPr>
                 </a:tc>
@@ -8500,9 +8500,9 @@
                       <a:r>
                         <a:rPr sz="1200" b="0">
                           <a:solidFill>
-                            <a:srgbClr val="D5D5D5"/>
+                            <a:srgbClr val="CFD3DA"/>
                           </a:solidFill>
-                          <a:latin typeface="Calibri"/>
+                          <a:latin typeface="Arial"/>
                         </a:rPr>
                         <a:t>observability, CI/CD, testing, LLMOps, DR</a:t>
                       </a:r>
@@ -8510,7 +8510,7 @@
                   </a:txBody>
                   <a:tcPr marL="63500" marR="63500" marT="25400" marB="25400" anchor="ctr">
                     <a:solidFill>
-                      <a:srgbClr val="1E222B"/>
+                      <a:srgbClr val="1B1F27"/>
                     </a:solidFill>
                   </a:tcPr>
                 </a:tc>
@@ -8526,7 +8526,7 @@
                           <a:solidFill>
                             <a:srgbClr val="FFFFFF"/>
                           </a:solidFill>
-                          <a:latin typeface="Calibri"/>
+                          <a:latin typeface="Arial"/>
                         </a:rPr>
                         <a:t>D8 Business Value</a:t>
                       </a:r>
@@ -8534,7 +8534,7 @@
                   </a:txBody>
                   <a:tcPr marL="63500" marR="63500" marT="25400" marB="25400" anchor="ctr">
                     <a:solidFill>
-                      <a:srgbClr val="14161C"/>
+                      <a:srgbClr val="121419"/>
                     </a:solidFill>
                   </a:tcPr>
                 </a:tc>
@@ -8546,9 +8546,9 @@
                       <a:r>
                         <a:rPr sz="1200" b="0">
                           <a:solidFill>
-                            <a:srgbClr val="D5D5D5"/>
+                            <a:srgbClr val="CFD3DA"/>
                           </a:solidFill>
-                          <a:latin typeface="Calibri"/>
+                          <a:latin typeface="Arial"/>
                         </a:rPr>
                         <a:t>10</a:t>
                       </a:r>
@@ -8556,7 +8556,7 @@
                   </a:txBody>
                   <a:tcPr marL="63500" marR="63500" marT="25400" marB="25400" anchor="ctr">
                     <a:solidFill>
-                      <a:srgbClr val="14161C"/>
+                      <a:srgbClr val="121419"/>
                     </a:solidFill>
                   </a:tcPr>
                 </a:tc>
@@ -8568,9 +8568,9 @@
                       <a:r>
                         <a:rPr sz="1200" b="0">
                           <a:solidFill>
-                            <a:srgbClr val="D5D5D5"/>
+                            <a:srgbClr val="CFD3DA"/>
                           </a:solidFill>
-                          <a:latin typeface="Calibri"/>
+                          <a:latin typeface="Arial"/>
                         </a:rPr>
                         <a:t>value, metrics, traceability</a:t>
                       </a:r>
@@ -8578,7 +8578,7 @@
                   </a:txBody>
                   <a:tcPr marL="63500" marR="63500" marT="25400" marB="25400" anchor="ctr">
                     <a:solidFill>
-                      <a:srgbClr val="14161C"/>
+                      <a:srgbClr val="121419"/>
                     </a:solidFill>
                   </a:tcPr>
                 </a:tc>
@@ -8613,9 +8613,9 @@
             <a:r>
               <a:rPr sz="1200" b="1" i="0">
                 <a:solidFill>
-                  <a:srgbClr val="FED038"/>
-                </a:solidFill>
-                <a:latin typeface="Calibri"/>
+                  <a:srgbClr val="2E9BF0"/>
+                </a:solidFill>
+                <a:latin typeface="Arial"/>
               </a:rPr>
               <a:t>145 governed ADRs  ·  5 still Proposed and awaiting ARB sign-off (deck 09)</a:t>
             </a:r>
@@ -8687,9 +8687,9 @@
             <a:r>
               <a:rPr sz="1500" b="1" i="0">
                 <a:solidFill>
-                  <a:srgbClr val="2ACCFF"/>
-                </a:solidFill>
-                <a:latin typeface="Calibri"/>
+                  <a:srgbClr val="2E9BF0"/>
+                </a:solidFill>
+                <a:latin typeface="Arial"/>
               </a:rPr>
               <a:t>Indicative — Azure UK South, Sept 2026, verify with FinOps</a:t>
             </a:r>
@@ -8705,18 +8705,16 @@
         <p:spPr>
           <a:xfrm>
             <a:off x="822960" y="2011680"/>
-            <a:ext cx="2514600" cy="1737360"/>
+            <a:ext cx="2430018" cy="1737360"/>
           </a:xfrm>
           <a:prstGeom prst="roundRect">
             <a:avLst/>
           </a:prstGeom>
           <a:solidFill>
-            <a:srgbClr val="14161C"/>
+            <a:srgbClr val="1B1F27"/>
           </a:solidFill>
-          <a:ln w="15875">
-            <a:solidFill>
-              <a:srgbClr val="2ACCFF"/>
-            </a:solidFill>
+          <a:ln>
+            <a:noFill/>
           </a:ln>
           <a:effectLst/>
         </p:spPr>
@@ -8744,7 +8742,7 @@
                 <a:solidFill>
                   <a:srgbClr val="FFFFFF"/>
                 </a:solidFill>
-                <a:latin typeface="Calibri"/>
+                <a:latin typeface="Arial"/>
               </a:rPr>
               <a:t/>
             </a:r>
@@ -8759,8 +8757,8 @@
         </p:nvSpPr>
         <p:spPr>
           <a:xfrm>
-            <a:off x="1051560" y="2240280"/>
-            <a:ext cx="2103120" cy="548640"/>
+            <a:off x="1051560" y="2212848"/>
+            <a:ext cx="1972817" cy="822960"/>
           </a:xfrm>
           <a:prstGeom prst="rect">
             <a:avLst/>
@@ -8775,11 +8773,11 @@
           <a:p>
             <a:pPr algn="l"/>
             <a:r>
-              <a:rPr sz="2000" b="1" i="0">
-                <a:solidFill>
-                  <a:srgbClr val="2ACCFF"/>
-                </a:solidFill>
-                <a:latin typeface="Calibri"/>
+              <a:rPr sz="2200" b="1" i="0">
+                <a:solidFill>
+                  <a:srgbClr val="2E9BF0"/>
+                </a:solidFill>
+                <a:latin typeface="Arial"/>
               </a:rPr>
               <a:t>HF API</a:t>
             </a:r>
@@ -8794,8 +8792,8 @@
         </p:nvSpPr>
         <p:spPr>
           <a:xfrm>
-            <a:off x="1051560" y="2880360"/>
-            <a:ext cx="2103120" cy="640080"/>
+            <a:off x="1051560" y="2944368"/>
+            <a:ext cx="1972817" cy="731519"/>
           </a:xfrm>
           <a:prstGeom prst="rect">
             <a:avLst/>
@@ -8812,9 +8810,9 @@
             <a:r>
               <a:rPr sz="1200" b="0" i="0">
                 <a:solidFill>
-                  <a:srgbClr val="D5D5D5"/>
-                </a:solidFill>
-                <a:latin typeface="Calibri"/>
+                  <a:srgbClr val="CFD3DA"/>
+                </a:solidFill>
+                <a:latin typeface="Arial"/>
               </a:rPr>
               <a:t>hosted SLM phase</a:t>
             </a:r>
@@ -8829,19 +8827,17 @@
         </p:nvSpPr>
         <p:spPr>
           <a:xfrm>
-            <a:off x="3520440" y="2011680"/>
-            <a:ext cx="2514600" cy="1737360"/>
+            <a:off x="3527297" y="2011680"/>
+            <a:ext cx="2430018" cy="1737360"/>
           </a:xfrm>
           <a:prstGeom prst="roundRect">
             <a:avLst/>
           </a:prstGeom>
           <a:solidFill>
-            <a:srgbClr val="14161C"/>
+            <a:srgbClr val="1B1F27"/>
           </a:solidFill>
-          <a:ln w="15875">
-            <a:solidFill>
-              <a:srgbClr val="5300DB"/>
-            </a:solidFill>
+          <a:ln>
+            <a:noFill/>
           </a:ln>
           <a:effectLst/>
         </p:spPr>
@@ -8869,7 +8865,7 @@
                 <a:solidFill>
                   <a:srgbClr val="FFFFFF"/>
                 </a:solidFill>
-                <a:latin typeface="Calibri"/>
+                <a:latin typeface="Arial"/>
               </a:rPr>
               <a:t/>
             </a:r>
@@ -8884,8 +8880,8 @@
         </p:nvSpPr>
         <p:spPr>
           <a:xfrm>
-            <a:off x="3749039" y="2240280"/>
-            <a:ext cx="2103120" cy="548640"/>
+            <a:off x="3755898" y="2212848"/>
+            <a:ext cx="1972817" cy="822960"/>
           </a:xfrm>
           <a:prstGeom prst="rect">
             <a:avLst/>
@@ -8900,11 +8896,11 @@
           <a:p>
             <a:pPr algn="l"/>
             <a:r>
-              <a:rPr sz="2000" b="1" i="0">
-                <a:solidFill>
-                  <a:srgbClr val="5300DB"/>
-                </a:solidFill>
-                <a:latin typeface="Calibri"/>
+              <a:rPr sz="2200" b="1" i="0">
+                <a:solidFill>
+                  <a:srgbClr val="C24DFF"/>
+                </a:solidFill>
+                <a:latin typeface="Arial"/>
               </a:rPr>
               <a:t>vLLM / GPU</a:t>
             </a:r>
@@ -8919,8 +8915,8 @@
         </p:nvSpPr>
         <p:spPr>
           <a:xfrm>
-            <a:off x="3749039" y="2880360"/>
-            <a:ext cx="2103120" cy="640080"/>
+            <a:off x="3755898" y="2944368"/>
+            <a:ext cx="1972817" cy="731519"/>
           </a:xfrm>
           <a:prstGeom prst="rect">
             <a:avLst/>
@@ -8937,9 +8933,9 @@
             <a:r>
               <a:rPr sz="1200" b="0" i="0">
                 <a:solidFill>
-                  <a:srgbClr val="D5D5D5"/>
-                </a:solidFill>
-                <a:latin typeface="Calibri"/>
+                  <a:srgbClr val="CFD3DA"/>
+                </a:solidFill>
+                <a:latin typeface="Arial"/>
               </a:rPr>
               <a:t>self-hosted target</a:t>
             </a:r>
@@ -8954,19 +8950,17 @@
         </p:nvSpPr>
         <p:spPr>
           <a:xfrm>
-            <a:off x="6217920" y="2011680"/>
-            <a:ext cx="2514600" cy="1737360"/>
+            <a:off x="6231636" y="2011680"/>
+            <a:ext cx="2430018" cy="1737360"/>
           </a:xfrm>
           <a:prstGeom prst="roundRect">
             <a:avLst/>
           </a:prstGeom>
           <a:solidFill>
-            <a:srgbClr val="14161C"/>
+            <a:srgbClr val="1B1F27"/>
           </a:solidFill>
-          <a:ln w="15875">
-            <a:solidFill>
-              <a:srgbClr val="48E84A"/>
-            </a:solidFill>
+          <a:ln>
+            <a:noFill/>
           </a:ln>
           <a:effectLst/>
         </p:spPr>
@@ -8994,7 +8988,7 @@
                 <a:solidFill>
                   <a:srgbClr val="FFFFFF"/>
                 </a:solidFill>
-                <a:latin typeface="Calibri"/>
+                <a:latin typeface="Arial"/>
               </a:rPr>
               <a:t/>
             </a:r>
@@ -9009,8 +9003,8 @@
         </p:nvSpPr>
         <p:spPr>
           <a:xfrm>
-            <a:off x="6446520" y="2240280"/>
-            <a:ext cx="2103120" cy="548640"/>
+            <a:off x="6460236" y="2212848"/>
+            <a:ext cx="1972817" cy="822960"/>
           </a:xfrm>
           <a:prstGeom prst="rect">
             <a:avLst/>
@@ -9025,11 +9019,11 @@
           <a:p>
             <a:pPr algn="l"/>
             <a:r>
-              <a:rPr sz="2000" b="1" i="0">
-                <a:solidFill>
-                  <a:srgbClr val="48E84A"/>
-                </a:solidFill>
-                <a:latin typeface="Calibri"/>
+              <a:rPr sz="2200" b="1" i="0">
+                <a:solidFill>
+                  <a:srgbClr val="2E9BF0"/>
+                </a:solidFill>
+                <a:latin typeface="Arial"/>
               </a:rPr>
               <a:t>AI Search</a:t>
             </a:r>
@@ -9044,8 +9038,8 @@
         </p:nvSpPr>
         <p:spPr>
           <a:xfrm>
-            <a:off x="6446520" y="2880360"/>
-            <a:ext cx="2103120" cy="640080"/>
+            <a:off x="6460236" y="2944368"/>
+            <a:ext cx="1972817" cy="731519"/>
           </a:xfrm>
           <a:prstGeom prst="rect">
             <a:avLst/>
@@ -9062,9 +9056,9 @@
             <a:r>
               <a:rPr sz="1200" b="0" i="0">
                 <a:solidFill>
-                  <a:srgbClr val="D5D5D5"/>
-                </a:solidFill>
-                <a:latin typeface="Calibri"/>
+                  <a:srgbClr val="CFD3DA"/>
+                </a:solidFill>
+                <a:latin typeface="Arial"/>
               </a:rPr>
               <a:t>vector store</a:t>
             </a:r>
@@ -9079,19 +9073,17 @@
         </p:nvSpPr>
         <p:spPr>
           <a:xfrm>
-            <a:off x="8915400" y="2011680"/>
-            <a:ext cx="2514600" cy="1737360"/>
+            <a:off x="8935974" y="2011680"/>
+            <a:ext cx="2430018" cy="1737360"/>
           </a:xfrm>
           <a:prstGeom prst="roundRect">
             <a:avLst/>
           </a:prstGeom>
           <a:solidFill>
-            <a:srgbClr val="14161C"/>
+            <a:srgbClr val="1B1F27"/>
           </a:solidFill>
-          <a:ln w="15875">
-            <a:solidFill>
-              <a:srgbClr val="FE2579"/>
-            </a:solidFill>
+          <a:ln>
+            <a:noFill/>
           </a:ln>
           <a:effectLst/>
         </p:spPr>
@@ -9119,7 +9111,7 @@
                 <a:solidFill>
                   <a:srgbClr val="FFFFFF"/>
                 </a:solidFill>
-                <a:latin typeface="Calibri"/>
+                <a:latin typeface="Arial"/>
               </a:rPr>
               <a:t/>
             </a:r>
@@ -9134,8 +9126,8 @@
         </p:nvSpPr>
         <p:spPr>
           <a:xfrm>
-            <a:off x="9144000" y="2240280"/>
-            <a:ext cx="2103120" cy="548640"/>
+            <a:off x="9164574" y="2212848"/>
+            <a:ext cx="1972817" cy="822960"/>
           </a:xfrm>
           <a:prstGeom prst="rect">
             <a:avLst/>
@@ -9150,11 +9142,11 @@
           <a:p>
             <a:pPr algn="l"/>
             <a:r>
-              <a:rPr sz="2000" b="1" i="0">
-                <a:solidFill>
-                  <a:srgbClr val="FE2579"/>
-                </a:solidFill>
-                <a:latin typeface="Calibri"/>
+              <a:rPr sz="2200" b="1" i="0">
+                <a:solidFill>
+                  <a:srgbClr val="C24DFF"/>
+                </a:solidFill>
+                <a:latin typeface="Arial"/>
               </a:rPr>
               <a:t>Langfuse</a:t>
             </a:r>
@@ -9169,8 +9161,8 @@
         </p:nvSpPr>
         <p:spPr>
           <a:xfrm>
-            <a:off x="9144000" y="2880360"/>
-            <a:ext cx="2103120" cy="640080"/>
+            <a:off x="9164574" y="2944368"/>
+            <a:ext cx="1972817" cy="731519"/>
           </a:xfrm>
           <a:prstGeom prst="rect">
             <a:avLst/>
@@ -9187,9 +9179,9 @@
             <a:r>
               <a:rPr sz="1200" b="0" i="0">
                 <a:solidFill>
-                  <a:srgbClr val="D5D5D5"/>
-                </a:solidFill>
-                <a:latin typeface="Calibri"/>
+                  <a:srgbClr val="CFD3DA"/>
+                </a:solidFill>
+                <a:latin typeface="Arial"/>
               </a:rPr>
               <a:t>AI observability</a:t>
             </a:r>
@@ -9224,7 +9216,7 @@
                 <a:solidFill>
                   <a:srgbClr val="FFFFFF"/>
                 </a:solidFill>
-                <a:latin typeface="Calibri"/>
+                <a:latin typeface="Arial"/>
               </a:rPr>
               <a:t>Deck 08 breaks cost down per technology (drivers, formula, Low / Expected / High monthly).</a:t>
             </a:r>
@@ -9309,9 +9301,9 @@
             <a:r>
               <a:rPr sz="1800" b="0" i="0">
                 <a:solidFill>
-                  <a:srgbClr val="D5D5D5"/>
-                </a:solidFill>
-                <a:latin typeface="Calibri"/>
+                  <a:srgbClr val="CFD3DA"/>
+                </a:solidFill>
+                <a:latin typeface="Arial"/>
               </a:rPr>
               <a:t>Note the architecture · ratify the 5 open decisions (deck 09) · endorse the cost model (deck 08)</a:t>
             </a:r>
@@ -9387,18 +9379,18 @@
             <a:r>
               <a:rPr sz="1800" b="1">
                 <a:solidFill>
-                  <a:srgbClr val="2ACCFF"/>
-                </a:solidFill>
-                <a:latin typeface="Calibri"/>
-              </a:rPr>
-              <a:t>▸ </a:t>
+                  <a:srgbClr val="2E9BF0"/>
+                </a:solidFill>
+                <a:latin typeface="Arial"/>
+              </a:rPr>
+              <a:t>•  </a:t>
             </a:r>
             <a:r>
               <a:rPr sz="1800">
                 <a:solidFill>
                   <a:srgbClr val="FFFFFF"/>
                 </a:solidFill>
-                <a:latin typeface="Calibri"/>
+                <a:latin typeface="Arial"/>
               </a:rPr>
               <a:t>00  Overview (this deck) — whole-system technical picture</a:t>
             </a:r>
@@ -9412,18 +9404,18 @@
             <a:r>
               <a:rPr sz="1800" b="1">
                 <a:solidFill>
-                  <a:srgbClr val="2ACCFF"/>
-                </a:solidFill>
-                <a:latin typeface="Calibri"/>
-              </a:rPr>
-              <a:t>▸ </a:t>
+                  <a:srgbClr val="2E9BF0"/>
+                </a:solidFill>
+                <a:latin typeface="Arial"/>
+              </a:rPr>
+              <a:t>•  </a:t>
             </a:r>
             <a:r>
               <a:rPr sz="1800">
                 <a:solidFill>
                   <a:srgbClr val="FFFFFF"/>
                 </a:solidFill>
-                <a:latin typeface="Calibri"/>
+                <a:latin typeface="Arial"/>
               </a:rPr>
               <a:t>01  Business Architecture &amp; Value — D0 / D1 / D8</a:t>
             </a:r>
@@ -9437,18 +9429,18 @@
             <a:r>
               <a:rPr sz="1800" b="1">
                 <a:solidFill>
-                  <a:srgbClr val="2ACCFF"/>
-                </a:solidFill>
-                <a:latin typeface="Calibri"/>
-              </a:rPr>
-              <a:t>▸ </a:t>
+                  <a:srgbClr val="2E9BF0"/>
+                </a:solidFill>
+                <a:latin typeface="Arial"/>
+              </a:rPr>
+              <a:t>•  </a:t>
             </a:r>
             <a:r>
               <a:rPr sz="1800">
                 <a:solidFill>
                   <a:srgbClr val="FFFFFF"/>
                 </a:solidFill>
-                <a:latin typeface="Calibri"/>
+                <a:latin typeface="Arial"/>
               </a:rPr>
               <a:t>02  Application &amp; Orchestration — D2</a:t>
             </a:r>
@@ -9462,18 +9454,18 @@
             <a:r>
               <a:rPr sz="1800" b="1">
                 <a:solidFill>
-                  <a:srgbClr val="2ACCFF"/>
-                </a:solidFill>
-                <a:latin typeface="Calibri"/>
-              </a:rPr>
-              <a:t>▸ </a:t>
+                  <a:srgbClr val="2E9BF0"/>
+                </a:solidFill>
+                <a:latin typeface="Arial"/>
+              </a:rPr>
+              <a:t>•  </a:t>
             </a:r>
             <a:r>
               <a:rPr sz="1800">
                 <a:solidFill>
                   <a:srgbClr val="FFFFFF"/>
                 </a:solidFill>
-                <a:latin typeface="Calibri"/>
+                <a:latin typeface="Arial"/>
               </a:rPr>
               <a:t>03  AI Architecture — D3 (RAG, SLM, prompts, guardrails)</a:t>
             </a:r>
@@ -9487,18 +9479,18 @@
             <a:r>
               <a:rPr sz="1800" b="1">
                 <a:solidFill>
-                  <a:srgbClr val="2ACCFF"/>
-                </a:solidFill>
-                <a:latin typeface="Calibri"/>
-              </a:rPr>
-              <a:t>▸ </a:t>
+                  <a:srgbClr val="2E9BF0"/>
+                </a:solidFill>
+                <a:latin typeface="Arial"/>
+              </a:rPr>
+              <a:t>•  </a:t>
             </a:r>
             <a:r>
               <a:rPr sz="1800">
                 <a:solidFill>
                   <a:srgbClr val="FFFFFF"/>
                 </a:solidFill>
-                <a:latin typeface="Calibri"/>
+                <a:latin typeface="Arial"/>
               </a:rPr>
               <a:t>04  Information, Context &amp; Data — D4 (ERC, memory, cache)</a:t>
             </a:r>
@@ -9535,18 +9527,18 @@
             <a:r>
               <a:rPr sz="1800" b="1">
                 <a:solidFill>
-                  <a:srgbClr val="2ACCFF"/>
-                </a:solidFill>
-                <a:latin typeface="Calibri"/>
-              </a:rPr>
-              <a:t>▸ </a:t>
+                  <a:srgbClr val="2E9BF0"/>
+                </a:solidFill>
+                <a:latin typeface="Arial"/>
+              </a:rPr>
+              <a:t>•  </a:t>
             </a:r>
             <a:r>
               <a:rPr sz="1800">
                 <a:solidFill>
                   <a:srgbClr val="FFFFFF"/>
                 </a:solidFill>
-                <a:latin typeface="Calibri"/>
+                <a:latin typeface="Arial"/>
               </a:rPr>
               <a:t>05  Technology &amp; Infrastructure — D5 (Azure, AKS, APIM)</a:t>
             </a:r>
@@ -9560,18 +9552,18 @@
             <a:r>
               <a:rPr sz="1800" b="1">
                 <a:solidFill>
-                  <a:srgbClr val="2ACCFF"/>
-                </a:solidFill>
-                <a:latin typeface="Calibri"/>
-              </a:rPr>
-              <a:t>▸ </a:t>
+                  <a:srgbClr val="2E9BF0"/>
+                </a:solidFill>
+                <a:latin typeface="Arial"/>
+              </a:rPr>
+              <a:t>•  </a:t>
             </a:r>
             <a:r>
               <a:rPr sz="1800">
                 <a:solidFill>
                   <a:srgbClr val="FFFFFF"/>
                 </a:solidFill>
-                <a:latin typeface="Calibri"/>
+                <a:latin typeface="Arial"/>
               </a:rPr>
               <a:t>06  Security &amp; Governance — D6</a:t>
             </a:r>
@@ -9585,18 +9577,18 @@
             <a:r>
               <a:rPr sz="1800" b="1">
                 <a:solidFill>
-                  <a:srgbClr val="2ACCFF"/>
-                </a:solidFill>
-                <a:latin typeface="Calibri"/>
-              </a:rPr>
-              <a:t>▸ </a:t>
+                  <a:srgbClr val="2E9BF0"/>
+                </a:solidFill>
+                <a:latin typeface="Arial"/>
+              </a:rPr>
+              <a:t>•  </a:t>
             </a:r>
             <a:r>
               <a:rPr sz="1800">
                 <a:solidFill>
                   <a:srgbClr val="FFFFFF"/>
                 </a:solidFill>
-                <a:latin typeface="Calibri"/>
+                <a:latin typeface="Arial"/>
               </a:rPr>
               <a:t>07  Operations, Observability &amp; Quality — D7</a:t>
             </a:r>
@@ -9610,18 +9602,18 @@
             <a:r>
               <a:rPr sz="1800" b="1">
                 <a:solidFill>
-                  <a:srgbClr val="2ACCFF"/>
-                </a:solidFill>
-                <a:latin typeface="Calibri"/>
-              </a:rPr>
-              <a:t>▸ </a:t>
+                  <a:srgbClr val="2E9BF0"/>
+                </a:solidFill>
+                <a:latin typeface="Arial"/>
+              </a:rPr>
+              <a:t>•  </a:t>
             </a:r>
             <a:r>
               <a:rPr sz="1800">
                 <a:solidFill>
                   <a:srgbClr val="FFFFFF"/>
                 </a:solidFill>
-                <a:latin typeface="Calibri"/>
+                <a:latin typeface="Arial"/>
               </a:rPr>
               <a:t>08  Cost &amp; FinOps — per-technology cost model</a:t>
             </a:r>
@@ -9635,18 +9627,18 @@
             <a:r>
               <a:rPr sz="1800" b="1">
                 <a:solidFill>
-                  <a:srgbClr val="2ACCFF"/>
-                </a:solidFill>
-                <a:latin typeface="Calibri"/>
-              </a:rPr>
-              <a:t>▸ </a:t>
+                  <a:srgbClr val="2E9BF0"/>
+                </a:solidFill>
+                <a:latin typeface="Arial"/>
+              </a:rPr>
+              <a:t>•  </a:t>
             </a:r>
             <a:r>
               <a:rPr sz="1800">
                 <a:solidFill>
                   <a:srgbClr val="FFFFFF"/>
                 </a:solidFill>
-                <a:latin typeface="Calibri"/>
+                <a:latin typeface="Arial"/>
               </a:rPr>
               <a:t>09  Open Decisions &amp; ARB sign-off asks</a:t>
             </a:r>
@@ -9718,9 +9710,9 @@
             <a:r>
               <a:rPr sz="1500" b="1" i="0">
                 <a:solidFill>
-                  <a:srgbClr val="2ACCFF"/>
-                </a:solidFill>
-                <a:latin typeface="Calibri"/>
+                  <a:srgbClr val="2E9BF0"/>
+                </a:solidFill>
+                <a:latin typeface="Arial"/>
               </a:rPr>
               <a:t>Adam AI — a conversational orchestration layer over PFF</a:t>
             </a:r>
@@ -9757,18 +9749,18 @@
             <a:r>
               <a:rPr sz="1700" b="1">
                 <a:solidFill>
-                  <a:srgbClr val="2ACCFF"/>
-                </a:solidFill>
-                <a:latin typeface="Calibri"/>
-              </a:rPr>
-              <a:t>▸ </a:t>
+                  <a:srgbClr val="2E9BF0"/>
+                </a:solidFill>
+                <a:latin typeface="Arial"/>
+              </a:rPr>
+              <a:t>•  </a:t>
             </a:r>
             <a:r>
               <a:rPr sz="1700">
                 <a:solidFill>
                   <a:srgbClr val="FFFFFF"/>
                 </a:solidFill>
-                <a:latin typeface="Calibri"/>
+                <a:latin typeface="Arial"/>
               </a:rPr>
               <a:t>PFF is the FA's county/club administration platform — affiliation, registration, insurance, discipline, officials, county cups, payments; integrates with WGS (the FA's national database).</a:t>
             </a:r>
@@ -9782,18 +9774,18 @@
             <a:r>
               <a:rPr sz="1700" b="1">
                 <a:solidFill>
-                  <a:srgbClr val="2ACCFF"/>
-                </a:solidFill>
-                <a:latin typeface="Calibri"/>
-              </a:rPr>
-              <a:t>▸ </a:t>
+                  <a:srgbClr val="2E9BF0"/>
+                </a:solidFill>
+                <a:latin typeface="Arial"/>
+              </a:rPr>
+              <a:t>•  </a:t>
             </a:r>
             <a:r>
               <a:rPr sz="1700">
                 <a:solidFill>
                   <a:srgbClr val="FFFFFF"/>
                 </a:solidFill>
-                <a:latin typeface="Calibri"/>
+                <a:latin typeface="Arial"/>
               </a:rPr>
               <a:t>Adam AI interprets requests, gathers enterprise context, reasons, calls controlled tools, and communicates results — it does not replace PFF's business logic or authority.</a:t>
             </a:r>
@@ -9807,18 +9799,18 @@
             <a:r>
               <a:rPr sz="1700" b="1">
                 <a:solidFill>
-                  <a:srgbClr val="2ACCFF"/>
-                </a:solidFill>
-                <a:latin typeface="Calibri"/>
-              </a:rPr>
-              <a:t>▸ </a:t>
+                  <a:srgbClr val="2E9BF0"/>
+                </a:solidFill>
+                <a:latin typeface="Arial"/>
+              </a:rPr>
+              <a:t>•  </a:t>
             </a:r>
             <a:r>
               <a:rPr sz="1700">
                 <a:solidFill>
                   <a:srgbClr val="FFFFFF"/>
                 </a:solidFill>
-                <a:latin typeface="Calibri"/>
+                <a:latin typeface="Arial"/>
               </a:rPr>
               <a:t>First end-to-end workflow delivered: Club Affiliation.</a:t>
             </a:r>
@@ -9832,18 +9824,18 @@
             <a:r>
               <a:rPr sz="1700" b="1">
                 <a:solidFill>
-                  <a:srgbClr val="2ACCFF"/>
-                </a:solidFill>
-                <a:latin typeface="Calibri"/>
-              </a:rPr>
-              <a:t>▸ </a:t>
+                  <a:srgbClr val="2E9BF0"/>
+                </a:solidFill>
+                <a:latin typeface="Arial"/>
+              </a:rPr>
+              <a:t>•  </a:t>
             </a:r>
             <a:r>
               <a:rPr sz="1700">
                 <a:solidFill>
                   <a:srgbClr val="FFFFFF"/>
                 </a:solidFill>
-                <a:latin typeface="Calibri"/>
+                <a:latin typeface="Arial"/>
               </a:rPr>
               <a:t>Persona: a workflow-first enterprise assistant with a natural football-commentary tone.</a:t>
             </a:r>
@@ -9904,12 +9896,10 @@
             <a:avLst/>
           </a:prstGeom>
           <a:solidFill>
-            <a:srgbClr val="14161C"/>
+            <a:srgbClr val="1B1F27"/>
           </a:solidFill>
-          <a:ln w="15875">
-            <a:solidFill>
-              <a:srgbClr val="FED038"/>
-            </a:solidFill>
+          <a:ln>
+            <a:noFill/>
           </a:ln>
           <a:effectLst/>
         </p:spPr>
@@ -9937,7 +9927,7 @@
                 <a:solidFill>
                   <a:srgbClr val="FFFFFF"/>
                 </a:solidFill>
-                <a:latin typeface="Calibri"/>
+                <a:latin typeface="Arial"/>
               </a:rPr>
               <a:t>Enterprise systems DECIDE and EXECUTE.</a:t>
             </a:r>
@@ -9949,7 +9939,7 @@
                 <a:solidFill>
                   <a:srgbClr val="FFFFFF"/>
                 </a:solidFill>
-                <a:latin typeface="Calibri"/>
+                <a:latin typeface="Arial"/>
               </a:rPr>
               <a:t>The AI platform INTERPRETS, ORCHESTRATES,</a:t>
             </a:r>
@@ -9961,7 +9951,7 @@
                 <a:solidFill>
                   <a:srgbClr val="FFFFFF"/>
                 </a:solidFill>
-                <a:latin typeface="Calibri"/>
+                <a:latin typeface="Arial"/>
               </a:rPr>
               <a:t>CONTEXTUALISES, EXPLAINS and COMMUNICATES.</a:t>
             </a:r>
@@ -9998,18 +9988,18 @@
             <a:r>
               <a:rPr sz="1500" b="1">
                 <a:solidFill>
-                  <a:srgbClr val="2ACCFF"/>
-                </a:solidFill>
-                <a:latin typeface="Calibri"/>
-              </a:rPr>
-              <a:t>▸ </a:t>
+                  <a:srgbClr val="2E9BF0"/>
+                </a:solidFill>
+                <a:latin typeface="Arial"/>
+              </a:rPr>
+              <a:t>•  </a:t>
             </a:r>
             <a:r>
               <a:rPr sz="1500">
                 <a:solidFill>
                   <a:srgbClr val="FFFFFF"/>
                 </a:solidFill>
-                <a:latin typeface="Calibri"/>
+                <a:latin typeface="Arial"/>
               </a:rPr>
               <a:t>The AI never authenticates/authorizes, re-implements business rules, or writes to the enterprise DB.</a:t>
             </a:r>
@@ -10023,18 +10013,18 @@
             <a:r>
               <a:rPr sz="1500" b="1">
                 <a:solidFill>
-                  <a:srgbClr val="2ACCFF"/>
-                </a:solidFill>
-                <a:latin typeface="Calibri"/>
-              </a:rPr>
-              <a:t>▸ </a:t>
+                  <a:srgbClr val="2E9BF0"/>
+                </a:solidFill>
+                <a:latin typeface="Arial"/>
+              </a:rPr>
+              <a:t>•  </a:t>
             </a:r>
             <a:r>
               <a:rPr sz="1500">
                 <a:solidFill>
                   <a:srgbClr val="FFFFFF"/>
                 </a:solidFill>
-                <a:latin typeface="Calibri"/>
+                <a:latin typeface="Arial"/>
               </a:rPr>
               <a:t>A model output never becomes an authorization decision.</a:t>
             </a:r>
@@ -10048,18 +10038,18 @@
             <a:r>
               <a:rPr sz="1500" b="1">
                 <a:solidFill>
-                  <a:srgbClr val="2ACCFF"/>
-                </a:solidFill>
-                <a:latin typeface="Calibri"/>
-              </a:rPr>
-              <a:t>▸ </a:t>
+                  <a:srgbClr val="2E9BF0"/>
+                </a:solidFill>
+                <a:latin typeface="Arial"/>
+              </a:rPr>
+              <a:t>•  </a:t>
             </a:r>
             <a:r>
               <a:rPr sz="1500">
                 <a:solidFill>
                   <a:srgbClr val="FFFFFF"/>
                 </a:solidFill>
-                <a:latin typeface="Calibri"/>
+                <a:latin typeface="Arial"/>
               </a:rPr>
               <a:t>Raw enterprise/personal data is never exposed to an external SLM (masked/tokenised, fail-closed).</a:t>
             </a:r>
@@ -10131,9 +10121,9 @@
             <a:r>
               <a:rPr sz="1500" b="1" i="0">
                 <a:solidFill>
-                  <a:srgbClr val="2ACCFF"/>
-                </a:solidFill>
-                <a:latin typeface="Calibri"/>
+                  <a:srgbClr val="2E9BF0"/>
+                </a:solidFill>
+                <a:latin typeface="Arial"/>
               </a:rPr>
               <a:t>Higher source always wins on conflict</a:t>
             </a:r>
@@ -10142,20 +10132,20 @@
       </p:sp>
       <p:sp>
         <p:nvSpPr>
-          <p:cNvPr id="4" name="Rounded Rectangle 3"/>
+          <p:cNvPr id="4" name="Oval 3"/>
           <p:cNvSpPr/>
           <p:nvPr/>
         </p:nvSpPr>
         <p:spPr>
           <a:xfrm>
-            <a:off x="868680" y="1691640"/>
-            <a:ext cx="146304" cy="749808"/>
-          </a:xfrm>
-          <a:prstGeom prst="roundRect">
+            <a:off x="868680" y="1810512"/>
+            <a:ext cx="512064" cy="512064"/>
+          </a:xfrm>
+          <a:prstGeom prst="ellipse">
             <a:avLst/>
           </a:prstGeom>
           <a:solidFill>
-            <a:srgbClr val="48E84A"/>
+            <a:srgbClr val="2E9BF0"/>
           </a:solidFill>
           <a:ln>
             <a:noFill/>
@@ -10182,38 +10172,141 @@
           <a:p>
             <a:pPr algn="ctr"/>
             <a:r>
-              <a:rPr sz="1300" b="1">
+              <a:rPr sz="1800" b="1">
                 <a:solidFill>
                   <a:srgbClr val="FFFFFF"/>
                 </a:solidFill>
-                <a:latin typeface="Calibri"/>
-              </a:rPr>
-              <a:t/>
-            </a:r>
-          </a:p>
-        </p:txBody>
-      </p:sp>
-      <p:sp>
-        <p:nvSpPr>
-          <p:cNvPr id="5" name="Oval 4"/>
+                <a:latin typeface="Arial"/>
+              </a:rPr>
+              <a:t>1</a:t>
+            </a:r>
+          </a:p>
+        </p:txBody>
+      </p:sp>
+      <p:sp>
+        <p:nvSpPr>
+          <p:cNvPr id="5" name="TextBox 4"/>
+          <p:cNvSpPr txBox="1"/>
+          <p:nvPr/>
+        </p:nvSpPr>
+        <p:spPr>
+          <a:xfrm>
+            <a:off x="1645919" y="1764792"/>
+            <a:ext cx="4572000" cy="365760"/>
+          </a:xfrm>
+          <a:prstGeom prst="rect">
+            <a:avLst/>
+          </a:prstGeom>
+          <a:noFill/>
+        </p:spPr>
+        <p:txBody>
+          <a:bodyPr wrap="square" anchor="t" lIns="0" rIns="0" tIns="0" bIns="0">
+            <a:spAutoFit/>
+          </a:bodyPr>
+          <a:lstStyle/>
+          <a:p>
+            <a:pPr algn="l"/>
+            <a:r>
+              <a:rPr sz="1700" b="1" i="0">
+                <a:solidFill>
+                  <a:srgbClr val="FFFFFF"/>
+                </a:solidFill>
+                <a:latin typeface="Arial"/>
+              </a:rPr>
+              <a:t>Enterprise API / Event</a:t>
+            </a:r>
+          </a:p>
+        </p:txBody>
+      </p:sp>
+      <p:sp>
+        <p:nvSpPr>
+          <p:cNvPr id="6" name="TextBox 5"/>
+          <p:cNvSpPr txBox="1"/>
+          <p:nvPr/>
+        </p:nvSpPr>
+        <p:spPr>
+          <a:xfrm>
+            <a:off x="1645919" y="2093976"/>
+            <a:ext cx="8961120" cy="320040"/>
+          </a:xfrm>
+          <a:prstGeom prst="rect">
+            <a:avLst/>
+          </a:prstGeom>
+          <a:noFill/>
+        </p:spPr>
+        <p:txBody>
+          <a:bodyPr wrap="square" anchor="t" lIns="0" rIns="0" tIns="0" bIns="0">
+            <a:spAutoFit/>
+          </a:bodyPr>
+          <a:lstStyle/>
+          <a:p>
+            <a:pPr algn="l"/>
+            <a:r>
+              <a:rPr sz="1200" b="0" i="0">
+                <a:solidFill>
+                  <a:srgbClr val="CFD3DA"/>
+                </a:solidFill>
+                <a:latin typeface="Arial"/>
+              </a:rPr>
+              <a:t>System of record — decides &amp; executes</a:t>
+            </a:r>
+          </a:p>
+        </p:txBody>
+      </p:sp>
+      <p:sp>
+        <p:nvSpPr>
+          <p:cNvPr id="7" name="TextBox 6"/>
+          <p:cNvSpPr txBox="1"/>
+          <p:nvPr/>
+        </p:nvSpPr>
+        <p:spPr>
+          <a:xfrm>
+            <a:off x="1645919" y="2423160"/>
+            <a:ext cx="7315200" cy="256032"/>
+          </a:xfrm>
+          <a:prstGeom prst="rect">
+            <a:avLst/>
+          </a:prstGeom>
+          <a:noFill/>
+        </p:spPr>
+        <p:txBody>
+          <a:bodyPr wrap="square" anchor="t" lIns="0" rIns="0" tIns="0" bIns="0">
+            <a:spAutoFit/>
+          </a:bodyPr>
+          <a:lstStyle/>
+          <a:p>
+            <a:pPr algn="l"/>
+            <a:r>
+              <a:rPr sz="900" b="0" i="0">
+                <a:solidFill>
+                  <a:srgbClr val="8A909C"/>
+                </a:solidFill>
+                <a:latin typeface="Arial"/>
+              </a:rPr>
+              <a:t>▼  higher source wins on conflict — always</a:t>
+            </a:r>
+          </a:p>
+        </p:txBody>
+      </p:sp>
+      <p:sp>
+        <p:nvSpPr>
+          <p:cNvPr id="8" name="Oval 7"/>
           <p:cNvSpPr/>
           <p:nvPr/>
         </p:nvSpPr>
         <p:spPr>
           <a:xfrm>
-            <a:off x="1124712" y="1810512"/>
+            <a:off x="868680" y="2688336"/>
             <a:ext cx="512064" cy="512064"/>
           </a:xfrm>
           <a:prstGeom prst="ellipse">
             <a:avLst/>
           </a:prstGeom>
           <a:solidFill>
-            <a:srgbClr val="1E222B"/>
+            <a:srgbClr val="2E9BF0"/>
           </a:solidFill>
-          <a:ln w="15875">
-            <a:solidFill>
-              <a:srgbClr val="48E84A"/>
-            </a:solidFill>
+          <a:ln>
+            <a:noFill/>
           </a:ln>
           <a:effectLst/>
         </p:spPr>
@@ -10239,25 +10332,25 @@
             <a:r>
               <a:rPr sz="1800" b="1">
                 <a:solidFill>
-                  <a:srgbClr val="48E84A"/>
-                </a:solidFill>
-                <a:latin typeface="Calibri"/>
-              </a:rPr>
-              <a:t>1</a:t>
-            </a:r>
-          </a:p>
-        </p:txBody>
-      </p:sp>
-      <p:sp>
-        <p:nvSpPr>
-          <p:cNvPr id="6" name="TextBox 5"/>
+                  <a:srgbClr val="FFFFFF"/>
+                </a:solidFill>
+                <a:latin typeface="Arial"/>
+              </a:rPr>
+              <a:t>2</a:t>
+            </a:r>
+          </a:p>
+        </p:txBody>
+      </p:sp>
+      <p:sp>
+        <p:nvSpPr>
+          <p:cNvPr id="9" name="TextBox 8"/>
           <p:cNvSpPr txBox="1"/>
           <p:nvPr/>
         </p:nvSpPr>
         <p:spPr>
           <a:xfrm>
-            <a:off x="1828800" y="1764792"/>
-            <a:ext cx="4114800" cy="365760"/>
+            <a:off x="1645919" y="2642616"/>
+            <a:ext cx="4572000" cy="365760"/>
           </a:xfrm>
           <a:prstGeom prst="rect">
             <a:avLst/>
@@ -10276,22 +10369,22 @@
                 <a:solidFill>
                   <a:srgbClr val="FFFFFF"/>
                 </a:solidFill>
-                <a:latin typeface="Calibri"/>
-              </a:rPr>
-              <a:t>Enterprise API / Event</a:t>
-            </a:r>
-          </a:p>
-        </p:txBody>
-      </p:sp>
-      <p:sp>
-        <p:nvSpPr>
-          <p:cNvPr id="7" name="TextBox 6"/>
+                <a:latin typeface="Arial"/>
+              </a:rPr>
+              <a:t>ERC</a:t>
+            </a:r>
+          </a:p>
+        </p:txBody>
+      </p:sp>
+      <p:sp>
+        <p:nvSpPr>
+          <p:cNvPr id="10" name="TextBox 9"/>
           <p:cNvSpPr txBox="1"/>
           <p:nvPr/>
         </p:nvSpPr>
         <p:spPr>
           <a:xfrm>
-            <a:off x="1828800" y="2093976"/>
+            <a:off x="1645919" y="2971800"/>
             <a:ext cx="8961120" cy="320040"/>
           </a:xfrm>
           <a:prstGeom prst="rect">
@@ -10309,24 +10402,24 @@
             <a:r>
               <a:rPr sz="1200" b="0" i="0">
                 <a:solidFill>
-                  <a:srgbClr val="D5D5D5"/>
-                </a:solidFill>
-                <a:latin typeface="Calibri"/>
-              </a:rPr>
-              <a:t>System of record — decides &amp; executes</a:t>
-            </a:r>
-          </a:p>
-        </p:txBody>
-      </p:sp>
-      <p:sp>
-        <p:nvSpPr>
-          <p:cNvPr id="8" name="TextBox 7"/>
+                  <a:srgbClr val="CFD3DA"/>
+                </a:solidFill>
+                <a:latin typeface="Arial"/>
+              </a:rPr>
+              <a:t>Enterprise Runtime Context — validated, provenanced</a:t>
+            </a:r>
+          </a:p>
+        </p:txBody>
+      </p:sp>
+      <p:sp>
+        <p:nvSpPr>
+          <p:cNvPr id="11" name="TextBox 10"/>
           <p:cNvSpPr txBox="1"/>
           <p:nvPr/>
         </p:nvSpPr>
         <p:spPr>
           <a:xfrm>
-            <a:off x="1828800" y="2423160"/>
+            <a:off x="1645919" y="3300984"/>
             <a:ext cx="7315200" cy="256032"/>
           </a:xfrm>
           <a:prstGeom prst="rect">
@@ -10344,9 +10437,9 @@
             <a:r>
               <a:rPr sz="900" b="0" i="0">
                 <a:solidFill>
-                  <a:srgbClr val="9A9A9A"/>
-                </a:solidFill>
-                <a:latin typeface="Calibri"/>
+                  <a:srgbClr val="8A909C"/>
+                </a:solidFill>
+                <a:latin typeface="Arial"/>
               </a:rPr>
               <a:t>▼  higher source wins on conflict — always</a:t>
             </a:r>
@@ -10355,20 +10448,20 @@
       </p:sp>
       <p:sp>
         <p:nvSpPr>
-          <p:cNvPr id="9" name="Rounded Rectangle 8"/>
+          <p:cNvPr id="12" name="Oval 11"/>
           <p:cNvSpPr/>
           <p:nvPr/>
         </p:nvSpPr>
         <p:spPr>
           <a:xfrm>
-            <a:off x="868680" y="2569464"/>
-            <a:ext cx="146304" cy="749808"/>
-          </a:xfrm>
-          <a:prstGeom prst="roundRect">
+            <a:off x="868680" y="3566160"/>
+            <a:ext cx="512064" cy="512064"/>
+          </a:xfrm>
+          <a:prstGeom prst="ellipse">
             <a:avLst/>
           </a:prstGeom>
           <a:solidFill>
-            <a:srgbClr val="2ACCFF"/>
+            <a:srgbClr val="2E9BF0"/>
           </a:solidFill>
           <a:ln>
             <a:noFill/>
@@ -10395,38 +10488,141 @@
           <a:p>
             <a:pPr algn="ctr"/>
             <a:r>
-              <a:rPr sz="1300" b="1">
+              <a:rPr sz="1800" b="1">
                 <a:solidFill>
                   <a:srgbClr val="FFFFFF"/>
                 </a:solidFill>
-                <a:latin typeface="Calibri"/>
-              </a:rPr>
-              <a:t/>
-            </a:r>
-          </a:p>
-        </p:txBody>
-      </p:sp>
-      <p:sp>
-        <p:nvSpPr>
-          <p:cNvPr id="10" name="Oval 9"/>
+                <a:latin typeface="Arial"/>
+              </a:rPr>
+              <a:t>3</a:t>
+            </a:r>
+          </a:p>
+        </p:txBody>
+      </p:sp>
+      <p:sp>
+        <p:nvSpPr>
+          <p:cNvPr id="13" name="TextBox 12"/>
+          <p:cNvSpPr txBox="1"/>
+          <p:nvPr/>
+        </p:nvSpPr>
+        <p:spPr>
+          <a:xfrm>
+            <a:off x="1645919" y="3520440"/>
+            <a:ext cx="4572000" cy="365760"/>
+          </a:xfrm>
+          <a:prstGeom prst="rect">
+            <a:avLst/>
+          </a:prstGeom>
+          <a:noFill/>
+        </p:spPr>
+        <p:txBody>
+          <a:bodyPr wrap="square" anchor="t" lIns="0" rIns="0" tIns="0" bIns="0">
+            <a:spAutoFit/>
+          </a:bodyPr>
+          <a:lstStyle/>
+          <a:p>
+            <a:pPr algn="l"/>
+            <a:r>
+              <a:rPr sz="1700" b="1" i="0">
+                <a:solidFill>
+                  <a:srgbClr val="FFFFFF"/>
+                </a:solidFill>
+                <a:latin typeface="Arial"/>
+              </a:rPr>
+              <a:t>Cache</a:t>
+            </a:r>
+          </a:p>
+        </p:txBody>
+      </p:sp>
+      <p:sp>
+        <p:nvSpPr>
+          <p:cNvPr id="14" name="TextBox 13"/>
+          <p:cNvSpPr txBox="1"/>
+          <p:nvPr/>
+        </p:nvSpPr>
+        <p:spPr>
+          <a:xfrm>
+            <a:off x="1645919" y="3849624"/>
+            <a:ext cx="8961120" cy="320040"/>
+          </a:xfrm>
+          <a:prstGeom prst="rect">
+            <a:avLst/>
+          </a:prstGeom>
+          <a:noFill/>
+        </p:spPr>
+        <p:txBody>
+          <a:bodyPr wrap="square" anchor="t" lIns="0" rIns="0" tIns="0" bIns="0">
+            <a:spAutoFit/>
+          </a:bodyPr>
+          <a:lstStyle/>
+          <a:p>
+            <a:pPr algn="l"/>
+            <a:r>
+              <a:rPr sz="1200" b="0" i="0">
+                <a:solidFill>
+                  <a:srgbClr val="CFD3DA"/>
+                </a:solidFill>
+                <a:latin typeface="Arial"/>
+              </a:rPr>
+              <a:t>Authorization-aware, freshness-bounded</a:t>
+            </a:r>
+          </a:p>
+        </p:txBody>
+      </p:sp>
+      <p:sp>
+        <p:nvSpPr>
+          <p:cNvPr id="15" name="TextBox 14"/>
+          <p:cNvSpPr txBox="1"/>
+          <p:nvPr/>
+        </p:nvSpPr>
+        <p:spPr>
+          <a:xfrm>
+            <a:off x="1645919" y="4178808"/>
+            <a:ext cx="7315200" cy="256032"/>
+          </a:xfrm>
+          <a:prstGeom prst="rect">
+            <a:avLst/>
+          </a:prstGeom>
+          <a:noFill/>
+        </p:spPr>
+        <p:txBody>
+          <a:bodyPr wrap="square" anchor="t" lIns="0" rIns="0" tIns="0" bIns="0">
+            <a:spAutoFit/>
+          </a:bodyPr>
+          <a:lstStyle/>
+          <a:p>
+            <a:pPr algn="l"/>
+            <a:r>
+              <a:rPr sz="900" b="0" i="0">
+                <a:solidFill>
+                  <a:srgbClr val="8A909C"/>
+                </a:solidFill>
+                <a:latin typeface="Arial"/>
+              </a:rPr>
+              <a:t>▼  higher source wins on conflict — always</a:t>
+            </a:r>
+          </a:p>
+        </p:txBody>
+      </p:sp>
+      <p:sp>
+        <p:nvSpPr>
+          <p:cNvPr id="16" name="Oval 15"/>
           <p:cNvSpPr/>
           <p:nvPr/>
         </p:nvSpPr>
         <p:spPr>
           <a:xfrm>
-            <a:off x="1124712" y="2688336"/>
+            <a:off x="868680" y="4443984"/>
             <a:ext cx="512064" cy="512064"/>
           </a:xfrm>
           <a:prstGeom prst="ellipse">
             <a:avLst/>
           </a:prstGeom>
           <a:solidFill>
-            <a:srgbClr val="1E222B"/>
+            <a:srgbClr val="2E9BF0"/>
           </a:solidFill>
-          <a:ln w="15875">
-            <a:solidFill>
-              <a:srgbClr val="2ACCFF"/>
-            </a:solidFill>
+          <a:ln>
+            <a:noFill/>
           </a:ln>
           <a:effectLst/>
         </p:spPr>
@@ -10452,25 +10648,25 @@
             <a:r>
               <a:rPr sz="1800" b="1">
                 <a:solidFill>
-                  <a:srgbClr val="2ACCFF"/>
-                </a:solidFill>
-                <a:latin typeface="Calibri"/>
-              </a:rPr>
-              <a:t>2</a:t>
-            </a:r>
-          </a:p>
-        </p:txBody>
-      </p:sp>
-      <p:sp>
-        <p:nvSpPr>
-          <p:cNvPr id="11" name="TextBox 10"/>
+                  <a:srgbClr val="FFFFFF"/>
+                </a:solidFill>
+                <a:latin typeface="Arial"/>
+              </a:rPr>
+              <a:t>4</a:t>
+            </a:r>
+          </a:p>
+        </p:txBody>
+      </p:sp>
+      <p:sp>
+        <p:nvSpPr>
+          <p:cNvPr id="17" name="TextBox 16"/>
           <p:cNvSpPr txBox="1"/>
           <p:nvPr/>
         </p:nvSpPr>
         <p:spPr>
           <a:xfrm>
-            <a:off x="1828800" y="2642616"/>
-            <a:ext cx="4114800" cy="365760"/>
+            <a:off x="1645919" y="4398264"/>
+            <a:ext cx="4572000" cy="365760"/>
           </a:xfrm>
           <a:prstGeom prst="rect">
             <a:avLst/>
@@ -10489,22 +10685,22 @@
                 <a:solidFill>
                   <a:srgbClr val="FFFFFF"/>
                 </a:solidFill>
-                <a:latin typeface="Calibri"/>
-              </a:rPr>
-              <a:t>ERC</a:t>
-            </a:r>
-          </a:p>
-        </p:txBody>
-      </p:sp>
-      <p:sp>
-        <p:nvSpPr>
-          <p:cNvPr id="12" name="TextBox 11"/>
+                <a:latin typeface="Arial"/>
+              </a:rPr>
+              <a:t>RAG</a:t>
+            </a:r>
+          </a:p>
+        </p:txBody>
+      </p:sp>
+      <p:sp>
+        <p:nvSpPr>
+          <p:cNvPr id="18" name="TextBox 17"/>
           <p:cNvSpPr txBox="1"/>
           <p:nvPr/>
         </p:nvSpPr>
         <p:spPr>
           <a:xfrm>
-            <a:off x="1828800" y="2971800"/>
+            <a:off x="1645919" y="4727448"/>
             <a:ext cx="8961120" cy="320040"/>
           </a:xfrm>
           <a:prstGeom prst="rect">
@@ -10522,24 +10718,24 @@
             <a:r>
               <a:rPr sz="1200" b="0" i="0">
                 <a:solidFill>
-                  <a:srgbClr val="D5D5D5"/>
-                </a:solidFill>
-                <a:latin typeface="Calibri"/>
-              </a:rPr>
-              <a:t>Enterprise Runtime Context — validated, provenanced</a:t>
-            </a:r>
-          </a:p>
-        </p:txBody>
-      </p:sp>
-      <p:sp>
-        <p:nvSpPr>
-          <p:cNvPr id="13" name="TextBox 12"/>
+                  <a:srgbClr val="CFD3DA"/>
+                </a:solidFill>
+                <a:latin typeface="Arial"/>
+              </a:rPr>
+              <a:t>Retrieved knowledge — cited, ACL-enforced</a:t>
+            </a:r>
+          </a:p>
+        </p:txBody>
+      </p:sp>
+      <p:sp>
+        <p:nvSpPr>
+          <p:cNvPr id="19" name="TextBox 18"/>
           <p:cNvSpPr txBox="1"/>
           <p:nvPr/>
         </p:nvSpPr>
         <p:spPr>
           <a:xfrm>
-            <a:off x="1828800" y="3300984"/>
+            <a:off x="1645919" y="5056632"/>
             <a:ext cx="7315200" cy="256032"/>
           </a:xfrm>
           <a:prstGeom prst="rect">
@@ -10557,9 +10753,9 @@
             <a:r>
               <a:rPr sz="900" b="0" i="0">
                 <a:solidFill>
-                  <a:srgbClr val="9A9A9A"/>
-                </a:solidFill>
-                <a:latin typeface="Calibri"/>
+                  <a:srgbClr val="8A909C"/>
+                </a:solidFill>
+                <a:latin typeface="Arial"/>
               </a:rPr>
               <a:t>▼  higher source wins on conflict — always</a:t>
             </a:r>
@@ -10568,20 +10764,20 @@
       </p:sp>
       <p:sp>
         <p:nvSpPr>
-          <p:cNvPr id="14" name="Rounded Rectangle 13"/>
+          <p:cNvPr id="20" name="Oval 19"/>
           <p:cNvSpPr/>
           <p:nvPr/>
         </p:nvSpPr>
         <p:spPr>
           <a:xfrm>
-            <a:off x="868680" y="3447288"/>
-            <a:ext cx="146304" cy="749808"/>
-          </a:xfrm>
-          <a:prstGeom prst="roundRect">
+            <a:off x="868680" y="5321808"/>
+            <a:ext cx="512064" cy="512064"/>
+          </a:xfrm>
+          <a:prstGeom prst="ellipse">
             <a:avLst/>
           </a:prstGeom>
           <a:solidFill>
-            <a:srgbClr val="0283FF"/>
+            <a:srgbClr val="2E9BF0"/>
           </a:solidFill>
           <a:ln>
             <a:noFill/>
@@ -10608,82 +10804,27 @@
           <a:p>
             <a:pPr algn="ctr"/>
             <a:r>
-              <a:rPr sz="1300" b="1">
+              <a:rPr sz="1800" b="1">
                 <a:solidFill>
                   <a:srgbClr val="FFFFFF"/>
                 </a:solidFill>
-                <a:latin typeface="Calibri"/>
-              </a:rPr>
-              <a:t/>
-            </a:r>
-          </a:p>
-        </p:txBody>
-      </p:sp>
-      <p:sp>
-        <p:nvSpPr>
-          <p:cNvPr id="15" name="Oval 14"/>
-          <p:cNvSpPr/>
-          <p:nvPr/>
-        </p:nvSpPr>
-        <p:spPr>
-          <a:xfrm>
-            <a:off x="1124712" y="3566160"/>
-            <a:ext cx="512064" cy="512064"/>
-          </a:xfrm>
-          <a:prstGeom prst="ellipse">
-            <a:avLst/>
-          </a:prstGeom>
-          <a:solidFill>
-            <a:srgbClr val="1E222B"/>
-          </a:solidFill>
-          <a:ln w="15875">
-            <a:solidFill>
-              <a:srgbClr val="0283FF"/>
-            </a:solidFill>
-          </a:ln>
-          <a:effectLst/>
-        </p:spPr>
-        <p:style>
-          <a:lnRef idx="1">
-            <a:schemeClr val="accent1"/>
-          </a:lnRef>
-          <a:fillRef idx="3">
-            <a:schemeClr val="accent1"/>
-          </a:fillRef>
-          <a:effectRef idx="2">
-            <a:schemeClr val="accent1"/>
-          </a:effectRef>
-          <a:fontRef idx="minor">
-            <a:schemeClr val="lt1"/>
-          </a:fontRef>
-        </p:style>
-        <p:txBody>
-          <a:bodyPr rtlCol="0" anchor="ctr" wrap="square" lIns="50800" rIns="50800" tIns="38100" bIns="38100"/>
-          <a:lstStyle/>
-          <a:p>
-            <a:pPr algn="ctr"/>
-            <a:r>
-              <a:rPr sz="1800" b="1">
-                <a:solidFill>
-                  <a:srgbClr val="0283FF"/>
-                </a:solidFill>
-                <a:latin typeface="Calibri"/>
-              </a:rPr>
-              <a:t>3</a:t>
-            </a:r>
-          </a:p>
-        </p:txBody>
-      </p:sp>
-      <p:sp>
-        <p:nvSpPr>
-          <p:cNvPr id="16" name="TextBox 15"/>
+                <a:latin typeface="Arial"/>
+              </a:rPr>
+              <a:t>5</a:t>
+            </a:r>
+          </a:p>
+        </p:txBody>
+      </p:sp>
+      <p:sp>
+        <p:nvSpPr>
+          <p:cNvPr id="21" name="TextBox 20"/>
           <p:cNvSpPr txBox="1"/>
           <p:nvPr/>
         </p:nvSpPr>
         <p:spPr>
           <a:xfrm>
-            <a:off x="1828800" y="3520440"/>
-            <a:ext cx="4114800" cy="365760"/>
+            <a:off x="1645919" y="5276088"/>
+            <a:ext cx="4572000" cy="365760"/>
           </a:xfrm>
           <a:prstGeom prst="rect">
             <a:avLst/>
@@ -10702,22 +10843,22 @@
                 <a:solidFill>
                   <a:srgbClr val="FFFFFF"/>
                 </a:solidFill>
-                <a:latin typeface="Calibri"/>
-              </a:rPr>
-              <a:t>Cache</a:t>
-            </a:r>
-          </a:p>
-        </p:txBody>
-      </p:sp>
-      <p:sp>
-        <p:nvSpPr>
-          <p:cNvPr id="17" name="TextBox 16"/>
+                <a:latin typeface="Arial"/>
+              </a:rPr>
+              <a:t>SLM output</a:t>
+            </a:r>
+          </a:p>
+        </p:txBody>
+      </p:sp>
+      <p:sp>
+        <p:nvSpPr>
+          <p:cNvPr id="22" name="TextBox 21"/>
           <p:cNvSpPr txBox="1"/>
           <p:nvPr/>
         </p:nvSpPr>
         <p:spPr>
           <a:xfrm>
-            <a:off x="1828800" y="3849624"/>
+            <a:off x="1645919" y="5605272"/>
             <a:ext cx="8961120" cy="320040"/>
           </a:xfrm>
           <a:prstGeom prst="rect">
@@ -10735,435 +10876,9 @@
             <a:r>
               <a:rPr sz="1200" b="0" i="0">
                 <a:solidFill>
-                  <a:srgbClr val="D5D5D5"/>
-                </a:solidFill>
-                <a:latin typeface="Calibri"/>
-              </a:rPr>
-              <a:t>Authorization-aware, freshness-bounded</a:t>
-            </a:r>
-          </a:p>
-        </p:txBody>
-      </p:sp>
-      <p:sp>
-        <p:nvSpPr>
-          <p:cNvPr id="18" name="TextBox 17"/>
-          <p:cNvSpPr txBox="1"/>
-          <p:nvPr/>
-        </p:nvSpPr>
-        <p:spPr>
-          <a:xfrm>
-            <a:off x="1828800" y="4178808"/>
-            <a:ext cx="7315200" cy="256032"/>
-          </a:xfrm>
-          <a:prstGeom prst="rect">
-            <a:avLst/>
-          </a:prstGeom>
-          <a:noFill/>
-        </p:spPr>
-        <p:txBody>
-          <a:bodyPr wrap="square" anchor="t" lIns="0" rIns="0" tIns="0" bIns="0">
-            <a:spAutoFit/>
-          </a:bodyPr>
-          <a:lstStyle/>
-          <a:p>
-            <a:pPr algn="l"/>
-            <a:r>
-              <a:rPr sz="900" b="0" i="0">
-                <a:solidFill>
-                  <a:srgbClr val="9A9A9A"/>
-                </a:solidFill>
-                <a:latin typeface="Calibri"/>
-              </a:rPr>
-              <a:t>▼  higher source wins on conflict — always</a:t>
-            </a:r>
-          </a:p>
-        </p:txBody>
-      </p:sp>
-      <p:sp>
-        <p:nvSpPr>
-          <p:cNvPr id="19" name="Rounded Rectangle 18"/>
-          <p:cNvSpPr/>
-          <p:nvPr/>
-        </p:nvSpPr>
-        <p:spPr>
-          <a:xfrm>
-            <a:off x="868680" y="4325112"/>
-            <a:ext cx="146304" cy="749808"/>
-          </a:xfrm>
-          <a:prstGeom prst="roundRect">
-            <a:avLst/>
-          </a:prstGeom>
-          <a:solidFill>
-            <a:srgbClr val="7F19BE"/>
-          </a:solidFill>
-          <a:ln>
-            <a:noFill/>
-          </a:ln>
-          <a:effectLst/>
-        </p:spPr>
-        <p:style>
-          <a:lnRef idx="1">
-            <a:schemeClr val="accent1"/>
-          </a:lnRef>
-          <a:fillRef idx="3">
-            <a:schemeClr val="accent1"/>
-          </a:fillRef>
-          <a:effectRef idx="2">
-            <a:schemeClr val="accent1"/>
-          </a:effectRef>
-          <a:fontRef idx="minor">
-            <a:schemeClr val="lt1"/>
-          </a:fontRef>
-        </p:style>
-        <p:txBody>
-          <a:bodyPr rtlCol="0" anchor="ctr" wrap="square" lIns="50800" rIns="50800" tIns="38100" bIns="38100"/>
-          <a:lstStyle/>
-          <a:p>
-            <a:pPr algn="ctr"/>
-            <a:r>
-              <a:rPr sz="1300" b="1">
-                <a:solidFill>
-                  <a:srgbClr val="FFFFFF"/>
-                </a:solidFill>
-                <a:latin typeface="Calibri"/>
-              </a:rPr>
-              <a:t/>
-            </a:r>
-          </a:p>
-        </p:txBody>
-      </p:sp>
-      <p:sp>
-        <p:nvSpPr>
-          <p:cNvPr id="20" name="Oval 19"/>
-          <p:cNvSpPr/>
-          <p:nvPr/>
-        </p:nvSpPr>
-        <p:spPr>
-          <a:xfrm>
-            <a:off x="1124712" y="4443984"/>
-            <a:ext cx="512064" cy="512064"/>
-          </a:xfrm>
-          <a:prstGeom prst="ellipse">
-            <a:avLst/>
-          </a:prstGeom>
-          <a:solidFill>
-            <a:srgbClr val="1E222B"/>
-          </a:solidFill>
-          <a:ln w="15875">
-            <a:solidFill>
-              <a:srgbClr val="7F19BE"/>
-            </a:solidFill>
-          </a:ln>
-          <a:effectLst/>
-        </p:spPr>
-        <p:style>
-          <a:lnRef idx="1">
-            <a:schemeClr val="accent1"/>
-          </a:lnRef>
-          <a:fillRef idx="3">
-            <a:schemeClr val="accent1"/>
-          </a:fillRef>
-          <a:effectRef idx="2">
-            <a:schemeClr val="accent1"/>
-          </a:effectRef>
-          <a:fontRef idx="minor">
-            <a:schemeClr val="lt1"/>
-          </a:fontRef>
-        </p:style>
-        <p:txBody>
-          <a:bodyPr rtlCol="0" anchor="ctr" wrap="square" lIns="50800" rIns="50800" tIns="38100" bIns="38100"/>
-          <a:lstStyle/>
-          <a:p>
-            <a:pPr algn="ctr"/>
-            <a:r>
-              <a:rPr sz="1800" b="1">
-                <a:solidFill>
-                  <a:srgbClr val="7F19BE"/>
-                </a:solidFill>
-                <a:latin typeface="Calibri"/>
-              </a:rPr>
-              <a:t>4</a:t>
-            </a:r>
-          </a:p>
-        </p:txBody>
-      </p:sp>
-      <p:sp>
-        <p:nvSpPr>
-          <p:cNvPr id="21" name="TextBox 20"/>
-          <p:cNvSpPr txBox="1"/>
-          <p:nvPr/>
-        </p:nvSpPr>
-        <p:spPr>
-          <a:xfrm>
-            <a:off x="1828800" y="4398264"/>
-            <a:ext cx="4114800" cy="365760"/>
-          </a:xfrm>
-          <a:prstGeom prst="rect">
-            <a:avLst/>
-          </a:prstGeom>
-          <a:noFill/>
-        </p:spPr>
-        <p:txBody>
-          <a:bodyPr wrap="square" anchor="t" lIns="0" rIns="0" tIns="0" bIns="0">
-            <a:spAutoFit/>
-          </a:bodyPr>
-          <a:lstStyle/>
-          <a:p>
-            <a:pPr algn="l"/>
-            <a:r>
-              <a:rPr sz="1700" b="1" i="0">
-                <a:solidFill>
-                  <a:srgbClr val="FFFFFF"/>
-                </a:solidFill>
-                <a:latin typeface="Calibri"/>
-              </a:rPr>
-              <a:t>RAG</a:t>
-            </a:r>
-          </a:p>
-        </p:txBody>
-      </p:sp>
-      <p:sp>
-        <p:nvSpPr>
-          <p:cNvPr id="22" name="TextBox 21"/>
-          <p:cNvSpPr txBox="1"/>
-          <p:nvPr/>
-        </p:nvSpPr>
-        <p:spPr>
-          <a:xfrm>
-            <a:off x="1828800" y="4727448"/>
-            <a:ext cx="8961120" cy="320040"/>
-          </a:xfrm>
-          <a:prstGeom prst="rect">
-            <a:avLst/>
-          </a:prstGeom>
-          <a:noFill/>
-        </p:spPr>
-        <p:txBody>
-          <a:bodyPr wrap="square" anchor="t" lIns="0" rIns="0" tIns="0" bIns="0">
-            <a:spAutoFit/>
-          </a:bodyPr>
-          <a:lstStyle/>
-          <a:p>
-            <a:pPr algn="l"/>
-            <a:r>
-              <a:rPr sz="1200" b="0" i="0">
-                <a:solidFill>
-                  <a:srgbClr val="D5D5D5"/>
-                </a:solidFill>
-                <a:latin typeface="Calibri"/>
-              </a:rPr>
-              <a:t>Retrieved knowledge — cited, ACL-enforced</a:t>
-            </a:r>
-          </a:p>
-        </p:txBody>
-      </p:sp>
-      <p:sp>
-        <p:nvSpPr>
-          <p:cNvPr id="23" name="TextBox 22"/>
-          <p:cNvSpPr txBox="1"/>
-          <p:nvPr/>
-        </p:nvSpPr>
-        <p:spPr>
-          <a:xfrm>
-            <a:off x="1828800" y="5056632"/>
-            <a:ext cx="7315200" cy="256032"/>
-          </a:xfrm>
-          <a:prstGeom prst="rect">
-            <a:avLst/>
-          </a:prstGeom>
-          <a:noFill/>
-        </p:spPr>
-        <p:txBody>
-          <a:bodyPr wrap="square" anchor="t" lIns="0" rIns="0" tIns="0" bIns="0">
-            <a:spAutoFit/>
-          </a:bodyPr>
-          <a:lstStyle/>
-          <a:p>
-            <a:pPr algn="l"/>
-            <a:r>
-              <a:rPr sz="900" b="0" i="0">
-                <a:solidFill>
-                  <a:srgbClr val="9A9A9A"/>
-                </a:solidFill>
-                <a:latin typeface="Calibri"/>
-              </a:rPr>
-              <a:t>▼  higher source wins on conflict — always</a:t>
-            </a:r>
-          </a:p>
-        </p:txBody>
-      </p:sp>
-      <p:sp>
-        <p:nvSpPr>
-          <p:cNvPr id="24" name="Rounded Rectangle 23"/>
-          <p:cNvSpPr/>
-          <p:nvPr/>
-        </p:nvSpPr>
-        <p:spPr>
-          <a:xfrm>
-            <a:off x="868680" y="5202936"/>
-            <a:ext cx="146304" cy="749808"/>
-          </a:xfrm>
-          <a:prstGeom prst="roundRect">
-            <a:avLst/>
-          </a:prstGeom>
-          <a:solidFill>
-            <a:srgbClr val="FE2579"/>
-          </a:solidFill>
-          <a:ln>
-            <a:noFill/>
-          </a:ln>
-          <a:effectLst/>
-        </p:spPr>
-        <p:style>
-          <a:lnRef idx="1">
-            <a:schemeClr val="accent1"/>
-          </a:lnRef>
-          <a:fillRef idx="3">
-            <a:schemeClr val="accent1"/>
-          </a:fillRef>
-          <a:effectRef idx="2">
-            <a:schemeClr val="accent1"/>
-          </a:effectRef>
-          <a:fontRef idx="minor">
-            <a:schemeClr val="lt1"/>
-          </a:fontRef>
-        </p:style>
-        <p:txBody>
-          <a:bodyPr rtlCol="0" anchor="ctr" wrap="square" lIns="50800" rIns="50800" tIns="38100" bIns="38100"/>
-          <a:lstStyle/>
-          <a:p>
-            <a:pPr algn="ctr"/>
-            <a:r>
-              <a:rPr sz="1300" b="1">
-                <a:solidFill>
-                  <a:srgbClr val="FFFFFF"/>
-                </a:solidFill>
-                <a:latin typeface="Calibri"/>
-              </a:rPr>
-              <a:t/>
-            </a:r>
-          </a:p>
-        </p:txBody>
-      </p:sp>
-      <p:sp>
-        <p:nvSpPr>
-          <p:cNvPr id="25" name="Oval 24"/>
-          <p:cNvSpPr/>
-          <p:nvPr/>
-        </p:nvSpPr>
-        <p:spPr>
-          <a:xfrm>
-            <a:off x="1124712" y="5321808"/>
-            <a:ext cx="512064" cy="512064"/>
-          </a:xfrm>
-          <a:prstGeom prst="ellipse">
-            <a:avLst/>
-          </a:prstGeom>
-          <a:solidFill>
-            <a:srgbClr val="1E222B"/>
-          </a:solidFill>
-          <a:ln w="15875">
-            <a:solidFill>
-              <a:srgbClr val="FE2579"/>
-            </a:solidFill>
-          </a:ln>
-          <a:effectLst/>
-        </p:spPr>
-        <p:style>
-          <a:lnRef idx="1">
-            <a:schemeClr val="accent1"/>
-          </a:lnRef>
-          <a:fillRef idx="3">
-            <a:schemeClr val="accent1"/>
-          </a:fillRef>
-          <a:effectRef idx="2">
-            <a:schemeClr val="accent1"/>
-          </a:effectRef>
-          <a:fontRef idx="minor">
-            <a:schemeClr val="lt1"/>
-          </a:fontRef>
-        </p:style>
-        <p:txBody>
-          <a:bodyPr rtlCol="0" anchor="ctr" wrap="square" lIns="50800" rIns="50800" tIns="38100" bIns="38100"/>
-          <a:lstStyle/>
-          <a:p>
-            <a:pPr algn="ctr"/>
-            <a:r>
-              <a:rPr sz="1800" b="1">
-                <a:solidFill>
-                  <a:srgbClr val="FE2579"/>
-                </a:solidFill>
-                <a:latin typeface="Calibri"/>
-              </a:rPr>
-              <a:t>5</a:t>
-            </a:r>
-          </a:p>
-        </p:txBody>
-      </p:sp>
-      <p:sp>
-        <p:nvSpPr>
-          <p:cNvPr id="26" name="TextBox 25"/>
-          <p:cNvSpPr txBox="1"/>
-          <p:nvPr/>
-        </p:nvSpPr>
-        <p:spPr>
-          <a:xfrm>
-            <a:off x="1828800" y="5276088"/>
-            <a:ext cx="4114800" cy="365760"/>
-          </a:xfrm>
-          <a:prstGeom prst="rect">
-            <a:avLst/>
-          </a:prstGeom>
-          <a:noFill/>
-        </p:spPr>
-        <p:txBody>
-          <a:bodyPr wrap="square" anchor="t" lIns="0" rIns="0" tIns="0" bIns="0">
-            <a:spAutoFit/>
-          </a:bodyPr>
-          <a:lstStyle/>
-          <a:p>
-            <a:pPr algn="l"/>
-            <a:r>
-              <a:rPr sz="1700" b="1" i="0">
-                <a:solidFill>
-                  <a:srgbClr val="FFFFFF"/>
-                </a:solidFill>
-                <a:latin typeface="Calibri"/>
-              </a:rPr>
-              <a:t>SLM output</a:t>
-            </a:r>
-          </a:p>
-        </p:txBody>
-      </p:sp>
-      <p:sp>
-        <p:nvSpPr>
-          <p:cNvPr id="27" name="TextBox 26"/>
-          <p:cNvSpPr txBox="1"/>
-          <p:nvPr/>
-        </p:nvSpPr>
-        <p:spPr>
-          <a:xfrm>
-            <a:off x="1828800" y="5605272"/>
-            <a:ext cx="8961120" cy="320040"/>
-          </a:xfrm>
-          <a:prstGeom prst="rect">
-            <a:avLst/>
-          </a:prstGeom>
-          <a:noFill/>
-        </p:spPr>
-        <p:txBody>
-          <a:bodyPr wrap="square" anchor="t" lIns="0" rIns="0" tIns="0" bIns="0">
-            <a:spAutoFit/>
-          </a:bodyPr>
-          <a:lstStyle/>
-          <a:p>
-            <a:pPr algn="l"/>
-            <a:r>
-              <a:rPr sz="1200" b="0" i="0">
-                <a:solidFill>
-                  <a:srgbClr val="D5D5D5"/>
-                </a:solidFill>
-                <a:latin typeface="Calibri"/>
+                  <a:srgbClr val="CFD3DA"/>
+                </a:solidFill>
+                <a:latin typeface="Arial"/>
               </a:rPr>
               <a:t>Language only — never a source of authority</a:t>
             </a:r>
@@ -11224,12 +10939,10 @@
             <a:avLst/>
           </a:prstGeom>
           <a:solidFill>
-            <a:srgbClr val="14161C"/>
+            <a:srgbClr val="121419"/>
           </a:solidFill>
-          <a:ln w="12700">
-            <a:solidFill>
-              <a:srgbClr val="5300DB"/>
-            </a:solidFill>
+          <a:ln>
+            <a:noFill/>
           </a:ln>
           <a:effectLst/>
         </p:spPr>
@@ -11257,7 +10970,7 @@
                 <a:solidFill>
                   <a:srgbClr val="FFFFFF"/>
                 </a:solidFill>
-                <a:latin typeface="Calibri"/>
+                <a:latin typeface="Arial"/>
               </a:rPr>
               <a:t/>
             </a:r>
@@ -11290,9 +11003,9 @@
             <a:r>
               <a:rPr sz="1000" b="1" i="0">
                 <a:solidFill>
-                  <a:srgbClr val="5300DB"/>
-                </a:solidFill>
-                <a:latin typeface="Calibri"/>
+                  <a:srgbClr val="2E9BF0"/>
+                </a:solidFill>
+                <a:latin typeface="Arial"/>
               </a:rPr>
               <a:t>AI RUNTIME  ·  single LangGraph process  ·  agents = logical capabilities</a:t>
             </a:r>
@@ -11325,9 +11038,9 @@
             <a:r>
               <a:rPr sz="1000" b="1" i="0">
                 <a:solidFill>
-                  <a:srgbClr val="FE2579"/>
-                </a:solidFill>
-                <a:latin typeface="Calibri"/>
+                  <a:srgbClr val="C24DFF"/>
+                </a:solidFill>
+                <a:latin typeface="Arial"/>
               </a:rPr>
               <a:t>Guardrails at every boundary (input · context · prompt · tool · model · output)</a:t>
             </a:r>
@@ -11349,12 +11062,10 @@
             <a:avLst/>
           </a:prstGeom>
           <a:solidFill>
-            <a:srgbClr val="1E222B"/>
+            <a:srgbClr val="1B1F27"/>
           </a:solidFill>
-          <a:ln w="15875">
-            <a:solidFill>
-              <a:srgbClr val="2ACCFF"/>
-            </a:solidFill>
+          <a:ln>
+            <a:noFill/>
           </a:ln>
           <a:effectLst/>
         </p:spPr>
@@ -11382,7 +11093,7 @@
                 <a:solidFill>
                   <a:srgbClr val="FFFFFF"/>
                 </a:solidFill>
-                <a:latin typeface="Calibri"/>
+                <a:latin typeface="Arial"/>
               </a:rPr>
               <a:t>Chat UI</a:t>
             </a:r>
@@ -11404,12 +11115,10 @@
             <a:avLst/>
           </a:prstGeom>
           <a:solidFill>
-            <a:srgbClr val="1E222B"/>
+            <a:srgbClr val="1B1F27"/>
           </a:solidFill>
-          <a:ln w="15875">
-            <a:solidFill>
-              <a:srgbClr val="0283FF"/>
-            </a:solidFill>
+          <a:ln>
+            <a:noFill/>
           </a:ln>
           <a:effectLst/>
         </p:spPr>
@@ -11437,7 +11146,7 @@
                 <a:solidFill>
                   <a:srgbClr val="FFFFFF"/>
                 </a:solidFill>
-                <a:latin typeface="Calibri"/>
+                <a:latin typeface="Arial"/>
               </a:rPr>
               <a:t>APIM</a:t>
             </a:r>
@@ -11449,7 +11158,7 @@
                 <a:solidFill>
                   <a:srgbClr val="FFFFFF"/>
                 </a:solidFill>
-                <a:latin typeface="Calibri"/>
+                <a:latin typeface="Arial"/>
               </a:rPr>
               <a:t>authN / authZ</a:t>
             </a:r>
@@ -11472,7 +11181,7 @@
           </a:prstGeom>
           <a:ln w="19050">
             <a:solidFill>
-              <a:srgbClr val="D5D5D5"/>
+              <a:srgbClr val="8A909C"/>
             </a:solidFill>
             <a:tailEnd type="triangle" w="med" len="med"/>
           </a:ln>
@@ -11508,12 +11217,10 @@
             <a:avLst/>
           </a:prstGeom>
           <a:solidFill>
-            <a:srgbClr val="1E222B"/>
+            <a:srgbClr val="1B1F27"/>
           </a:solidFill>
-          <a:ln w="15875">
-            <a:solidFill>
-              <a:srgbClr val="2ACCFF"/>
-            </a:solidFill>
+          <a:ln>
+            <a:noFill/>
           </a:ln>
           <a:effectLst/>
         </p:spPr>
@@ -11541,7 +11248,7 @@
                 <a:solidFill>
                   <a:srgbClr val="FFFFFF"/>
                 </a:solidFill>
-                <a:latin typeface="Calibri"/>
+                <a:latin typeface="Arial"/>
               </a:rPr>
               <a:t>FastAPI</a:t>
             </a:r>
@@ -11553,7 +11260,7 @@
                 <a:solidFill>
                   <a:srgbClr val="FFFFFF"/>
                 </a:solidFill>
-                <a:latin typeface="Calibri"/>
+                <a:latin typeface="Arial"/>
               </a:rPr>
               <a:t>thin API</a:t>
             </a:r>
@@ -11576,7 +11283,7 @@
           </a:prstGeom>
           <a:ln w="19050">
             <a:solidFill>
-              <a:srgbClr val="D5D5D5"/>
+              <a:srgbClr val="8A909C"/>
             </a:solidFill>
             <a:tailEnd type="triangle" w="med" len="med"/>
           </a:ln>
@@ -11612,12 +11319,10 @@
             <a:avLst/>
           </a:prstGeom>
           <a:solidFill>
-            <a:srgbClr val="1E222B"/>
+            <a:srgbClr val="1B1F27"/>
           </a:solidFill>
-          <a:ln w="15875">
-            <a:solidFill>
-              <a:srgbClr val="FED038"/>
-            </a:solidFill>
+          <a:ln>
+            <a:noFill/>
           </a:ln>
           <a:effectLst/>
         </p:spPr>
@@ -11645,7 +11350,7 @@
                 <a:solidFill>
                   <a:srgbClr val="FFFFFF"/>
                 </a:solidFill>
-                <a:latin typeface="Calibri"/>
+                <a:latin typeface="Arial"/>
               </a:rPr>
               <a:t>Supervisor</a:t>
             </a:r>
@@ -11657,7 +11362,7 @@
                 <a:solidFill>
                   <a:srgbClr val="FFFFFF"/>
                 </a:solidFill>
-                <a:latin typeface="Calibri"/>
+                <a:latin typeface="Arial"/>
               </a:rPr>
               <a:t>intent routing</a:t>
             </a:r>
@@ -11680,7 +11385,7 @@
           </a:prstGeom>
           <a:ln w="19050">
             <a:solidFill>
-              <a:srgbClr val="D5D5D5"/>
+              <a:srgbClr val="8A909C"/>
             </a:solidFill>
             <a:tailEnd type="triangle" w="med" len="med"/>
           </a:ln>
@@ -11716,12 +11421,10 @@
             <a:avLst/>
           </a:prstGeom>
           <a:solidFill>
-            <a:srgbClr val="1E222B"/>
+            <a:srgbClr val="1B1F27"/>
           </a:solidFill>
-          <a:ln w="15875">
-            <a:solidFill>
-              <a:srgbClr val="48E84A"/>
-            </a:solidFill>
+          <a:ln>
+            <a:noFill/>
           </a:ln>
           <a:effectLst/>
         </p:spPr>
@@ -11749,7 +11452,7 @@
                 <a:solidFill>
                   <a:srgbClr val="FFFFFF"/>
                 </a:solidFill>
-                <a:latin typeface="Calibri"/>
+                <a:latin typeface="Arial"/>
               </a:rPr>
               <a:t>LangGraph</a:t>
             </a:r>
@@ -11761,7 +11464,7 @@
                 <a:solidFill>
                   <a:srgbClr val="FFFFFF"/>
                 </a:solidFill>
-                <a:latin typeface="Calibri"/>
+                <a:latin typeface="Arial"/>
               </a:rPr>
               <a:t>orchestration</a:t>
             </a:r>
@@ -11784,7 +11487,7 @@
           </a:prstGeom>
           <a:ln w="19050">
             <a:solidFill>
-              <a:srgbClr val="D5D5D5"/>
+              <a:srgbClr val="8A909C"/>
             </a:solidFill>
             <a:tailEnd type="triangle" w="med" len="med"/>
           </a:ln>
@@ -11821,7 +11524,7 @@
           </a:prstGeom>
           <a:ln w="22225">
             <a:solidFill>
-              <a:srgbClr val="48E84A"/>
+              <a:srgbClr val="2E9BF0"/>
             </a:solidFill>
             <a:tailEnd type="triangle" w="med" len="med"/>
           </a:ln>
@@ -11857,12 +11560,10 @@
             <a:avLst/>
           </a:prstGeom>
           <a:solidFill>
-            <a:srgbClr val="1E222B"/>
+            <a:srgbClr val="1B1F27"/>
           </a:solidFill>
-          <a:ln w="15875">
-            <a:solidFill>
-              <a:srgbClr val="FED038"/>
-            </a:solidFill>
+          <a:ln>
+            <a:noFill/>
           </a:ln>
           <a:effectLst/>
         </p:spPr>
@@ -11890,7 +11591,7 @@
                 <a:solidFill>
                   <a:srgbClr val="FFFFFF"/>
                 </a:solidFill>
-                <a:latin typeface="Calibri"/>
+                <a:latin typeface="Arial"/>
               </a:rPr>
               <a:t>Agents</a:t>
             </a:r>
@@ -11902,7 +11603,7 @@
                 <a:solidFill>
                   <a:srgbClr val="FFFFFF"/>
                 </a:solidFill>
-                <a:latin typeface="Calibri"/>
+                <a:latin typeface="Arial"/>
               </a:rPr>
               <a:t>(AffiliationAgent first)</a:t>
             </a:r>
@@ -11924,12 +11625,10 @@
             <a:avLst/>
           </a:prstGeom>
           <a:solidFill>
-            <a:srgbClr val="1E222B"/>
+            <a:srgbClr val="1B1F27"/>
           </a:solidFill>
-          <a:ln w="15875">
-            <a:solidFill>
-              <a:srgbClr val="2ACCFF"/>
-            </a:solidFill>
+          <a:ln>
+            <a:noFill/>
           </a:ln>
           <a:effectLst/>
         </p:spPr>
@@ -11957,7 +11656,7 @@
                 <a:solidFill>
                   <a:srgbClr val="FFFFFF"/>
                 </a:solidFill>
-                <a:latin typeface="Calibri"/>
+                <a:latin typeface="Arial"/>
               </a:rPr>
               <a:t>ERC</a:t>
             </a:r>
@@ -11969,7 +11668,7 @@
                 <a:solidFill>
                   <a:srgbClr val="FFFFFF"/>
                 </a:solidFill>
-                <a:latin typeface="Calibri"/>
+                <a:latin typeface="Arial"/>
               </a:rPr>
               <a:t>enterprise context</a:t>
             </a:r>
@@ -11991,12 +11690,10 @@
             <a:avLst/>
           </a:prstGeom>
           <a:solidFill>
-            <a:srgbClr val="1E222B"/>
+            <a:srgbClr val="1B1F27"/>
           </a:solidFill>
-          <a:ln w="15875">
-            <a:solidFill>
-              <a:srgbClr val="0283FF"/>
-            </a:solidFill>
+          <a:ln>
+            <a:noFill/>
           </a:ln>
           <a:effectLst/>
         </p:spPr>
@@ -12024,7 +11721,7 @@
                 <a:solidFill>
                   <a:srgbClr val="FFFFFF"/>
                 </a:solidFill>
-                <a:latin typeface="Calibri"/>
+                <a:latin typeface="Arial"/>
               </a:rPr>
               <a:t>Tools / MCP</a:t>
             </a:r>
@@ -12046,12 +11743,10 @@
             <a:avLst/>
           </a:prstGeom>
           <a:solidFill>
-            <a:srgbClr val="1E222B"/>
+            <a:srgbClr val="1B1F27"/>
           </a:solidFill>
-          <a:ln w="15875">
-            <a:solidFill>
-              <a:srgbClr val="48E84A"/>
-            </a:solidFill>
+          <a:ln>
+            <a:noFill/>
           </a:ln>
           <a:effectLst/>
         </p:spPr>
@@ -12079,7 +11774,7 @@
                 <a:solidFill>
                   <a:srgbClr val="FFFFFF"/>
                 </a:solidFill>
-                <a:latin typeface="Calibri"/>
+                <a:latin typeface="Arial"/>
               </a:rPr>
               <a:t>RAG</a:t>
             </a:r>
@@ -12091,7 +11786,7 @@
                 <a:solidFill>
                   <a:srgbClr val="FFFFFF"/>
                 </a:solidFill>
-                <a:latin typeface="Calibri"/>
+                <a:latin typeface="Arial"/>
               </a:rPr>
               <a:t>knowledge</a:t>
             </a:r>
@@ -12113,12 +11808,10 @@
             <a:avLst/>
           </a:prstGeom>
           <a:solidFill>
-            <a:srgbClr val="1E222B"/>
+            <a:srgbClr val="1B1F27"/>
           </a:solidFill>
-          <a:ln w="15875">
-            <a:solidFill>
-              <a:srgbClr val="FE2579"/>
-            </a:solidFill>
+          <a:ln>
+            <a:noFill/>
           </a:ln>
           <a:effectLst/>
         </p:spPr>
@@ -12146,7 +11839,7 @@
                 <a:solidFill>
                   <a:srgbClr val="FFFFFF"/>
                 </a:solidFill>
-                <a:latin typeface="Calibri"/>
+                <a:latin typeface="Arial"/>
               </a:rPr>
               <a:t>Memory / Cache</a:t>
             </a:r>
@@ -12158,7 +11851,7 @@
                 <a:solidFill>
                   <a:srgbClr val="FFFFFF"/>
                 </a:solidFill>
-                <a:latin typeface="Calibri"/>
+                <a:latin typeface="Arial"/>
               </a:rPr>
               <a:t>Redis</a:t>
             </a:r>
@@ -12180,12 +11873,10 @@
             <a:avLst/>
           </a:prstGeom>
           <a:solidFill>
-            <a:srgbClr val="1E222B"/>
+            <a:srgbClr val="1B1F27"/>
           </a:solidFill>
-          <a:ln w="15875">
-            <a:solidFill>
-              <a:srgbClr val="5300DB"/>
-            </a:solidFill>
+          <a:ln>
+            <a:noFill/>
           </a:ln>
           <a:effectLst/>
         </p:spPr>
@@ -12213,7 +11904,7 @@
                 <a:solidFill>
                   <a:srgbClr val="FFFFFF"/>
                 </a:solidFill>
-                <a:latin typeface="Calibri"/>
+                <a:latin typeface="Arial"/>
               </a:rPr>
               <a:t>SLM</a:t>
             </a:r>
@@ -12225,7 +11916,7 @@
                 <a:solidFill>
                   <a:srgbClr val="FFFFFF"/>
                 </a:solidFill>
-                <a:latin typeface="Calibri"/>
+                <a:latin typeface="Arial"/>
               </a:rPr>
               <a:t>HF → vLLM</a:t>
             </a:r>
@@ -12248,7 +11939,7 @@
           </a:prstGeom>
           <a:ln w="19050">
             <a:solidFill>
-              <a:srgbClr val="FED038"/>
+              <a:srgbClr val="8A909C"/>
             </a:solidFill>
             <a:tailEnd type="triangle" w="med" len="med"/>
           </a:ln>
@@ -12284,12 +11975,10 @@
             <a:avLst/>
           </a:prstGeom>
           <a:solidFill>
-            <a:srgbClr val="1E222B"/>
+            <a:srgbClr val="1B1F27"/>
           </a:solidFill>
-          <a:ln w="15875">
-            <a:solidFill>
-              <a:srgbClr val="0283FF"/>
-            </a:solidFill>
+          <a:ln>
+            <a:noFill/>
           </a:ln>
           <a:effectLst/>
         </p:spPr>
@@ -12317,7 +12006,7 @@
                 <a:solidFill>
                   <a:srgbClr val="FFFFFF"/>
                 </a:solidFill>
-                <a:latin typeface="Calibri"/>
+                <a:latin typeface="Arial"/>
               </a:rPr>
               <a:t>Enterprise APIs / Events  —  PFF System of Record (decides &amp; executes)</a:t>
             </a:r>
@@ -12339,12 +12028,10 @@
             <a:avLst/>
           </a:prstGeom>
           <a:solidFill>
-            <a:srgbClr val="1E222B"/>
+            <a:srgbClr val="1B1F27"/>
           </a:solidFill>
-          <a:ln w="15875">
-            <a:solidFill>
-              <a:srgbClr val="FE2579"/>
-            </a:solidFill>
+          <a:ln>
+            <a:noFill/>
           </a:ln>
           <a:effectLst/>
         </p:spPr>
@@ -12372,7 +12059,7 @@
                 <a:solidFill>
                   <a:srgbClr val="FFFFFF"/>
                 </a:solidFill>
-                <a:latin typeface="Calibri"/>
+                <a:latin typeface="Arial"/>
               </a:rPr>
               <a:t>Output</a:t>
             </a:r>
@@ -12384,7 +12071,7 @@
                 <a:solidFill>
                   <a:srgbClr val="FFFFFF"/>
                 </a:solidFill>
-                <a:latin typeface="Calibri"/>
+                <a:latin typeface="Arial"/>
               </a:rPr>
               <a:t>Guardrail</a:t>
             </a:r>
@@ -12406,12 +12093,10 @@
             <a:avLst/>
           </a:prstGeom>
           <a:solidFill>
-            <a:srgbClr val="1E222B"/>
+            <a:srgbClr val="1B1F27"/>
           </a:solidFill>
-          <a:ln w="15875">
-            <a:solidFill>
-              <a:srgbClr val="2ACCFF"/>
-            </a:solidFill>
+          <a:ln>
+            <a:noFill/>
           </a:ln>
           <a:effectLst/>
         </p:spPr>
@@ -12439,7 +12124,7 @@
                 <a:solidFill>
                   <a:srgbClr val="FFFFFF"/>
                 </a:solidFill>
-                <a:latin typeface="Calibri"/>
+                <a:latin typeface="Arial"/>
               </a:rPr>
               <a:t>Response</a:t>
             </a:r>
@@ -12462,7 +12147,7 @@
           </a:prstGeom>
           <a:ln w="19050">
             <a:solidFill>
-              <a:srgbClr val="0283FF"/>
+              <a:srgbClr val="8A909C"/>
             </a:solidFill>
             <a:tailEnd type="triangle" w="med" len="med"/>
           </a:ln>
@@ -12499,7 +12184,7 @@
           </a:prstGeom>
           <a:ln w="17780">
             <a:solidFill>
-              <a:srgbClr val="D5D5D5"/>
+              <a:srgbClr val="8A909C"/>
             </a:solidFill>
             <a:tailEnd type="triangle" w="med" len="med"/>
           </a:ln>
@@ -12536,7 +12221,7 @@
           </a:prstGeom>
           <a:ln w="17780">
             <a:solidFill>
-              <a:srgbClr val="D5D5D5"/>
+              <a:srgbClr val="8A909C"/>
             </a:solidFill>
             <a:tailEnd type="triangle" w="med" len="med"/>
           </a:ln>
@@ -12583,9 +12268,9 @@
             <a:r>
               <a:rPr sz="1100" b="1" i="0">
                 <a:solidFill>
-                  <a:srgbClr val="FED038"/>
-                </a:solidFill>
-                <a:latin typeface="Calibri"/>
+                  <a:srgbClr val="2E9BF0"/>
+                </a:solidFill>
+                <a:latin typeface="Arial"/>
               </a:rPr>
               <a:t>Authoritative-truth precedence:  Enterprise API / Event  ›  ERC  ›  Cache  ›  RAG  ›  SLM output</a:t>
             </a:r>
@@ -12646,12 +12331,10 @@
             <a:avLst/>
           </a:prstGeom>
           <a:solidFill>
-            <a:srgbClr val="14161C"/>
+            <a:srgbClr val="1B1F27"/>
           </a:solidFill>
-          <a:ln w="15875">
-            <a:solidFill>
-              <a:srgbClr val="2ACCFF"/>
-            </a:solidFill>
+          <a:ln>
+            <a:noFill/>
           </a:ln>
           <a:effectLst/>
         </p:spPr>
@@ -12679,7 +12362,7 @@
                 <a:solidFill>
                   <a:srgbClr val="FFFFFF"/>
                 </a:solidFill>
-                <a:latin typeface="Calibri"/>
+                <a:latin typeface="Arial"/>
               </a:rPr>
               <a:t/>
             </a:r>
@@ -12712,9 +12395,9 @@
             <a:r>
               <a:rPr sz="1800" b="1" i="0">
                 <a:solidFill>
-                  <a:srgbClr val="2ACCFF"/>
-                </a:solidFill>
-                <a:latin typeface="Calibri"/>
+                  <a:srgbClr val="2E9BF0"/>
+                </a:solidFill>
+                <a:latin typeface="Arial"/>
               </a:rPr>
               <a:t>Conversation State</a:t>
             </a:r>
@@ -12747,9 +12430,9 @@
             <a:r>
               <a:rPr sz="1300" b="0" i="0">
                 <a:solidFill>
-                  <a:srgbClr val="D5D5D5"/>
-                </a:solidFill>
-                <a:latin typeface="Calibri"/>
+                  <a:srgbClr val="CFD3DA"/>
+                </a:solidFill>
+                <a:latin typeface="Arial"/>
               </a:rPr>
               <a:t>turns, messages, intent — per conversation</a:t>
             </a:r>
@@ -12771,12 +12454,10 @@
             <a:avLst/>
           </a:prstGeom>
           <a:solidFill>
-            <a:srgbClr val="14161C"/>
+            <a:srgbClr val="1B1F27"/>
           </a:solidFill>
-          <a:ln w="15875">
-            <a:solidFill>
-              <a:srgbClr val="0283FF"/>
-            </a:solidFill>
+          <a:ln>
+            <a:noFill/>
           </a:ln>
           <a:effectLst/>
         </p:spPr>
@@ -12804,7 +12485,7 @@
                 <a:solidFill>
                   <a:srgbClr val="FFFFFF"/>
                 </a:solidFill>
-                <a:latin typeface="Calibri"/>
+                <a:latin typeface="Arial"/>
               </a:rPr>
               <a:t/>
             </a:r>
@@ -12837,9 +12518,9 @@
             <a:r>
               <a:rPr sz="1800" b="1" i="0">
                 <a:solidFill>
-                  <a:srgbClr val="0283FF"/>
-                </a:solidFill>
-                <a:latin typeface="Calibri"/>
+                  <a:srgbClr val="C24DFF"/>
+                </a:solidFill>
+                <a:latin typeface="Arial"/>
               </a:rPr>
               <a:t>Session State</a:t>
             </a:r>
@@ -12872,9 +12553,9 @@
             <a:r>
               <a:rPr sz="1300" b="0" i="0">
                 <a:solidFill>
-                  <a:srgbClr val="D5D5D5"/>
-                </a:solidFill>
-                <a:latin typeface="Calibri"/>
+                  <a:srgbClr val="CFD3DA"/>
+                </a:solidFill>
+                <a:latin typeface="Arial"/>
               </a:rPr>
               <a:t>auth context, correlation, ttl — per session</a:t>
             </a:r>
@@ -12896,12 +12577,10 @@
             <a:avLst/>
           </a:prstGeom>
           <a:solidFill>
-            <a:srgbClr val="14161C"/>
+            <a:srgbClr val="1B1F27"/>
           </a:solidFill>
-          <a:ln w="15875">
-            <a:solidFill>
-              <a:srgbClr val="48E84A"/>
-            </a:solidFill>
+          <a:ln>
+            <a:noFill/>
           </a:ln>
           <a:effectLst/>
         </p:spPr>
@@ -12929,7 +12608,7 @@
                 <a:solidFill>
                   <a:srgbClr val="FFFFFF"/>
                 </a:solidFill>
-                <a:latin typeface="Calibri"/>
+                <a:latin typeface="Arial"/>
               </a:rPr>
               <a:t/>
             </a:r>
@@ -12962,9 +12641,9 @@
             <a:r>
               <a:rPr sz="1800" b="1" i="0">
                 <a:solidFill>
-                  <a:srgbClr val="48E84A"/>
-                </a:solidFill>
-                <a:latin typeface="Calibri"/>
+                  <a:srgbClr val="2E9BF0"/>
+                </a:solidFill>
+                <a:latin typeface="Arial"/>
               </a:rPr>
               <a:t>Workflow / Agent State</a:t>
             </a:r>
@@ -12997,9 +12676,9 @@
             <a:r>
               <a:rPr sz="1300" b="0" i="0">
                 <a:solidFill>
-                  <a:srgbClr val="D5D5D5"/>
-                </a:solidFill>
-                <a:latin typeface="Calibri"/>
+                  <a:srgbClr val="CFD3DA"/>
+                </a:solidFill>
+                <a:latin typeface="Arial"/>
               </a:rPr>
               <a:t>graph state, steps, HIL — per workflow run</a:t>
             </a:r>
@@ -13021,12 +12700,10 @@
             <a:avLst/>
           </a:prstGeom>
           <a:solidFill>
-            <a:srgbClr val="14161C"/>
+            <a:srgbClr val="1B1F27"/>
           </a:solidFill>
-          <a:ln w="15875">
-            <a:solidFill>
-              <a:srgbClr val="FE2579"/>
-            </a:solidFill>
+          <a:ln>
+            <a:noFill/>
           </a:ln>
           <a:effectLst/>
         </p:spPr>
@@ -13054,7 +12731,7 @@
                 <a:solidFill>
                   <a:srgbClr val="FFFFFF"/>
                 </a:solidFill>
-                <a:latin typeface="Calibri"/>
+                <a:latin typeface="Arial"/>
               </a:rPr>
               <a:t/>
             </a:r>
@@ -13087,9 +12764,9 @@
             <a:r>
               <a:rPr sz="1800" b="1" i="0">
                 <a:solidFill>
-                  <a:srgbClr val="FE2579"/>
-                </a:solidFill>
-                <a:latin typeface="Calibri"/>
+                  <a:srgbClr val="C24DFF"/>
+                </a:solidFill>
+                <a:latin typeface="Arial"/>
               </a:rPr>
               <a:t>Enterprise Business State</a:t>
             </a:r>
@@ -13122,9 +12799,9 @@
             <a:r>
               <a:rPr sz="1300" b="0" i="0">
                 <a:solidFill>
-                  <a:srgbClr val="D5D5D5"/>
-                </a:solidFill>
-                <a:latin typeface="Calibri"/>
+                  <a:srgbClr val="CFD3DA"/>
+                </a:solidFill>
+                <a:latin typeface="Arial"/>
               </a:rPr>
               <a:t>system-of-record truth — owned by PFF</a:t>
             </a:r>
@@ -13200,18 +12877,18 @@
             <a:r>
               <a:rPr sz="1700" b="1">
                 <a:solidFill>
-                  <a:srgbClr val="2ACCFF"/>
-                </a:solidFill>
-                <a:latin typeface="Calibri"/>
-              </a:rPr>
-              <a:t>▸ </a:t>
+                  <a:srgbClr val="2E9BF0"/>
+                </a:solidFill>
+                <a:latin typeface="Arial"/>
+              </a:rPr>
+              <a:t>•  </a:t>
             </a:r>
             <a:r>
               <a:rPr sz="1700">
                 <a:solidFill>
                   <a:srgbClr val="FFFFFF"/>
                 </a:solidFill>
-                <a:latin typeface="Calibri"/>
+                <a:latin typeface="Arial"/>
               </a:rPr>
               <a:t>One AI runtime; agents are logical capabilities inside it — not one microservice per agent.</a:t>
             </a:r>
@@ -13225,18 +12902,18 @@
             <a:r>
               <a:rPr sz="1700" b="1">
                 <a:solidFill>
-                  <a:srgbClr val="2ACCFF"/>
-                </a:solidFill>
-                <a:latin typeface="Calibri"/>
-              </a:rPr>
-              <a:t>▸ </a:t>
+                  <a:srgbClr val="2E9BF0"/>
+                </a:solidFill>
+                <a:latin typeface="Arial"/>
+              </a:rPr>
+              <a:t>•  </a:t>
             </a:r>
             <a:r>
               <a:rPr sz="1700">
                 <a:solidFill>
                   <a:srgbClr val="FFFFFF"/>
                 </a:solidFill>
-                <a:latin typeface="Calibri"/>
+                <a:latin typeface="Arial"/>
               </a:rPr>
               <a:t>AffiliationAgent is the only agent built in the first pass (Phase 23).</a:t>
             </a:r>
@@ -13250,18 +12927,18 @@
             <a:r>
               <a:rPr sz="1700" b="1">
                 <a:solidFill>
-                  <a:srgbClr val="2ACCFF"/>
-                </a:solidFill>
-                <a:latin typeface="Calibri"/>
-              </a:rPr>
-              <a:t>▸ </a:t>
+                  <a:srgbClr val="2E9BF0"/>
+                </a:solidFill>
+                <a:latin typeface="Arial"/>
+              </a:rPr>
+              <a:t>•  </a:t>
             </a:r>
             <a:r>
               <a:rPr sz="1700">
                 <a:solidFill>
                   <a:srgbClr val="FFFFFF"/>
                 </a:solidFill>
-                <a:latin typeface="Calibri"/>
+                <a:latin typeface="Arial"/>
               </a:rPr>
               <a:t>The wider agent catalogue (registration, discipline, officials, competitions…) is a real product decision, deliberately deferred — not invented.</a:t>
             </a:r>
@@ -13275,18 +12952,18 @@
             <a:r>
               <a:rPr sz="1700" b="1">
                 <a:solidFill>
-                  <a:srgbClr val="2ACCFF"/>
-                </a:solidFill>
-                <a:latin typeface="Calibri"/>
-              </a:rPr>
-              <a:t>▸ </a:t>
+                  <a:srgbClr val="2E9BF0"/>
+                </a:solidFill>
+                <a:latin typeface="Arial"/>
+              </a:rPr>
+              <a:t>•  </a:t>
             </a:r>
             <a:r>
               <a:rPr sz="1700">
                 <a:solidFill>
                   <a:srgbClr val="FFFFFF"/>
                 </a:solidFill>
-                <a:latin typeface="Calibri"/>
+                <a:latin typeface="Arial"/>
               </a:rPr>
               <a:t>Everything is a versioned software artifact: prompts, models, agents, workflows, RAG indexes, guardrails — released as immutable bundles.</a:t>
             </a:r>
@@ -13382,9 +13059,9 @@
             <a:r>
               <a:rPr sz="900" b="0" i="0">
                 <a:solidFill>
-                  <a:srgbClr val="D5D5D5"/>
-                </a:solidFill>
-                <a:latin typeface="Calibri"/>
+                  <a:srgbClr val="CFD3DA"/>
+                </a:solidFill>
+                <a:latin typeface="Arial"/>
               </a:rPr>
               <a:t>Python</a:t>
             </a:r>
@@ -13441,9 +13118,9 @@
             <a:r>
               <a:rPr sz="900" b="0" i="0">
                 <a:solidFill>
-                  <a:srgbClr val="D5D5D5"/>
-                </a:solidFill>
-                <a:latin typeface="Calibri"/>
+                  <a:srgbClr val="CFD3DA"/>
+                </a:solidFill>
+                <a:latin typeface="Arial"/>
               </a:rPr>
               <a:t>FastAPI</a:t>
             </a:r>
@@ -13500,9 +13177,9 @@
             <a:r>
               <a:rPr sz="900" b="0" i="0">
                 <a:solidFill>
-                  <a:srgbClr val="D5D5D5"/>
-                </a:solidFill>
-                <a:latin typeface="Calibri"/>
+                  <a:srgbClr val="CFD3DA"/>
+                </a:solidFill>
+                <a:latin typeface="Arial"/>
               </a:rPr>
               <a:t>LangGraph</a:t>
             </a:r>
@@ -13559,9 +13236,9 @@
             <a:r>
               <a:rPr sz="900" b="0" i="0">
                 <a:solidFill>
-                  <a:srgbClr val="D5D5D5"/>
-                </a:solidFill>
-                <a:latin typeface="Calibri"/>
+                  <a:srgbClr val="CFD3DA"/>
+                </a:solidFill>
+                <a:latin typeface="Arial"/>
               </a:rPr>
               <a:t>HF SLM</a:t>
             </a:r>
@@ -13618,9 +13295,9 @@
             <a:r>
               <a:rPr sz="900" b="0" i="0">
                 <a:solidFill>
-                  <a:srgbClr val="D5D5D5"/>
-                </a:solidFill>
-                <a:latin typeface="Calibri"/>
+                  <a:srgbClr val="CFD3DA"/>
+                </a:solidFill>
+                <a:latin typeface="Arial"/>
               </a:rPr>
               <a:t>vLLM</a:t>
             </a:r>
@@ -13677,9 +13354,9 @@
             <a:r>
               <a:rPr sz="900" b="0" i="0">
                 <a:solidFill>
-                  <a:srgbClr val="D5D5D5"/>
-                </a:solidFill>
-                <a:latin typeface="Calibri"/>
+                  <a:srgbClr val="CFD3DA"/>
+                </a:solidFill>
+                <a:latin typeface="Arial"/>
               </a:rPr>
               <a:t>AI Search</a:t>
             </a:r>
@@ -13736,9 +13413,9 @@
             <a:r>
               <a:rPr sz="900" b="0" i="0">
                 <a:solidFill>
-                  <a:srgbClr val="D5D5D5"/>
-                </a:solidFill>
-                <a:latin typeface="Calibri"/>
+                  <a:srgbClr val="CFD3DA"/>
+                </a:solidFill>
+                <a:latin typeface="Arial"/>
               </a:rPr>
               <a:t>AKS</a:t>
             </a:r>
@@ -13795,9 +13472,9 @@
             <a:r>
               <a:rPr sz="900" b="0" i="0">
                 <a:solidFill>
-                  <a:srgbClr val="D5D5D5"/>
-                </a:solidFill>
-                <a:latin typeface="Calibri"/>
+                  <a:srgbClr val="CFD3DA"/>
+                </a:solidFill>
+                <a:latin typeface="Arial"/>
               </a:rPr>
               <a:t>APIM</a:t>
             </a:r>
@@ -13854,9 +13531,9 @@
             <a:r>
               <a:rPr sz="900" b="0" i="0">
                 <a:solidFill>
-                  <a:srgbClr val="D5D5D5"/>
-                </a:solidFill>
-                <a:latin typeface="Calibri"/>
+                  <a:srgbClr val="CFD3DA"/>
+                </a:solidFill>
+                <a:latin typeface="Arial"/>
               </a:rPr>
               <a:t>Service Bus</a:t>
             </a:r>
@@ -13913,9 +13590,9 @@
             <a:r>
               <a:rPr sz="900" b="0" i="0">
                 <a:solidFill>
-                  <a:srgbClr val="D5D5D5"/>
-                </a:solidFill>
-                <a:latin typeface="Calibri"/>
+                  <a:srgbClr val="CFD3DA"/>
+                </a:solidFill>
+                <a:latin typeface="Arial"/>
               </a:rPr>
               <a:t>Redis</a:t>
             </a:r>
@@ -13972,9 +13649,9 @@
             <a:r>
               <a:rPr sz="900" b="0" i="0">
                 <a:solidFill>
-                  <a:srgbClr val="D5D5D5"/>
-                </a:solidFill>
-                <a:latin typeface="Calibri"/>
+                  <a:srgbClr val="CFD3DA"/>
+                </a:solidFill>
+                <a:latin typeface="Arial"/>
               </a:rPr>
               <a:t>Key Vault</a:t>
             </a:r>
@@ -14031,9 +13708,9 @@
             <a:r>
               <a:rPr sz="900" b="0" i="0">
                 <a:solidFill>
-                  <a:srgbClr val="D5D5D5"/>
-                </a:solidFill>
-                <a:latin typeface="Calibri"/>
+                  <a:srgbClr val="CFD3DA"/>
+                </a:solidFill>
+                <a:latin typeface="Arial"/>
               </a:rPr>
               <a:t>Langfuse</a:t>
             </a:r>

</xml_diff>

<commit_message>
fix(ppt): visible tile borders, concentric numbered circles, bordered precedence items
- fa.py: card borders made clearly visible (#A9BACE, 1.25pt); add num_circle
  helper that centres the number inside the circle (anchor middle)
- deck_00: precedence slide rebuilt as bordered item cards with centred circles
  and chevrons; four-state tiles get an accent tab + wider gaps so they read as
  separate cards, not merged

Co-Authored-By: Claude Opus 4.8 <noreply@anthropic.com>
Claude-Session: https://claude.ai/code/session_01NZAFLWCrwekDfmM1HS83Mp
</commit_message>
<xml_diff>
--- a/docs/PPT/00-overview.pptx
+++ b/docs/PPT/00-overview.pptx
@@ -3087,9 +3087,9 @@
           <a:solidFill>
             <a:srgbClr val="F3F6FA"/>
           </a:solidFill>
-          <a:ln w="12700">
+          <a:ln w="15875">
             <a:solidFill>
-              <a:srgbClr val="D9E1EA"/>
+              <a:srgbClr val="A9BACE"/>
             </a:solidFill>
           </a:ln>
           <a:effectLst/>
@@ -3203,9 +3203,9 @@
           <a:solidFill>
             <a:srgbClr val="F3F6FA"/>
           </a:solidFill>
-          <a:ln w="12700">
+          <a:ln w="15875">
             <a:solidFill>
-              <a:srgbClr val="D9E1EA"/>
+              <a:srgbClr val="A9BACE"/>
             </a:solidFill>
           </a:ln>
           <a:effectLst/>
@@ -3319,9 +3319,9 @@
           <a:solidFill>
             <a:srgbClr val="F3F6FA"/>
           </a:solidFill>
-          <a:ln w="12700">
+          <a:ln w="15875">
             <a:solidFill>
-              <a:srgbClr val="D9E1EA"/>
+              <a:srgbClr val="A9BACE"/>
             </a:solidFill>
           </a:ln>
           <a:effectLst/>
@@ -3435,9 +3435,9 @@
           <a:solidFill>
             <a:srgbClr val="F3F6FA"/>
           </a:solidFill>
-          <a:ln w="12700">
+          <a:ln w="15875">
             <a:solidFill>
-              <a:srgbClr val="D9E1EA"/>
+              <a:srgbClr val="A9BACE"/>
             </a:solidFill>
           </a:ln>
           <a:effectLst/>
@@ -6094,14 +6094,60 @@
       </p:sp>
       <p:sp>
         <p:nvSpPr>
-          <p:cNvPr id="12" name="Oval 11"/>
+          <p:cNvPr id="12" name="Rounded Rectangle 11"/>
           <p:cNvSpPr/>
           <p:nvPr/>
         </p:nvSpPr>
         <p:spPr>
           <a:xfrm>
-            <a:off x="1874519" y="1810512"/>
-            <a:ext cx="512064" cy="512064"/>
+            <a:off x="1874519" y="1737360"/>
+            <a:ext cx="9921240" cy="713232"/>
+          </a:xfrm>
+          <a:prstGeom prst="roundRect">
+            <a:avLst/>
+          </a:prstGeom>
+          <a:solidFill>
+            <a:srgbClr val="F3F6FA"/>
+          </a:solidFill>
+          <a:ln w="15875">
+            <a:solidFill>
+              <a:srgbClr val="A9BACE"/>
+            </a:solidFill>
+          </a:ln>
+          <a:effectLst/>
+        </p:spPr>
+        <p:style>
+          <a:lnRef idx="1">
+            <a:schemeClr val="accent1"/>
+          </a:lnRef>
+          <a:fillRef idx="3">
+            <a:schemeClr val="accent1"/>
+          </a:fillRef>
+          <a:effectRef idx="2">
+            <a:schemeClr val="accent1"/>
+          </a:effectRef>
+          <a:fontRef idx="minor">
+            <a:schemeClr val="lt1"/>
+          </a:fontRef>
+        </p:style>
+        <p:txBody>
+          <a:bodyPr rtlCol="0" anchor="ctr"/>
+          <a:lstStyle/>
+          <a:p>
+            <a:pPr algn="ctr"/>
+          </a:p>
+        </p:txBody>
+      </p:sp>
+      <p:sp>
+        <p:nvSpPr>
+          <p:cNvPr id="13" name="Oval 12"/>
+          <p:cNvSpPr/>
+          <p:nvPr/>
+        </p:nvSpPr>
+        <p:spPr>
+          <a:xfrm>
+            <a:off x="2148839" y="1865376"/>
+            <a:ext cx="457200" cy="457200"/>
           </a:xfrm>
           <a:prstGeom prst="ellipse">
             <a:avLst/>
@@ -6138,14 +6184,49 @@
       </p:sp>
       <p:sp>
         <p:nvSpPr>
-          <p:cNvPr id="13" name="TextBox 12"/>
-          <p:cNvSpPr txBox="1"/>
-          <p:nvPr/>
-        </p:nvSpPr>
-        <p:spPr>
-          <a:xfrm>
-            <a:off x="1874519" y="1865376"/>
-            <a:ext cx="512064" cy="411480"/>
+          <p:cNvPr id="14" name="TextBox 13"/>
+          <p:cNvSpPr txBox="1"/>
+          <p:nvPr/>
+        </p:nvSpPr>
+        <p:spPr>
+          <a:xfrm>
+            <a:off x="2148839" y="1865376"/>
+            <a:ext cx="457200" cy="457200"/>
+          </a:xfrm>
+          <a:prstGeom prst="rect">
+            <a:avLst/>
+          </a:prstGeom>
+          <a:noFill/>
+        </p:spPr>
+        <p:txBody>
+          <a:bodyPr wrap="square" anchor="ctr" lIns="0" rIns="0" tIns="0" bIns="0">
+            <a:spAutoFit/>
+          </a:bodyPr>
+          <a:lstStyle/>
+          <a:p>
+            <a:pPr algn="ctr"/>
+            <a:r>
+              <a:rPr sz="1800" b="1" i="0">
+                <a:solidFill>
+                  <a:srgbClr val="FFFFFF"/>
+                </a:solidFill>
+                <a:latin typeface="Cambria"/>
+              </a:rPr>
+              <a:t>1</a:t>
+            </a:r>
+          </a:p>
+        </p:txBody>
+      </p:sp>
+      <p:sp>
+        <p:nvSpPr>
+          <p:cNvPr id="15" name="TextBox 14"/>
+          <p:cNvSpPr txBox="1"/>
+          <p:nvPr/>
+        </p:nvSpPr>
+        <p:spPr>
+          <a:xfrm>
+            <a:off x="2880360" y="1847088"/>
+            <a:ext cx="5486400" cy="310896"/>
           </a:xfrm>
           <a:prstGeom prst="rect">
             <a:avLst/>
@@ -6158,29 +6239,29 @@
           </a:bodyPr>
           <a:lstStyle/>
           <a:p>
-            <a:pPr algn="ctr"/>
-            <a:r>
-              <a:rPr sz="1800" b="1" i="0">
-                <a:solidFill>
-                  <a:srgbClr val="FFFFFF"/>
+            <a:pPr algn="l"/>
+            <a:r>
+              <a:rPr sz="1500" b="1" i="0">
+                <a:solidFill>
+                  <a:srgbClr val="13294B"/>
                 </a:solidFill>
                 <a:latin typeface="Cambria"/>
               </a:rPr>
-              <a:t>1</a:t>
-            </a:r>
-          </a:p>
-        </p:txBody>
-      </p:sp>
-      <p:sp>
-        <p:nvSpPr>
-          <p:cNvPr id="14" name="TextBox 13"/>
-          <p:cNvSpPr txBox="1"/>
-          <p:nvPr/>
-        </p:nvSpPr>
-        <p:spPr>
-          <a:xfrm>
-            <a:off x="2651760" y="1746504"/>
-            <a:ext cx="5029200" cy="365760"/>
+              <a:t>Enterprise API / Event</a:t>
+            </a:r>
+          </a:p>
+        </p:txBody>
+      </p:sp>
+      <p:sp>
+        <p:nvSpPr>
+          <p:cNvPr id="16" name="TextBox 15"/>
+          <p:cNvSpPr txBox="1"/>
+          <p:nvPr/>
+        </p:nvSpPr>
+        <p:spPr>
+          <a:xfrm>
+            <a:off x="2880360" y="2139696"/>
+            <a:ext cx="8412480" cy="274320"/>
           </a:xfrm>
           <a:prstGeom prst="rect">
             <a:avLst/>
@@ -6195,27 +6276,27 @@
           <a:p>
             <a:pPr algn="l"/>
             <a:r>
-              <a:rPr sz="1700" b="1" i="0">
-                <a:solidFill>
-                  <a:srgbClr val="13294B"/>
-                </a:solidFill>
-                <a:latin typeface="Cambria"/>
-              </a:rPr>
-              <a:t>Enterprise API / Event</a:t>
-            </a:r>
-          </a:p>
-        </p:txBody>
-      </p:sp>
-      <p:sp>
-        <p:nvSpPr>
-          <p:cNvPr id="15" name="TextBox 14"/>
-          <p:cNvSpPr txBox="1"/>
-          <p:nvPr/>
-        </p:nvSpPr>
-        <p:spPr>
-          <a:xfrm>
-            <a:off x="2651760" y="2112264"/>
-            <a:ext cx="8595360" cy="320040"/>
+              <a:rPr sz="1150" b="0" i="0">
+                <a:solidFill>
+                  <a:srgbClr val="5C6B7A"/>
+                </a:solidFill>
+                <a:latin typeface="Calibri"/>
+              </a:rPr>
+              <a:t>System of record — decides &amp; executes</a:t>
+            </a:r>
+          </a:p>
+        </p:txBody>
+      </p:sp>
+      <p:sp>
+        <p:nvSpPr>
+          <p:cNvPr id="17" name="TextBox 16"/>
+          <p:cNvSpPr txBox="1"/>
+          <p:nvPr/>
+        </p:nvSpPr>
+        <p:spPr>
+          <a:xfrm>
+            <a:off x="2240279" y="2432303"/>
+            <a:ext cx="274320" cy="201168"/>
           </a:xfrm>
           <a:prstGeom prst="rect">
             <a:avLst/>
@@ -6228,64 +6309,75 @@
           </a:bodyPr>
           <a:lstStyle/>
           <a:p>
-            <a:pPr algn="l"/>
-            <a:r>
-              <a:rPr sz="1200" b="0" i="0">
-                <a:solidFill>
-                  <a:srgbClr val="5C6B7A"/>
-                </a:solidFill>
-                <a:latin typeface="Calibri"/>
-              </a:rPr>
-              <a:t>System of record — decides &amp; executes</a:t>
-            </a:r>
-          </a:p>
-        </p:txBody>
-      </p:sp>
-      <p:sp>
-        <p:nvSpPr>
-          <p:cNvPr id="16" name="TextBox 15"/>
-          <p:cNvSpPr txBox="1"/>
-          <p:nvPr/>
-        </p:nvSpPr>
-        <p:spPr>
-          <a:xfrm>
-            <a:off x="2651760" y="2414016"/>
-            <a:ext cx="7315200" cy="256032"/>
-          </a:xfrm>
-          <a:prstGeom prst="rect">
-            <a:avLst/>
-          </a:prstGeom>
-          <a:noFill/>
-        </p:spPr>
-        <p:txBody>
-          <a:bodyPr wrap="square" anchor="t" lIns="0" rIns="0" tIns="0" bIns="0">
-            <a:spAutoFit/>
-          </a:bodyPr>
-          <a:lstStyle/>
-          <a:p>
-            <a:pPr algn="l"/>
-            <a:r>
-              <a:rPr sz="900" b="0" i="0">
-                <a:solidFill>
-                  <a:srgbClr val="8FA6C4"/>
-                </a:solidFill>
-                <a:latin typeface="Calibri"/>
-              </a:rPr>
-              <a:t>▼  higher source wins on conflict — always</a:t>
-            </a:r>
-          </a:p>
-        </p:txBody>
-      </p:sp>
-      <p:sp>
-        <p:nvSpPr>
-          <p:cNvPr id="17" name="Oval 16"/>
+            <a:pPr algn="ctr"/>
+            <a:r>
+              <a:rPr sz="1100" b="1" i="0">
+                <a:solidFill>
+                  <a:srgbClr val="2E75B6"/>
+                </a:solidFill>
+                <a:latin typeface="Calibri"/>
+              </a:rPr>
+              <a:t>▼</a:t>
+            </a:r>
+          </a:p>
+        </p:txBody>
+      </p:sp>
+      <p:sp>
+        <p:nvSpPr>
+          <p:cNvPr id="18" name="Rounded Rectangle 17"/>
           <p:cNvSpPr/>
           <p:nvPr/>
         </p:nvSpPr>
         <p:spPr>
           <a:xfrm>
-            <a:off x="1874519" y="2688336"/>
-            <a:ext cx="512064" cy="512064"/>
+            <a:off x="1874519" y="2615184"/>
+            <a:ext cx="9921240" cy="713232"/>
+          </a:xfrm>
+          <a:prstGeom prst="roundRect">
+            <a:avLst/>
+          </a:prstGeom>
+          <a:solidFill>
+            <a:srgbClr val="F3F6FA"/>
+          </a:solidFill>
+          <a:ln w="15875">
+            <a:solidFill>
+              <a:srgbClr val="A9BACE"/>
+            </a:solidFill>
+          </a:ln>
+          <a:effectLst/>
+        </p:spPr>
+        <p:style>
+          <a:lnRef idx="1">
+            <a:schemeClr val="accent1"/>
+          </a:lnRef>
+          <a:fillRef idx="3">
+            <a:schemeClr val="accent1"/>
+          </a:fillRef>
+          <a:effectRef idx="2">
+            <a:schemeClr val="accent1"/>
+          </a:effectRef>
+          <a:fontRef idx="minor">
+            <a:schemeClr val="lt1"/>
+          </a:fontRef>
+        </p:style>
+        <p:txBody>
+          <a:bodyPr rtlCol="0" anchor="ctr"/>
+          <a:lstStyle/>
+          <a:p>
+            <a:pPr algn="ctr"/>
+          </a:p>
+        </p:txBody>
+      </p:sp>
+      <p:sp>
+        <p:nvSpPr>
+          <p:cNvPr id="19" name="Oval 18"/>
+          <p:cNvSpPr/>
+          <p:nvPr/>
+        </p:nvSpPr>
+        <p:spPr>
+          <a:xfrm>
+            <a:off x="2148839" y="2743200"/>
+            <a:ext cx="457200" cy="457200"/>
           </a:xfrm>
           <a:prstGeom prst="ellipse">
             <a:avLst/>
@@ -6322,14 +6414,49 @@
       </p:sp>
       <p:sp>
         <p:nvSpPr>
-          <p:cNvPr id="18" name="TextBox 17"/>
-          <p:cNvSpPr txBox="1"/>
-          <p:nvPr/>
-        </p:nvSpPr>
-        <p:spPr>
-          <a:xfrm>
-            <a:off x="1874519" y="2743200"/>
-            <a:ext cx="512064" cy="411480"/>
+          <p:cNvPr id="20" name="TextBox 19"/>
+          <p:cNvSpPr txBox="1"/>
+          <p:nvPr/>
+        </p:nvSpPr>
+        <p:spPr>
+          <a:xfrm>
+            <a:off x="2148839" y="2743200"/>
+            <a:ext cx="457200" cy="457200"/>
+          </a:xfrm>
+          <a:prstGeom prst="rect">
+            <a:avLst/>
+          </a:prstGeom>
+          <a:noFill/>
+        </p:spPr>
+        <p:txBody>
+          <a:bodyPr wrap="square" anchor="ctr" lIns="0" rIns="0" tIns="0" bIns="0">
+            <a:spAutoFit/>
+          </a:bodyPr>
+          <a:lstStyle/>
+          <a:p>
+            <a:pPr algn="ctr"/>
+            <a:r>
+              <a:rPr sz="1800" b="1" i="0">
+                <a:solidFill>
+                  <a:srgbClr val="FFFFFF"/>
+                </a:solidFill>
+                <a:latin typeface="Cambria"/>
+              </a:rPr>
+              <a:t>2</a:t>
+            </a:r>
+          </a:p>
+        </p:txBody>
+      </p:sp>
+      <p:sp>
+        <p:nvSpPr>
+          <p:cNvPr id="21" name="TextBox 20"/>
+          <p:cNvSpPr txBox="1"/>
+          <p:nvPr/>
+        </p:nvSpPr>
+        <p:spPr>
+          <a:xfrm>
+            <a:off x="2880360" y="2724912"/>
+            <a:ext cx="5486400" cy="310896"/>
           </a:xfrm>
           <a:prstGeom prst="rect">
             <a:avLst/>
@@ -6342,29 +6469,29 @@
           </a:bodyPr>
           <a:lstStyle/>
           <a:p>
-            <a:pPr algn="ctr"/>
-            <a:r>
-              <a:rPr sz="1800" b="1" i="0">
-                <a:solidFill>
-                  <a:srgbClr val="FFFFFF"/>
+            <a:pPr algn="l"/>
+            <a:r>
+              <a:rPr sz="1500" b="1" i="0">
+                <a:solidFill>
+                  <a:srgbClr val="13294B"/>
                 </a:solidFill>
                 <a:latin typeface="Cambria"/>
               </a:rPr>
-              <a:t>2</a:t>
-            </a:r>
-          </a:p>
-        </p:txBody>
-      </p:sp>
-      <p:sp>
-        <p:nvSpPr>
-          <p:cNvPr id="19" name="TextBox 18"/>
-          <p:cNvSpPr txBox="1"/>
-          <p:nvPr/>
-        </p:nvSpPr>
-        <p:spPr>
-          <a:xfrm>
-            <a:off x="2651760" y="2624328"/>
-            <a:ext cx="5029200" cy="365760"/>
+              <a:t>ERC</a:t>
+            </a:r>
+          </a:p>
+        </p:txBody>
+      </p:sp>
+      <p:sp>
+        <p:nvSpPr>
+          <p:cNvPr id="22" name="TextBox 21"/>
+          <p:cNvSpPr txBox="1"/>
+          <p:nvPr/>
+        </p:nvSpPr>
+        <p:spPr>
+          <a:xfrm>
+            <a:off x="2880360" y="3017520"/>
+            <a:ext cx="8412480" cy="274320"/>
           </a:xfrm>
           <a:prstGeom prst="rect">
             <a:avLst/>
@@ -6379,27 +6506,27 @@
           <a:p>
             <a:pPr algn="l"/>
             <a:r>
-              <a:rPr sz="1700" b="1" i="0">
-                <a:solidFill>
-                  <a:srgbClr val="13294B"/>
-                </a:solidFill>
-                <a:latin typeface="Cambria"/>
-              </a:rPr>
-              <a:t>ERC</a:t>
-            </a:r>
-          </a:p>
-        </p:txBody>
-      </p:sp>
-      <p:sp>
-        <p:nvSpPr>
-          <p:cNvPr id="20" name="TextBox 19"/>
-          <p:cNvSpPr txBox="1"/>
-          <p:nvPr/>
-        </p:nvSpPr>
-        <p:spPr>
-          <a:xfrm>
-            <a:off x="2651760" y="2990088"/>
-            <a:ext cx="8595360" cy="320040"/>
+              <a:rPr sz="1150" b="0" i="0">
+                <a:solidFill>
+                  <a:srgbClr val="5C6B7A"/>
+                </a:solidFill>
+                <a:latin typeface="Calibri"/>
+              </a:rPr>
+              <a:t>Enterprise Runtime Context — validated, provenanced</a:t>
+            </a:r>
+          </a:p>
+        </p:txBody>
+      </p:sp>
+      <p:sp>
+        <p:nvSpPr>
+          <p:cNvPr id="23" name="TextBox 22"/>
+          <p:cNvSpPr txBox="1"/>
+          <p:nvPr/>
+        </p:nvSpPr>
+        <p:spPr>
+          <a:xfrm>
+            <a:off x="2240279" y="3310127"/>
+            <a:ext cx="274320" cy="201168"/>
           </a:xfrm>
           <a:prstGeom prst="rect">
             <a:avLst/>
@@ -6412,64 +6539,75 @@
           </a:bodyPr>
           <a:lstStyle/>
           <a:p>
-            <a:pPr algn="l"/>
-            <a:r>
-              <a:rPr sz="1200" b="0" i="0">
-                <a:solidFill>
-                  <a:srgbClr val="5C6B7A"/>
-                </a:solidFill>
-                <a:latin typeface="Calibri"/>
-              </a:rPr>
-              <a:t>Enterprise Runtime Context — validated, provenanced</a:t>
-            </a:r>
-          </a:p>
-        </p:txBody>
-      </p:sp>
-      <p:sp>
-        <p:nvSpPr>
-          <p:cNvPr id="21" name="TextBox 20"/>
-          <p:cNvSpPr txBox="1"/>
-          <p:nvPr/>
-        </p:nvSpPr>
-        <p:spPr>
-          <a:xfrm>
-            <a:off x="2651760" y="3291840"/>
-            <a:ext cx="7315200" cy="256032"/>
-          </a:xfrm>
-          <a:prstGeom prst="rect">
-            <a:avLst/>
-          </a:prstGeom>
-          <a:noFill/>
-        </p:spPr>
-        <p:txBody>
-          <a:bodyPr wrap="square" anchor="t" lIns="0" rIns="0" tIns="0" bIns="0">
-            <a:spAutoFit/>
-          </a:bodyPr>
-          <a:lstStyle/>
-          <a:p>
-            <a:pPr algn="l"/>
-            <a:r>
-              <a:rPr sz="900" b="0" i="0">
-                <a:solidFill>
-                  <a:srgbClr val="8FA6C4"/>
-                </a:solidFill>
-                <a:latin typeface="Calibri"/>
-              </a:rPr>
-              <a:t>▼  higher source wins on conflict — always</a:t>
-            </a:r>
-          </a:p>
-        </p:txBody>
-      </p:sp>
-      <p:sp>
-        <p:nvSpPr>
-          <p:cNvPr id="22" name="Oval 21"/>
+            <a:pPr algn="ctr"/>
+            <a:r>
+              <a:rPr sz="1100" b="1" i="0">
+                <a:solidFill>
+                  <a:srgbClr val="2E75B6"/>
+                </a:solidFill>
+                <a:latin typeface="Calibri"/>
+              </a:rPr>
+              <a:t>▼</a:t>
+            </a:r>
+          </a:p>
+        </p:txBody>
+      </p:sp>
+      <p:sp>
+        <p:nvSpPr>
+          <p:cNvPr id="24" name="Rounded Rectangle 23"/>
           <p:cNvSpPr/>
           <p:nvPr/>
         </p:nvSpPr>
         <p:spPr>
           <a:xfrm>
-            <a:off x="1874519" y="3566160"/>
-            <a:ext cx="512064" cy="512064"/>
+            <a:off x="1874519" y="3493008"/>
+            <a:ext cx="9921240" cy="713232"/>
+          </a:xfrm>
+          <a:prstGeom prst="roundRect">
+            <a:avLst/>
+          </a:prstGeom>
+          <a:solidFill>
+            <a:srgbClr val="F3F6FA"/>
+          </a:solidFill>
+          <a:ln w="15875">
+            <a:solidFill>
+              <a:srgbClr val="A9BACE"/>
+            </a:solidFill>
+          </a:ln>
+          <a:effectLst/>
+        </p:spPr>
+        <p:style>
+          <a:lnRef idx="1">
+            <a:schemeClr val="accent1"/>
+          </a:lnRef>
+          <a:fillRef idx="3">
+            <a:schemeClr val="accent1"/>
+          </a:fillRef>
+          <a:effectRef idx="2">
+            <a:schemeClr val="accent1"/>
+          </a:effectRef>
+          <a:fontRef idx="minor">
+            <a:schemeClr val="lt1"/>
+          </a:fontRef>
+        </p:style>
+        <p:txBody>
+          <a:bodyPr rtlCol="0" anchor="ctr"/>
+          <a:lstStyle/>
+          <a:p>
+            <a:pPr algn="ctr"/>
+          </a:p>
+        </p:txBody>
+      </p:sp>
+      <p:sp>
+        <p:nvSpPr>
+          <p:cNvPr id="25" name="Oval 24"/>
+          <p:cNvSpPr/>
+          <p:nvPr/>
+        </p:nvSpPr>
+        <p:spPr>
+          <a:xfrm>
+            <a:off x="2148839" y="3621024"/>
+            <a:ext cx="457200" cy="457200"/>
           </a:xfrm>
           <a:prstGeom prst="ellipse">
             <a:avLst/>
@@ -6506,14 +6644,49 @@
       </p:sp>
       <p:sp>
         <p:nvSpPr>
-          <p:cNvPr id="23" name="TextBox 22"/>
-          <p:cNvSpPr txBox="1"/>
-          <p:nvPr/>
-        </p:nvSpPr>
-        <p:spPr>
-          <a:xfrm>
-            <a:off x="1874519" y="3621024"/>
-            <a:ext cx="512064" cy="411480"/>
+          <p:cNvPr id="26" name="TextBox 25"/>
+          <p:cNvSpPr txBox="1"/>
+          <p:nvPr/>
+        </p:nvSpPr>
+        <p:spPr>
+          <a:xfrm>
+            <a:off x="2148839" y="3621024"/>
+            <a:ext cx="457200" cy="457200"/>
+          </a:xfrm>
+          <a:prstGeom prst="rect">
+            <a:avLst/>
+          </a:prstGeom>
+          <a:noFill/>
+        </p:spPr>
+        <p:txBody>
+          <a:bodyPr wrap="square" anchor="ctr" lIns="0" rIns="0" tIns="0" bIns="0">
+            <a:spAutoFit/>
+          </a:bodyPr>
+          <a:lstStyle/>
+          <a:p>
+            <a:pPr algn="ctr"/>
+            <a:r>
+              <a:rPr sz="1800" b="1" i="0">
+                <a:solidFill>
+                  <a:srgbClr val="FFFFFF"/>
+                </a:solidFill>
+                <a:latin typeface="Cambria"/>
+              </a:rPr>
+              <a:t>3</a:t>
+            </a:r>
+          </a:p>
+        </p:txBody>
+      </p:sp>
+      <p:sp>
+        <p:nvSpPr>
+          <p:cNvPr id="27" name="TextBox 26"/>
+          <p:cNvSpPr txBox="1"/>
+          <p:nvPr/>
+        </p:nvSpPr>
+        <p:spPr>
+          <a:xfrm>
+            <a:off x="2880360" y="3602736"/>
+            <a:ext cx="5486400" cy="310896"/>
           </a:xfrm>
           <a:prstGeom prst="rect">
             <a:avLst/>
@@ -6526,29 +6699,29 @@
           </a:bodyPr>
           <a:lstStyle/>
           <a:p>
-            <a:pPr algn="ctr"/>
-            <a:r>
-              <a:rPr sz="1800" b="1" i="0">
-                <a:solidFill>
-                  <a:srgbClr val="FFFFFF"/>
+            <a:pPr algn="l"/>
+            <a:r>
+              <a:rPr sz="1500" b="1" i="0">
+                <a:solidFill>
+                  <a:srgbClr val="13294B"/>
                 </a:solidFill>
                 <a:latin typeface="Cambria"/>
               </a:rPr>
-              <a:t>3</a:t>
-            </a:r>
-          </a:p>
-        </p:txBody>
-      </p:sp>
-      <p:sp>
-        <p:nvSpPr>
-          <p:cNvPr id="24" name="TextBox 23"/>
-          <p:cNvSpPr txBox="1"/>
-          <p:nvPr/>
-        </p:nvSpPr>
-        <p:spPr>
-          <a:xfrm>
-            <a:off x="2651760" y="3502152"/>
-            <a:ext cx="5029200" cy="365760"/>
+              <a:t>Cache</a:t>
+            </a:r>
+          </a:p>
+        </p:txBody>
+      </p:sp>
+      <p:sp>
+        <p:nvSpPr>
+          <p:cNvPr id="28" name="TextBox 27"/>
+          <p:cNvSpPr txBox="1"/>
+          <p:nvPr/>
+        </p:nvSpPr>
+        <p:spPr>
+          <a:xfrm>
+            <a:off x="2880360" y="3895344"/>
+            <a:ext cx="8412480" cy="274320"/>
           </a:xfrm>
           <a:prstGeom prst="rect">
             <a:avLst/>
@@ -6563,27 +6736,27 @@
           <a:p>
             <a:pPr algn="l"/>
             <a:r>
-              <a:rPr sz="1700" b="1" i="0">
-                <a:solidFill>
-                  <a:srgbClr val="13294B"/>
-                </a:solidFill>
-                <a:latin typeface="Cambria"/>
-              </a:rPr>
-              <a:t>Cache</a:t>
-            </a:r>
-          </a:p>
-        </p:txBody>
-      </p:sp>
-      <p:sp>
-        <p:nvSpPr>
-          <p:cNvPr id="25" name="TextBox 24"/>
-          <p:cNvSpPr txBox="1"/>
-          <p:nvPr/>
-        </p:nvSpPr>
-        <p:spPr>
-          <a:xfrm>
-            <a:off x="2651760" y="3867912"/>
-            <a:ext cx="8595360" cy="320040"/>
+              <a:rPr sz="1150" b="0" i="0">
+                <a:solidFill>
+                  <a:srgbClr val="5C6B7A"/>
+                </a:solidFill>
+                <a:latin typeface="Calibri"/>
+              </a:rPr>
+              <a:t>Authorization-aware, freshness-bounded</a:t>
+            </a:r>
+          </a:p>
+        </p:txBody>
+      </p:sp>
+      <p:sp>
+        <p:nvSpPr>
+          <p:cNvPr id="29" name="TextBox 28"/>
+          <p:cNvSpPr txBox="1"/>
+          <p:nvPr/>
+        </p:nvSpPr>
+        <p:spPr>
+          <a:xfrm>
+            <a:off x="2240279" y="4187952"/>
+            <a:ext cx="274320" cy="201168"/>
           </a:xfrm>
           <a:prstGeom prst="rect">
             <a:avLst/>
@@ -6596,64 +6769,75 @@
           </a:bodyPr>
           <a:lstStyle/>
           <a:p>
-            <a:pPr algn="l"/>
-            <a:r>
-              <a:rPr sz="1200" b="0" i="0">
-                <a:solidFill>
-                  <a:srgbClr val="5C6B7A"/>
-                </a:solidFill>
-                <a:latin typeface="Calibri"/>
-              </a:rPr>
-              <a:t>Authorization-aware, freshness-bounded</a:t>
-            </a:r>
-          </a:p>
-        </p:txBody>
-      </p:sp>
-      <p:sp>
-        <p:nvSpPr>
-          <p:cNvPr id="26" name="TextBox 25"/>
-          <p:cNvSpPr txBox="1"/>
-          <p:nvPr/>
-        </p:nvSpPr>
-        <p:spPr>
-          <a:xfrm>
-            <a:off x="2651760" y="4169663"/>
-            <a:ext cx="7315200" cy="256032"/>
-          </a:xfrm>
-          <a:prstGeom prst="rect">
-            <a:avLst/>
-          </a:prstGeom>
-          <a:noFill/>
-        </p:spPr>
-        <p:txBody>
-          <a:bodyPr wrap="square" anchor="t" lIns="0" rIns="0" tIns="0" bIns="0">
-            <a:spAutoFit/>
-          </a:bodyPr>
-          <a:lstStyle/>
-          <a:p>
-            <a:pPr algn="l"/>
-            <a:r>
-              <a:rPr sz="900" b="0" i="0">
-                <a:solidFill>
-                  <a:srgbClr val="8FA6C4"/>
-                </a:solidFill>
-                <a:latin typeface="Calibri"/>
-              </a:rPr>
-              <a:t>▼  higher source wins on conflict — always</a:t>
-            </a:r>
-          </a:p>
-        </p:txBody>
-      </p:sp>
-      <p:sp>
-        <p:nvSpPr>
-          <p:cNvPr id="27" name="Oval 26"/>
+            <a:pPr algn="ctr"/>
+            <a:r>
+              <a:rPr sz="1100" b="1" i="0">
+                <a:solidFill>
+                  <a:srgbClr val="2E75B6"/>
+                </a:solidFill>
+                <a:latin typeface="Calibri"/>
+              </a:rPr>
+              <a:t>▼</a:t>
+            </a:r>
+          </a:p>
+        </p:txBody>
+      </p:sp>
+      <p:sp>
+        <p:nvSpPr>
+          <p:cNvPr id="30" name="Rounded Rectangle 29"/>
           <p:cNvSpPr/>
           <p:nvPr/>
         </p:nvSpPr>
         <p:spPr>
           <a:xfrm>
-            <a:off x="1874519" y="4443984"/>
-            <a:ext cx="512064" cy="512064"/>
+            <a:off x="1874519" y="4370831"/>
+            <a:ext cx="9921240" cy="713232"/>
+          </a:xfrm>
+          <a:prstGeom prst="roundRect">
+            <a:avLst/>
+          </a:prstGeom>
+          <a:solidFill>
+            <a:srgbClr val="F3F6FA"/>
+          </a:solidFill>
+          <a:ln w="15875">
+            <a:solidFill>
+              <a:srgbClr val="A9BACE"/>
+            </a:solidFill>
+          </a:ln>
+          <a:effectLst/>
+        </p:spPr>
+        <p:style>
+          <a:lnRef idx="1">
+            <a:schemeClr val="accent1"/>
+          </a:lnRef>
+          <a:fillRef idx="3">
+            <a:schemeClr val="accent1"/>
+          </a:fillRef>
+          <a:effectRef idx="2">
+            <a:schemeClr val="accent1"/>
+          </a:effectRef>
+          <a:fontRef idx="minor">
+            <a:schemeClr val="lt1"/>
+          </a:fontRef>
+        </p:style>
+        <p:txBody>
+          <a:bodyPr rtlCol="0" anchor="ctr"/>
+          <a:lstStyle/>
+          <a:p>
+            <a:pPr algn="ctr"/>
+          </a:p>
+        </p:txBody>
+      </p:sp>
+      <p:sp>
+        <p:nvSpPr>
+          <p:cNvPr id="31" name="Oval 30"/>
+          <p:cNvSpPr/>
+          <p:nvPr/>
+        </p:nvSpPr>
+        <p:spPr>
+          <a:xfrm>
+            <a:off x="2148839" y="4498847"/>
+            <a:ext cx="457200" cy="457200"/>
           </a:xfrm>
           <a:prstGeom prst="ellipse">
             <a:avLst/>
@@ -6690,14 +6874,49 @@
       </p:sp>
       <p:sp>
         <p:nvSpPr>
-          <p:cNvPr id="28" name="TextBox 27"/>
-          <p:cNvSpPr txBox="1"/>
-          <p:nvPr/>
-        </p:nvSpPr>
-        <p:spPr>
-          <a:xfrm>
-            <a:off x="1874519" y="4498848"/>
-            <a:ext cx="512064" cy="411480"/>
+          <p:cNvPr id="32" name="TextBox 31"/>
+          <p:cNvSpPr txBox="1"/>
+          <p:nvPr/>
+        </p:nvSpPr>
+        <p:spPr>
+          <a:xfrm>
+            <a:off x="2148839" y="4498847"/>
+            <a:ext cx="457200" cy="457200"/>
+          </a:xfrm>
+          <a:prstGeom prst="rect">
+            <a:avLst/>
+          </a:prstGeom>
+          <a:noFill/>
+        </p:spPr>
+        <p:txBody>
+          <a:bodyPr wrap="square" anchor="ctr" lIns="0" rIns="0" tIns="0" bIns="0">
+            <a:spAutoFit/>
+          </a:bodyPr>
+          <a:lstStyle/>
+          <a:p>
+            <a:pPr algn="ctr"/>
+            <a:r>
+              <a:rPr sz="1800" b="1" i="0">
+                <a:solidFill>
+                  <a:srgbClr val="FFFFFF"/>
+                </a:solidFill>
+                <a:latin typeface="Cambria"/>
+              </a:rPr>
+              <a:t>4</a:t>
+            </a:r>
+          </a:p>
+        </p:txBody>
+      </p:sp>
+      <p:sp>
+        <p:nvSpPr>
+          <p:cNvPr id="33" name="TextBox 32"/>
+          <p:cNvSpPr txBox="1"/>
+          <p:nvPr/>
+        </p:nvSpPr>
+        <p:spPr>
+          <a:xfrm>
+            <a:off x="2880360" y="4480559"/>
+            <a:ext cx="5486400" cy="310896"/>
           </a:xfrm>
           <a:prstGeom prst="rect">
             <a:avLst/>
@@ -6710,29 +6929,29 @@
           </a:bodyPr>
           <a:lstStyle/>
           <a:p>
-            <a:pPr algn="ctr"/>
-            <a:r>
-              <a:rPr sz="1800" b="1" i="0">
-                <a:solidFill>
-                  <a:srgbClr val="FFFFFF"/>
+            <a:pPr algn="l"/>
+            <a:r>
+              <a:rPr sz="1500" b="1" i="0">
+                <a:solidFill>
+                  <a:srgbClr val="13294B"/>
                 </a:solidFill>
                 <a:latin typeface="Cambria"/>
               </a:rPr>
-              <a:t>4</a:t>
-            </a:r>
-          </a:p>
-        </p:txBody>
-      </p:sp>
-      <p:sp>
-        <p:nvSpPr>
-          <p:cNvPr id="29" name="TextBox 28"/>
-          <p:cNvSpPr txBox="1"/>
-          <p:nvPr/>
-        </p:nvSpPr>
-        <p:spPr>
-          <a:xfrm>
-            <a:off x="2651760" y="4379976"/>
-            <a:ext cx="5029200" cy="365760"/>
+              <a:t>RAG</a:t>
+            </a:r>
+          </a:p>
+        </p:txBody>
+      </p:sp>
+      <p:sp>
+        <p:nvSpPr>
+          <p:cNvPr id="34" name="TextBox 33"/>
+          <p:cNvSpPr txBox="1"/>
+          <p:nvPr/>
+        </p:nvSpPr>
+        <p:spPr>
+          <a:xfrm>
+            <a:off x="2880360" y="4773168"/>
+            <a:ext cx="8412480" cy="274320"/>
           </a:xfrm>
           <a:prstGeom prst="rect">
             <a:avLst/>
@@ -6747,27 +6966,27 @@
           <a:p>
             <a:pPr algn="l"/>
             <a:r>
-              <a:rPr sz="1700" b="1" i="0">
-                <a:solidFill>
-                  <a:srgbClr val="13294B"/>
-                </a:solidFill>
-                <a:latin typeface="Cambria"/>
-              </a:rPr>
-              <a:t>RAG</a:t>
-            </a:r>
-          </a:p>
-        </p:txBody>
-      </p:sp>
-      <p:sp>
-        <p:nvSpPr>
-          <p:cNvPr id="30" name="TextBox 29"/>
-          <p:cNvSpPr txBox="1"/>
-          <p:nvPr/>
-        </p:nvSpPr>
-        <p:spPr>
-          <a:xfrm>
-            <a:off x="2651760" y="4745736"/>
-            <a:ext cx="8595360" cy="320040"/>
+              <a:rPr sz="1150" b="0" i="0">
+                <a:solidFill>
+                  <a:srgbClr val="5C6B7A"/>
+                </a:solidFill>
+                <a:latin typeface="Calibri"/>
+              </a:rPr>
+              <a:t>Retrieved knowledge — cited, ACL-enforced</a:t>
+            </a:r>
+          </a:p>
+        </p:txBody>
+      </p:sp>
+      <p:sp>
+        <p:nvSpPr>
+          <p:cNvPr id="35" name="TextBox 34"/>
+          <p:cNvSpPr txBox="1"/>
+          <p:nvPr/>
+        </p:nvSpPr>
+        <p:spPr>
+          <a:xfrm>
+            <a:off x="2240279" y="5065776"/>
+            <a:ext cx="274320" cy="201168"/>
           </a:xfrm>
           <a:prstGeom prst="rect">
             <a:avLst/>
@@ -6780,64 +6999,75 @@
           </a:bodyPr>
           <a:lstStyle/>
           <a:p>
-            <a:pPr algn="l"/>
-            <a:r>
-              <a:rPr sz="1200" b="0" i="0">
-                <a:solidFill>
-                  <a:srgbClr val="5C6B7A"/>
-                </a:solidFill>
-                <a:latin typeface="Calibri"/>
-              </a:rPr>
-              <a:t>Retrieved knowledge — cited, ACL-enforced</a:t>
-            </a:r>
-          </a:p>
-        </p:txBody>
-      </p:sp>
-      <p:sp>
-        <p:nvSpPr>
-          <p:cNvPr id="31" name="TextBox 30"/>
-          <p:cNvSpPr txBox="1"/>
-          <p:nvPr/>
-        </p:nvSpPr>
-        <p:spPr>
-          <a:xfrm>
-            <a:off x="2651760" y="5047488"/>
-            <a:ext cx="7315200" cy="256032"/>
-          </a:xfrm>
-          <a:prstGeom prst="rect">
-            <a:avLst/>
-          </a:prstGeom>
-          <a:noFill/>
-        </p:spPr>
-        <p:txBody>
-          <a:bodyPr wrap="square" anchor="t" lIns="0" rIns="0" tIns="0" bIns="0">
-            <a:spAutoFit/>
-          </a:bodyPr>
-          <a:lstStyle/>
-          <a:p>
-            <a:pPr algn="l"/>
-            <a:r>
-              <a:rPr sz="900" b="0" i="0">
-                <a:solidFill>
-                  <a:srgbClr val="8FA6C4"/>
-                </a:solidFill>
-                <a:latin typeface="Calibri"/>
-              </a:rPr>
-              <a:t>▼  higher source wins on conflict — always</a:t>
-            </a:r>
-          </a:p>
-        </p:txBody>
-      </p:sp>
-      <p:sp>
-        <p:nvSpPr>
-          <p:cNvPr id="32" name="Oval 31"/>
+            <a:pPr algn="ctr"/>
+            <a:r>
+              <a:rPr sz="1100" b="1" i="0">
+                <a:solidFill>
+                  <a:srgbClr val="2E75B6"/>
+                </a:solidFill>
+                <a:latin typeface="Calibri"/>
+              </a:rPr>
+              <a:t>▼</a:t>
+            </a:r>
+          </a:p>
+        </p:txBody>
+      </p:sp>
+      <p:sp>
+        <p:nvSpPr>
+          <p:cNvPr id="36" name="Rounded Rectangle 35"/>
           <p:cNvSpPr/>
           <p:nvPr/>
         </p:nvSpPr>
         <p:spPr>
           <a:xfrm>
-            <a:off x="1874519" y="5321808"/>
-            <a:ext cx="512064" cy="512064"/>
+            <a:off x="1874519" y="5248655"/>
+            <a:ext cx="9921240" cy="713232"/>
+          </a:xfrm>
+          <a:prstGeom prst="roundRect">
+            <a:avLst/>
+          </a:prstGeom>
+          <a:solidFill>
+            <a:srgbClr val="F3F6FA"/>
+          </a:solidFill>
+          <a:ln w="15875">
+            <a:solidFill>
+              <a:srgbClr val="A9BACE"/>
+            </a:solidFill>
+          </a:ln>
+          <a:effectLst/>
+        </p:spPr>
+        <p:style>
+          <a:lnRef idx="1">
+            <a:schemeClr val="accent1"/>
+          </a:lnRef>
+          <a:fillRef idx="3">
+            <a:schemeClr val="accent1"/>
+          </a:fillRef>
+          <a:effectRef idx="2">
+            <a:schemeClr val="accent1"/>
+          </a:effectRef>
+          <a:fontRef idx="minor">
+            <a:schemeClr val="lt1"/>
+          </a:fontRef>
+        </p:style>
+        <p:txBody>
+          <a:bodyPr rtlCol="0" anchor="ctr"/>
+          <a:lstStyle/>
+          <a:p>
+            <a:pPr algn="ctr"/>
+          </a:p>
+        </p:txBody>
+      </p:sp>
+      <p:sp>
+        <p:nvSpPr>
+          <p:cNvPr id="37" name="Oval 36"/>
+          <p:cNvSpPr/>
+          <p:nvPr/>
+        </p:nvSpPr>
+        <p:spPr>
+          <a:xfrm>
+            <a:off x="2148839" y="5376671"/>
+            <a:ext cx="457200" cy="457200"/>
           </a:xfrm>
           <a:prstGeom prst="ellipse">
             <a:avLst/>
@@ -6874,14 +7104,49 @@
       </p:sp>
       <p:sp>
         <p:nvSpPr>
-          <p:cNvPr id="33" name="TextBox 32"/>
-          <p:cNvSpPr txBox="1"/>
-          <p:nvPr/>
-        </p:nvSpPr>
-        <p:spPr>
-          <a:xfrm>
-            <a:off x="1874519" y="5376672"/>
-            <a:ext cx="512064" cy="411480"/>
+          <p:cNvPr id="38" name="TextBox 37"/>
+          <p:cNvSpPr txBox="1"/>
+          <p:nvPr/>
+        </p:nvSpPr>
+        <p:spPr>
+          <a:xfrm>
+            <a:off x="2148839" y="5376671"/>
+            <a:ext cx="457200" cy="457200"/>
+          </a:xfrm>
+          <a:prstGeom prst="rect">
+            <a:avLst/>
+          </a:prstGeom>
+          <a:noFill/>
+        </p:spPr>
+        <p:txBody>
+          <a:bodyPr wrap="square" anchor="ctr" lIns="0" rIns="0" tIns="0" bIns="0">
+            <a:spAutoFit/>
+          </a:bodyPr>
+          <a:lstStyle/>
+          <a:p>
+            <a:pPr algn="ctr"/>
+            <a:r>
+              <a:rPr sz="1800" b="1" i="0">
+                <a:solidFill>
+                  <a:srgbClr val="FFFFFF"/>
+                </a:solidFill>
+                <a:latin typeface="Cambria"/>
+              </a:rPr>
+              <a:t>5</a:t>
+            </a:r>
+          </a:p>
+        </p:txBody>
+      </p:sp>
+      <p:sp>
+        <p:nvSpPr>
+          <p:cNvPr id="39" name="TextBox 38"/>
+          <p:cNvSpPr txBox="1"/>
+          <p:nvPr/>
+        </p:nvSpPr>
+        <p:spPr>
+          <a:xfrm>
+            <a:off x="2880360" y="5358383"/>
+            <a:ext cx="5486400" cy="310896"/>
           </a:xfrm>
           <a:prstGeom prst="rect">
             <a:avLst/>
@@ -6894,29 +7159,29 @@
           </a:bodyPr>
           <a:lstStyle/>
           <a:p>
-            <a:pPr algn="ctr"/>
-            <a:r>
-              <a:rPr sz="1800" b="1" i="0">
-                <a:solidFill>
-                  <a:srgbClr val="FFFFFF"/>
+            <a:pPr algn="l"/>
+            <a:r>
+              <a:rPr sz="1500" b="1" i="0">
+                <a:solidFill>
+                  <a:srgbClr val="13294B"/>
                 </a:solidFill>
                 <a:latin typeface="Cambria"/>
               </a:rPr>
-              <a:t>5</a:t>
-            </a:r>
-          </a:p>
-        </p:txBody>
-      </p:sp>
-      <p:sp>
-        <p:nvSpPr>
-          <p:cNvPr id="34" name="TextBox 33"/>
-          <p:cNvSpPr txBox="1"/>
-          <p:nvPr/>
-        </p:nvSpPr>
-        <p:spPr>
-          <a:xfrm>
-            <a:off x="2651760" y="5257800"/>
-            <a:ext cx="5029200" cy="365760"/>
+              <a:t>SLM output</a:t>
+            </a:r>
+          </a:p>
+        </p:txBody>
+      </p:sp>
+      <p:sp>
+        <p:nvSpPr>
+          <p:cNvPr id="40" name="TextBox 39"/>
+          <p:cNvSpPr txBox="1"/>
+          <p:nvPr/>
+        </p:nvSpPr>
+        <p:spPr>
+          <a:xfrm>
+            <a:off x="2880360" y="5650992"/>
+            <a:ext cx="8412480" cy="274320"/>
           </a:xfrm>
           <a:prstGeom prst="rect">
             <a:avLst/>
@@ -6931,27 +7196,27 @@
           <a:p>
             <a:pPr algn="l"/>
             <a:r>
-              <a:rPr sz="1700" b="1" i="0">
-                <a:solidFill>
-                  <a:srgbClr val="13294B"/>
-                </a:solidFill>
-                <a:latin typeface="Cambria"/>
-              </a:rPr>
-              <a:t>SLM output</a:t>
-            </a:r>
-          </a:p>
-        </p:txBody>
-      </p:sp>
-      <p:sp>
-        <p:nvSpPr>
-          <p:cNvPr id="35" name="TextBox 34"/>
-          <p:cNvSpPr txBox="1"/>
-          <p:nvPr/>
-        </p:nvSpPr>
-        <p:spPr>
-          <a:xfrm>
-            <a:off x="2651760" y="5623560"/>
-            <a:ext cx="8595360" cy="320040"/>
+              <a:rPr sz="1150" b="0" i="0">
+                <a:solidFill>
+                  <a:srgbClr val="5C6B7A"/>
+                </a:solidFill>
+                <a:latin typeface="Calibri"/>
+              </a:rPr>
+              <a:t>Language only — never a source of authority</a:t>
+            </a:r>
+          </a:p>
+        </p:txBody>
+      </p:sp>
+      <p:sp>
+        <p:nvSpPr>
+          <p:cNvPr id="41" name="TextBox 40"/>
+          <p:cNvSpPr txBox="1"/>
+          <p:nvPr/>
+        </p:nvSpPr>
+        <p:spPr>
+          <a:xfrm>
+            <a:off x="1874519" y="6144767"/>
+            <a:ext cx="9921240" cy="274320"/>
           </a:xfrm>
           <a:prstGeom prst="rect">
             <a:avLst/>
@@ -6966,13 +7231,13 @@
           <a:p>
             <a:pPr algn="l"/>
             <a:r>
-              <a:rPr sz="1200" b="0" i="0">
-                <a:solidFill>
-                  <a:srgbClr val="5C6B7A"/>
-                </a:solidFill>
-                <a:latin typeface="Calibri"/>
-              </a:rPr>
-              <a:t>Language only — never a source of authority</a:t>
+              <a:rPr sz="1100" b="0" i="1">
+                <a:solidFill>
+                  <a:srgbClr val="8FA6C4"/>
+                </a:solidFill>
+                <a:latin typeface="Calibri"/>
+              </a:rPr>
+              <a:t>Higher source always wins on conflict — no exceptions.</a:t>
             </a:r>
           </a:p>
         </p:txBody>
@@ -7341,9 +7606,9 @@
           <a:solidFill>
             <a:srgbClr val="F3F6FA"/>
           </a:solidFill>
-          <a:ln w="12700">
+          <a:ln w="15875">
             <a:solidFill>
-              <a:srgbClr val="D9E1EA"/>
+              <a:srgbClr val="A9BACE"/>
             </a:solidFill>
           </a:ln>
           <a:effectLst/>
@@ -7457,9 +7722,9 @@
           <a:solidFill>
             <a:srgbClr val="F3F6FA"/>
           </a:solidFill>
-          <a:ln w="12700">
+          <a:ln w="15875">
             <a:solidFill>
-              <a:srgbClr val="D9E1EA"/>
+              <a:srgbClr val="A9BACE"/>
             </a:solidFill>
           </a:ln>
           <a:effectLst/>
@@ -7512,9 +7777,9 @@
           <a:solidFill>
             <a:srgbClr val="F3F6FA"/>
           </a:solidFill>
-          <a:ln w="12700">
+          <a:ln w="15875">
             <a:solidFill>
-              <a:srgbClr val="D9E1EA"/>
+              <a:srgbClr val="A9BACE"/>
             </a:solidFill>
           </a:ln>
           <a:effectLst/>
@@ -7616,9 +7881,9 @@
           <a:solidFill>
             <a:srgbClr val="F3F6FA"/>
           </a:solidFill>
-          <a:ln w="12700">
+          <a:ln w="15875">
             <a:solidFill>
-              <a:srgbClr val="D9E1EA"/>
+              <a:srgbClr val="A9BACE"/>
             </a:solidFill>
           </a:ln>
           <a:effectLst/>
@@ -7720,9 +7985,9 @@
           <a:solidFill>
             <a:srgbClr val="F3F6FA"/>
           </a:solidFill>
-          <a:ln w="12700">
+          <a:ln w="15875">
             <a:solidFill>
-              <a:srgbClr val="D9E1EA"/>
+              <a:srgbClr val="A9BACE"/>
             </a:solidFill>
           </a:ln>
           <a:effectLst/>
@@ -7963,9 +8228,9 @@
           <a:solidFill>
             <a:srgbClr val="F3F6FA"/>
           </a:solidFill>
-          <a:ln w="12700">
+          <a:ln w="15875">
             <a:solidFill>
-              <a:srgbClr val="D9E1EA"/>
+              <a:srgbClr val="A9BACE"/>
             </a:solidFill>
           </a:ln>
           <a:effectLst/>
@@ -8030,9 +8295,9 @@
           <a:solidFill>
             <a:srgbClr val="F3F6FA"/>
           </a:solidFill>
-          <a:ln w="12700">
+          <a:ln w="15875">
             <a:solidFill>
-              <a:srgbClr val="D9E1EA"/>
+              <a:srgbClr val="A9BACE"/>
             </a:solidFill>
           </a:ln>
           <a:effectLst/>
@@ -8097,9 +8362,9 @@
           <a:solidFill>
             <a:srgbClr val="F3F6FA"/>
           </a:solidFill>
-          <a:ln w="12700">
+          <a:ln w="15875">
             <a:solidFill>
-              <a:srgbClr val="D9E1EA"/>
+              <a:srgbClr val="A9BACE"/>
             </a:solidFill>
           </a:ln>
           <a:effectLst/>
@@ -8152,9 +8417,9 @@
           <a:solidFill>
             <a:srgbClr val="F3F6FA"/>
           </a:solidFill>
-          <a:ln w="12700">
+          <a:ln w="15875">
             <a:solidFill>
-              <a:srgbClr val="D9E1EA"/>
+              <a:srgbClr val="A9BACE"/>
             </a:solidFill>
           </a:ln>
           <a:effectLst/>
@@ -8219,9 +8484,9 @@
           <a:solidFill>
             <a:srgbClr val="F3F6FA"/>
           </a:solidFill>
-          <a:ln w="12700">
+          <a:ln w="15875">
             <a:solidFill>
-              <a:srgbClr val="D9E1EA"/>
+              <a:srgbClr val="A9BACE"/>
             </a:solidFill>
           </a:ln>
           <a:effectLst/>
@@ -8286,9 +8551,9 @@
           <a:solidFill>
             <a:srgbClr val="F3F6FA"/>
           </a:solidFill>
-          <a:ln w="12700">
+          <a:ln w="15875">
             <a:solidFill>
-              <a:srgbClr val="D9E1EA"/>
+              <a:srgbClr val="A9BACE"/>
             </a:solidFill>
           </a:ln>
           <a:effectLst/>
@@ -8443,9 +8708,9 @@
           <a:solidFill>
             <a:srgbClr val="F3F6FA"/>
           </a:solidFill>
-          <a:ln w="12700">
+          <a:ln w="15875">
             <a:solidFill>
-              <a:srgbClr val="D9E1EA"/>
+              <a:srgbClr val="A9BACE"/>
             </a:solidFill>
           </a:ln>
           <a:effectLst/>
@@ -9083,7 +9348,7 @@
         <p:spPr>
           <a:xfrm>
             <a:off x="1874519" y="1783080"/>
-            <a:ext cx="4846320" cy="1874519"/>
+            <a:ext cx="4800600" cy="1783080"/>
           </a:xfrm>
           <a:prstGeom prst="roundRect">
             <a:avLst/>
@@ -9091,9 +9356,9 @@
           <a:solidFill>
             <a:srgbClr val="F3F6FA"/>
           </a:solidFill>
-          <a:ln w="12700">
+          <a:ln w="15875">
             <a:solidFill>
-              <a:srgbClr val="D9E1EA"/>
+              <a:srgbClr val="A9BACE"/>
             </a:solidFill>
           </a:ln>
           <a:effectLst/>
@@ -9122,95 +9387,23 @@
       </p:sp>
       <p:sp>
         <p:nvSpPr>
-          <p:cNvPr id="13" name="TextBox 12"/>
-          <p:cNvSpPr txBox="1"/>
-          <p:nvPr/>
-        </p:nvSpPr>
-        <p:spPr>
-          <a:xfrm>
-            <a:off x="2148839" y="2039112"/>
-            <a:ext cx="4297680" cy="457200"/>
-          </a:xfrm>
-          <a:prstGeom prst="rect">
-            <a:avLst/>
-          </a:prstGeom>
-          <a:noFill/>
-        </p:spPr>
-        <p:txBody>
-          <a:bodyPr wrap="square" anchor="t" lIns="0" rIns="0" tIns="0" bIns="0">
-            <a:spAutoFit/>
-          </a:bodyPr>
-          <a:lstStyle/>
-          <a:p>
-            <a:pPr algn="l"/>
-            <a:r>
-              <a:rPr sz="1800" b="1" i="0">
-                <a:solidFill>
-                  <a:srgbClr val="13294B"/>
-                </a:solidFill>
-                <a:latin typeface="Cambria"/>
-              </a:rPr>
-              <a:t>Conversation State</a:t>
-            </a:r>
-          </a:p>
-        </p:txBody>
-      </p:sp>
-      <p:sp>
-        <p:nvSpPr>
-          <p:cNvPr id="14" name="TextBox 13"/>
-          <p:cNvSpPr txBox="1"/>
-          <p:nvPr/>
-        </p:nvSpPr>
-        <p:spPr>
-          <a:xfrm>
-            <a:off x="2148839" y="2697480"/>
-            <a:ext cx="4297680" cy="822960"/>
-          </a:xfrm>
-          <a:prstGeom prst="rect">
-            <a:avLst/>
-          </a:prstGeom>
-          <a:noFill/>
-        </p:spPr>
-        <p:txBody>
-          <a:bodyPr wrap="square" anchor="t" lIns="0" rIns="0" tIns="0" bIns="0">
-            <a:spAutoFit/>
-          </a:bodyPr>
-          <a:lstStyle/>
-          <a:p>
-            <a:pPr algn="l"/>
-            <a:r>
-              <a:rPr sz="1300" b="0" i="0">
-                <a:solidFill>
-                  <a:srgbClr val="5C6B7A"/>
-                </a:solidFill>
-                <a:latin typeface="Calibri"/>
-              </a:rPr>
-              <a:t>turns, messages, intent — per conversation</a:t>
-            </a:r>
-          </a:p>
-        </p:txBody>
-      </p:sp>
-      <p:sp>
-        <p:nvSpPr>
-          <p:cNvPr id="15" name="Rounded Rectangle 14"/>
+          <p:cNvPr id="13" name="Rectangle 12"/>
           <p:cNvSpPr/>
           <p:nvPr/>
         </p:nvSpPr>
         <p:spPr>
           <a:xfrm>
-            <a:off x="6720840" y="1783080"/>
-            <a:ext cx="4846320" cy="1874519"/>
-          </a:xfrm>
-          <a:prstGeom prst="roundRect">
+            <a:off x="1874519" y="2075688"/>
+            <a:ext cx="109728" cy="822960"/>
+          </a:xfrm>
+          <a:prstGeom prst="rect">
             <a:avLst/>
           </a:prstGeom>
           <a:solidFill>
-            <a:srgbClr val="F3F6FA"/>
+            <a:srgbClr val="13294B"/>
           </a:solidFill>
-          <a:ln w="12700">
-            <a:solidFill>
-              <a:srgbClr val="D9E1EA"/>
-            </a:solidFill>
+          <a:ln>
+            <a:noFill/>
           </a:ln>
           <a:effectLst/>
         </p:spPr>
@@ -9238,14 +9431,14 @@
       </p:sp>
       <p:sp>
         <p:nvSpPr>
-          <p:cNvPr id="16" name="TextBox 15"/>
-          <p:cNvSpPr txBox="1"/>
-          <p:nvPr/>
-        </p:nvSpPr>
-        <p:spPr>
-          <a:xfrm>
-            <a:off x="6995159" y="2039112"/>
-            <a:ext cx="4297680" cy="457200"/>
+          <p:cNvPr id="14" name="TextBox 13"/>
+          <p:cNvSpPr txBox="1"/>
+          <p:nvPr/>
+        </p:nvSpPr>
+        <p:spPr>
+          <a:xfrm>
+            <a:off x="2194560" y="2075688"/>
+            <a:ext cx="4251960" cy="457200"/>
           </a:xfrm>
           <a:prstGeom prst="rect">
             <a:avLst/>
@@ -9262,25 +9455,25 @@
             <a:r>
               <a:rPr sz="1800" b="1" i="0">
                 <a:solidFill>
-                  <a:srgbClr val="2E75B6"/>
+                  <a:srgbClr val="13294B"/>
                 </a:solidFill>
                 <a:latin typeface="Cambria"/>
               </a:rPr>
-              <a:t>Session State</a:t>
-            </a:r>
-          </a:p>
-        </p:txBody>
-      </p:sp>
-      <p:sp>
-        <p:nvSpPr>
-          <p:cNvPr id="17" name="TextBox 16"/>
-          <p:cNvSpPr txBox="1"/>
-          <p:nvPr/>
-        </p:nvSpPr>
-        <p:spPr>
-          <a:xfrm>
-            <a:off x="6995159" y="2697480"/>
-            <a:ext cx="4297680" cy="822960"/>
+              <a:t>Conversation State</a:t>
+            </a:r>
+          </a:p>
+        </p:txBody>
+      </p:sp>
+      <p:sp>
+        <p:nvSpPr>
+          <p:cNvPr id="15" name="TextBox 14"/>
+          <p:cNvSpPr txBox="1"/>
+          <p:nvPr/>
+        </p:nvSpPr>
+        <p:spPr>
+          <a:xfrm>
+            <a:off x="2194560" y="2715768"/>
+            <a:ext cx="4251960" cy="731520"/>
           </a:xfrm>
           <a:prstGeom prst="rect">
             <a:avLst/>
@@ -9301,21 +9494,21 @@
                 </a:solidFill>
                 <a:latin typeface="Calibri"/>
               </a:rPr>
-              <a:t>auth context, correlation, ttl — per session</a:t>
-            </a:r>
-          </a:p>
-        </p:txBody>
-      </p:sp>
-      <p:sp>
-        <p:nvSpPr>
-          <p:cNvPr id="18" name="Rounded Rectangle 17"/>
+              <a:t>turns, messages, intent — per conversation</a:t>
+            </a:r>
+          </a:p>
+        </p:txBody>
+      </p:sp>
+      <p:sp>
+        <p:nvSpPr>
+          <p:cNvPr id="16" name="Rounded Rectangle 15"/>
           <p:cNvSpPr/>
           <p:nvPr/>
         </p:nvSpPr>
         <p:spPr>
           <a:xfrm>
-            <a:off x="1874519" y="3840480"/>
-            <a:ext cx="4846320" cy="1874519"/>
+            <a:off x="6766560" y="1783080"/>
+            <a:ext cx="4800600" cy="1783080"/>
           </a:xfrm>
           <a:prstGeom prst="roundRect">
             <a:avLst/>
@@ -9323,9 +9516,9 @@
           <a:solidFill>
             <a:srgbClr val="F3F6FA"/>
           </a:solidFill>
-          <a:ln w="12700">
+          <a:ln w="15875">
             <a:solidFill>
-              <a:srgbClr val="D9E1EA"/>
+              <a:srgbClr val="A9BACE"/>
             </a:solidFill>
           </a:ln>
           <a:effectLst/>
@@ -9354,95 +9547,23 @@
       </p:sp>
       <p:sp>
         <p:nvSpPr>
-          <p:cNvPr id="19" name="TextBox 18"/>
-          <p:cNvSpPr txBox="1"/>
-          <p:nvPr/>
-        </p:nvSpPr>
-        <p:spPr>
-          <a:xfrm>
-            <a:off x="2148839" y="4096512"/>
-            <a:ext cx="4297680" cy="457200"/>
-          </a:xfrm>
-          <a:prstGeom prst="rect">
-            <a:avLst/>
-          </a:prstGeom>
-          <a:noFill/>
-        </p:spPr>
-        <p:txBody>
-          <a:bodyPr wrap="square" anchor="t" lIns="0" rIns="0" tIns="0" bIns="0">
-            <a:spAutoFit/>
-          </a:bodyPr>
-          <a:lstStyle/>
-          <a:p>
-            <a:pPr algn="l"/>
-            <a:r>
-              <a:rPr sz="1800" b="1" i="0">
-                <a:solidFill>
-                  <a:srgbClr val="13294B"/>
-                </a:solidFill>
-                <a:latin typeface="Cambria"/>
-              </a:rPr>
-              <a:t>Workflow / Agent State</a:t>
-            </a:r>
-          </a:p>
-        </p:txBody>
-      </p:sp>
-      <p:sp>
-        <p:nvSpPr>
-          <p:cNvPr id="20" name="TextBox 19"/>
-          <p:cNvSpPr txBox="1"/>
-          <p:nvPr/>
-        </p:nvSpPr>
-        <p:spPr>
-          <a:xfrm>
-            <a:off x="2148839" y="4754880"/>
-            <a:ext cx="4297680" cy="822960"/>
-          </a:xfrm>
-          <a:prstGeom prst="rect">
-            <a:avLst/>
-          </a:prstGeom>
-          <a:noFill/>
-        </p:spPr>
-        <p:txBody>
-          <a:bodyPr wrap="square" anchor="t" lIns="0" rIns="0" tIns="0" bIns="0">
-            <a:spAutoFit/>
-          </a:bodyPr>
-          <a:lstStyle/>
-          <a:p>
-            <a:pPr algn="l"/>
-            <a:r>
-              <a:rPr sz="1300" b="0" i="0">
-                <a:solidFill>
-                  <a:srgbClr val="5C6B7A"/>
-                </a:solidFill>
-                <a:latin typeface="Calibri"/>
-              </a:rPr>
-              <a:t>graph state, steps, HIL — per workflow run</a:t>
-            </a:r>
-          </a:p>
-        </p:txBody>
-      </p:sp>
-      <p:sp>
-        <p:nvSpPr>
-          <p:cNvPr id="21" name="Rounded Rectangle 20"/>
+          <p:cNvPr id="17" name="Rectangle 16"/>
           <p:cNvSpPr/>
           <p:nvPr/>
         </p:nvSpPr>
         <p:spPr>
           <a:xfrm>
-            <a:off x="6720840" y="3840480"/>
-            <a:ext cx="4846320" cy="1874519"/>
-          </a:xfrm>
-          <a:prstGeom prst="roundRect">
+            <a:off x="6766560" y="2075688"/>
+            <a:ext cx="109728" cy="822960"/>
+          </a:xfrm>
+          <a:prstGeom prst="rect">
             <a:avLst/>
           </a:prstGeom>
           <a:solidFill>
-            <a:srgbClr val="F3F6FA"/>
+            <a:srgbClr val="2E75B6"/>
           </a:solidFill>
-          <a:ln w="12700">
-            <a:solidFill>
-              <a:srgbClr val="D9E1EA"/>
-            </a:solidFill>
+          <a:ln>
+            <a:noFill/>
           </a:ln>
           <a:effectLst/>
         </p:spPr>
@@ -9470,14 +9591,174 @@
       </p:sp>
       <p:sp>
         <p:nvSpPr>
+          <p:cNvPr id="18" name="TextBox 17"/>
+          <p:cNvSpPr txBox="1"/>
+          <p:nvPr/>
+        </p:nvSpPr>
+        <p:spPr>
+          <a:xfrm>
+            <a:off x="7086600" y="2075688"/>
+            <a:ext cx="4251960" cy="457200"/>
+          </a:xfrm>
+          <a:prstGeom prst="rect">
+            <a:avLst/>
+          </a:prstGeom>
+          <a:noFill/>
+        </p:spPr>
+        <p:txBody>
+          <a:bodyPr wrap="square" anchor="t" lIns="0" rIns="0" tIns="0" bIns="0">
+            <a:spAutoFit/>
+          </a:bodyPr>
+          <a:lstStyle/>
+          <a:p>
+            <a:pPr algn="l"/>
+            <a:r>
+              <a:rPr sz="1800" b="1" i="0">
+                <a:solidFill>
+                  <a:srgbClr val="2E75B6"/>
+                </a:solidFill>
+                <a:latin typeface="Cambria"/>
+              </a:rPr>
+              <a:t>Session State</a:t>
+            </a:r>
+          </a:p>
+        </p:txBody>
+      </p:sp>
+      <p:sp>
+        <p:nvSpPr>
+          <p:cNvPr id="19" name="TextBox 18"/>
+          <p:cNvSpPr txBox="1"/>
+          <p:nvPr/>
+        </p:nvSpPr>
+        <p:spPr>
+          <a:xfrm>
+            <a:off x="7086600" y="2715768"/>
+            <a:ext cx="4251960" cy="731520"/>
+          </a:xfrm>
+          <a:prstGeom prst="rect">
+            <a:avLst/>
+          </a:prstGeom>
+          <a:noFill/>
+        </p:spPr>
+        <p:txBody>
+          <a:bodyPr wrap="square" anchor="t" lIns="0" rIns="0" tIns="0" bIns="0">
+            <a:spAutoFit/>
+          </a:bodyPr>
+          <a:lstStyle/>
+          <a:p>
+            <a:pPr algn="l"/>
+            <a:r>
+              <a:rPr sz="1300" b="0" i="0">
+                <a:solidFill>
+                  <a:srgbClr val="5C6B7A"/>
+                </a:solidFill>
+                <a:latin typeface="Calibri"/>
+              </a:rPr>
+              <a:t>auth context, correlation, ttl — per session</a:t>
+            </a:r>
+          </a:p>
+        </p:txBody>
+      </p:sp>
+      <p:sp>
+        <p:nvSpPr>
+          <p:cNvPr id="20" name="Rounded Rectangle 19"/>
+          <p:cNvSpPr/>
+          <p:nvPr/>
+        </p:nvSpPr>
+        <p:spPr>
+          <a:xfrm>
+            <a:off x="1874519" y="3886200"/>
+            <a:ext cx="4800600" cy="1783080"/>
+          </a:xfrm>
+          <a:prstGeom prst="roundRect">
+            <a:avLst/>
+          </a:prstGeom>
+          <a:solidFill>
+            <a:srgbClr val="F3F6FA"/>
+          </a:solidFill>
+          <a:ln w="15875">
+            <a:solidFill>
+              <a:srgbClr val="A9BACE"/>
+            </a:solidFill>
+          </a:ln>
+          <a:effectLst/>
+        </p:spPr>
+        <p:style>
+          <a:lnRef idx="1">
+            <a:schemeClr val="accent1"/>
+          </a:lnRef>
+          <a:fillRef idx="3">
+            <a:schemeClr val="accent1"/>
+          </a:fillRef>
+          <a:effectRef idx="2">
+            <a:schemeClr val="accent1"/>
+          </a:effectRef>
+          <a:fontRef idx="minor">
+            <a:schemeClr val="lt1"/>
+          </a:fontRef>
+        </p:style>
+        <p:txBody>
+          <a:bodyPr rtlCol="0" anchor="ctr"/>
+          <a:lstStyle/>
+          <a:p>
+            <a:pPr algn="ctr"/>
+          </a:p>
+        </p:txBody>
+      </p:sp>
+      <p:sp>
+        <p:nvSpPr>
+          <p:cNvPr id="21" name="Rectangle 20"/>
+          <p:cNvSpPr/>
+          <p:nvPr/>
+        </p:nvSpPr>
+        <p:spPr>
+          <a:xfrm>
+            <a:off x="1874519" y="4178808"/>
+            <a:ext cx="109728" cy="822960"/>
+          </a:xfrm>
+          <a:prstGeom prst="rect">
+            <a:avLst/>
+          </a:prstGeom>
+          <a:solidFill>
+            <a:srgbClr val="13294B"/>
+          </a:solidFill>
+          <a:ln>
+            <a:noFill/>
+          </a:ln>
+          <a:effectLst/>
+        </p:spPr>
+        <p:style>
+          <a:lnRef idx="1">
+            <a:schemeClr val="accent1"/>
+          </a:lnRef>
+          <a:fillRef idx="3">
+            <a:schemeClr val="accent1"/>
+          </a:fillRef>
+          <a:effectRef idx="2">
+            <a:schemeClr val="accent1"/>
+          </a:effectRef>
+          <a:fontRef idx="minor">
+            <a:schemeClr val="lt1"/>
+          </a:fontRef>
+        </p:style>
+        <p:txBody>
+          <a:bodyPr rtlCol="0" anchor="ctr"/>
+          <a:lstStyle/>
+          <a:p>
+            <a:pPr algn="ctr"/>
+          </a:p>
+        </p:txBody>
+      </p:sp>
+      <p:sp>
+        <p:nvSpPr>
           <p:cNvPr id="22" name="TextBox 21"/>
           <p:cNvSpPr txBox="1"/>
           <p:nvPr/>
         </p:nvSpPr>
         <p:spPr>
           <a:xfrm>
-            <a:off x="6995159" y="4096512"/>
-            <a:ext cx="4297680" cy="457200"/>
+            <a:off x="2194560" y="4178808"/>
+            <a:ext cx="4251960" cy="457200"/>
           </a:xfrm>
           <a:prstGeom prst="rect">
             <a:avLst/>
@@ -9494,6 +9775,166 @@
             <a:r>
               <a:rPr sz="1800" b="1" i="0">
                 <a:solidFill>
+                  <a:srgbClr val="13294B"/>
+                </a:solidFill>
+                <a:latin typeface="Cambria"/>
+              </a:rPr>
+              <a:t>Workflow / Agent State</a:t>
+            </a:r>
+          </a:p>
+        </p:txBody>
+      </p:sp>
+      <p:sp>
+        <p:nvSpPr>
+          <p:cNvPr id="23" name="TextBox 22"/>
+          <p:cNvSpPr txBox="1"/>
+          <p:nvPr/>
+        </p:nvSpPr>
+        <p:spPr>
+          <a:xfrm>
+            <a:off x="2194560" y="4818888"/>
+            <a:ext cx="4251960" cy="731520"/>
+          </a:xfrm>
+          <a:prstGeom prst="rect">
+            <a:avLst/>
+          </a:prstGeom>
+          <a:noFill/>
+        </p:spPr>
+        <p:txBody>
+          <a:bodyPr wrap="square" anchor="t" lIns="0" rIns="0" tIns="0" bIns="0">
+            <a:spAutoFit/>
+          </a:bodyPr>
+          <a:lstStyle/>
+          <a:p>
+            <a:pPr algn="l"/>
+            <a:r>
+              <a:rPr sz="1300" b="0" i="0">
+                <a:solidFill>
+                  <a:srgbClr val="5C6B7A"/>
+                </a:solidFill>
+                <a:latin typeface="Calibri"/>
+              </a:rPr>
+              <a:t>graph state, steps, HIL — per workflow run</a:t>
+            </a:r>
+          </a:p>
+        </p:txBody>
+      </p:sp>
+      <p:sp>
+        <p:nvSpPr>
+          <p:cNvPr id="24" name="Rounded Rectangle 23"/>
+          <p:cNvSpPr/>
+          <p:nvPr/>
+        </p:nvSpPr>
+        <p:spPr>
+          <a:xfrm>
+            <a:off x="6766560" y="3886200"/>
+            <a:ext cx="4800600" cy="1783080"/>
+          </a:xfrm>
+          <a:prstGeom prst="roundRect">
+            <a:avLst/>
+          </a:prstGeom>
+          <a:solidFill>
+            <a:srgbClr val="F3F6FA"/>
+          </a:solidFill>
+          <a:ln w="15875">
+            <a:solidFill>
+              <a:srgbClr val="A9BACE"/>
+            </a:solidFill>
+          </a:ln>
+          <a:effectLst/>
+        </p:spPr>
+        <p:style>
+          <a:lnRef idx="1">
+            <a:schemeClr val="accent1"/>
+          </a:lnRef>
+          <a:fillRef idx="3">
+            <a:schemeClr val="accent1"/>
+          </a:fillRef>
+          <a:effectRef idx="2">
+            <a:schemeClr val="accent1"/>
+          </a:effectRef>
+          <a:fontRef idx="minor">
+            <a:schemeClr val="lt1"/>
+          </a:fontRef>
+        </p:style>
+        <p:txBody>
+          <a:bodyPr rtlCol="0" anchor="ctr"/>
+          <a:lstStyle/>
+          <a:p>
+            <a:pPr algn="ctr"/>
+          </a:p>
+        </p:txBody>
+      </p:sp>
+      <p:sp>
+        <p:nvSpPr>
+          <p:cNvPr id="25" name="Rectangle 24"/>
+          <p:cNvSpPr/>
+          <p:nvPr/>
+        </p:nvSpPr>
+        <p:spPr>
+          <a:xfrm>
+            <a:off x="6766560" y="4178808"/>
+            <a:ext cx="109728" cy="822960"/>
+          </a:xfrm>
+          <a:prstGeom prst="rect">
+            <a:avLst/>
+          </a:prstGeom>
+          <a:solidFill>
+            <a:srgbClr val="2E75B6"/>
+          </a:solidFill>
+          <a:ln>
+            <a:noFill/>
+          </a:ln>
+          <a:effectLst/>
+        </p:spPr>
+        <p:style>
+          <a:lnRef idx="1">
+            <a:schemeClr val="accent1"/>
+          </a:lnRef>
+          <a:fillRef idx="3">
+            <a:schemeClr val="accent1"/>
+          </a:fillRef>
+          <a:effectRef idx="2">
+            <a:schemeClr val="accent1"/>
+          </a:effectRef>
+          <a:fontRef idx="minor">
+            <a:schemeClr val="lt1"/>
+          </a:fontRef>
+        </p:style>
+        <p:txBody>
+          <a:bodyPr rtlCol="0" anchor="ctr"/>
+          <a:lstStyle/>
+          <a:p>
+            <a:pPr algn="ctr"/>
+          </a:p>
+        </p:txBody>
+      </p:sp>
+      <p:sp>
+        <p:nvSpPr>
+          <p:cNvPr id="26" name="TextBox 25"/>
+          <p:cNvSpPr txBox="1"/>
+          <p:nvPr/>
+        </p:nvSpPr>
+        <p:spPr>
+          <a:xfrm>
+            <a:off x="7086600" y="4178808"/>
+            <a:ext cx="4251960" cy="457200"/>
+          </a:xfrm>
+          <a:prstGeom prst="rect">
+            <a:avLst/>
+          </a:prstGeom>
+          <a:noFill/>
+        </p:spPr>
+        <p:txBody>
+          <a:bodyPr wrap="square" anchor="t" lIns="0" rIns="0" tIns="0" bIns="0">
+            <a:spAutoFit/>
+          </a:bodyPr>
+          <a:lstStyle/>
+          <a:p>
+            <a:pPr algn="l"/>
+            <a:r>
+              <a:rPr sz="1800" b="1" i="0">
+                <a:solidFill>
                   <a:srgbClr val="2E75B6"/>
                 </a:solidFill>
                 <a:latin typeface="Cambria"/>
@@ -9505,14 +9946,14 @@
       </p:sp>
       <p:sp>
         <p:nvSpPr>
-          <p:cNvPr id="23" name="TextBox 22"/>
-          <p:cNvSpPr txBox="1"/>
-          <p:nvPr/>
-        </p:nvSpPr>
-        <p:spPr>
-          <a:xfrm>
-            <a:off x="6995159" y="4754880"/>
-            <a:ext cx="4297680" cy="822960"/>
+          <p:cNvPr id="27" name="TextBox 26"/>
+          <p:cNvSpPr txBox="1"/>
+          <p:nvPr/>
+        </p:nvSpPr>
+        <p:spPr>
+          <a:xfrm>
+            <a:off x="7086600" y="4818888"/>
+            <a:ext cx="4251960" cy="731520"/>
           </a:xfrm>
           <a:prstGeom prst="rect">
             <a:avLst/>

</xml_diff>